<commit_message>
fix: review Grade 8 Monkey Festival lesson and use Hebrew dates
</commit_message>
<xml_diff>
--- a/grade8/monkey-festival/files/monkey-festival.pptx
+++ b/grade8/monkey-festival/files/monkey-festival.pptx
@@ -2,82 +2,82 @@
 <file path=ppt/presentation.xml><?xml version="1.0" encoding="utf-8"?>
 <p:presentation xmlns:p="http://schemas.openxmlformats.org/presentationml/2006/main">
   <p:sldMasterIdLst>
-    <p:sldMasterId xmlns:r="http://schemas.openxmlformats.org/officeDocument/2006/relationships" id="2147483648" r:id="R7c18b431fe0c4d2a"/>
+    <p:sldMasterId xmlns:r="http://schemas.openxmlformats.org/officeDocument/2006/relationships" id="2147483648" r:id="R0a014e9d786c45de"/>
   </p:sldMasterIdLst>
   <p:notesMasterIdLst>
-    <p:notesMasterId xmlns:r="http://schemas.openxmlformats.org/officeDocument/2006/relationships" r:id="Rd0c5e021a3374123"/>
+    <p:notesMasterId xmlns:r="http://schemas.openxmlformats.org/officeDocument/2006/relationships" r:id="Re036793dee6548c8"/>
   </p:notesMasterIdLst>
   <p:sldIdLst>
-    <p:sldId xmlns:r="http://schemas.openxmlformats.org/officeDocument/2006/relationships" id="256" r:id="R22be6ef05b514417"/>
-    <p:sldId xmlns:r="http://schemas.openxmlformats.org/officeDocument/2006/relationships" id="257" r:id="Rd02a9bdff0234ad0"/>
-    <p:sldId xmlns:r="http://schemas.openxmlformats.org/officeDocument/2006/relationships" id="258" r:id="R48327b7f813942d6"/>
-    <p:sldId xmlns:r="http://schemas.openxmlformats.org/officeDocument/2006/relationships" id="259" r:id="R44d3db827c904930"/>
-    <p:sldId xmlns:r="http://schemas.openxmlformats.org/officeDocument/2006/relationships" id="260" r:id="R9a7862b5b06e4d24"/>
-    <p:sldId xmlns:r="http://schemas.openxmlformats.org/officeDocument/2006/relationships" id="261" r:id="R887055bb95c542f4"/>
-    <p:sldId xmlns:r="http://schemas.openxmlformats.org/officeDocument/2006/relationships" id="262" r:id="Rfa6c5c77763b4caa"/>
-    <p:sldId xmlns:r="http://schemas.openxmlformats.org/officeDocument/2006/relationships" id="263" r:id="R6fea5c2f98b94ad2"/>
-    <p:sldId xmlns:r="http://schemas.openxmlformats.org/officeDocument/2006/relationships" id="264" r:id="R3a8e07ff9f444e0b"/>
-    <p:sldId xmlns:r="http://schemas.openxmlformats.org/officeDocument/2006/relationships" id="265" r:id="Rfda41bb63bb44a97"/>
-    <p:sldId xmlns:r="http://schemas.openxmlformats.org/officeDocument/2006/relationships" id="266" r:id="Rfca6479c08df4b2b"/>
-    <p:sldId xmlns:r="http://schemas.openxmlformats.org/officeDocument/2006/relationships" id="267" r:id="R005db1b8fdfe4934"/>
-    <p:sldId xmlns:r="http://schemas.openxmlformats.org/officeDocument/2006/relationships" id="268" r:id="R782affb9d24444d0"/>
-    <p:sldId xmlns:r="http://schemas.openxmlformats.org/officeDocument/2006/relationships" id="269" r:id="R626bc76cfc7c419e"/>
-    <p:sldId xmlns:r="http://schemas.openxmlformats.org/officeDocument/2006/relationships" id="270" r:id="R946590dc982d4ba8"/>
-    <p:sldId xmlns:r="http://schemas.openxmlformats.org/officeDocument/2006/relationships" id="271" r:id="R5956eeaccecc42eb"/>
-    <p:sldId xmlns:r="http://schemas.openxmlformats.org/officeDocument/2006/relationships" id="272" r:id="R8fd637c35d8f422a"/>
-    <p:sldId xmlns:r="http://schemas.openxmlformats.org/officeDocument/2006/relationships" id="273" r:id="Rac3e9f83d37c420f"/>
-    <p:sldId xmlns:r="http://schemas.openxmlformats.org/officeDocument/2006/relationships" id="274" r:id="R9adaf3f7bccd4289"/>
-    <p:sldId xmlns:r="http://schemas.openxmlformats.org/officeDocument/2006/relationships" id="275" r:id="R23315af2acd8493c"/>
-    <p:sldId xmlns:r="http://schemas.openxmlformats.org/officeDocument/2006/relationships" id="276" r:id="R1fb02562253449fe"/>
-    <p:sldId xmlns:r="http://schemas.openxmlformats.org/officeDocument/2006/relationships" id="277" r:id="R879c3501245445b4"/>
-    <p:sldId xmlns:r="http://schemas.openxmlformats.org/officeDocument/2006/relationships" id="278" r:id="R7651a5bb621d4638"/>
-    <p:sldId xmlns:r="http://schemas.openxmlformats.org/officeDocument/2006/relationships" id="279" r:id="R05e3d5ac603048ab"/>
-    <p:sldId xmlns:r="http://schemas.openxmlformats.org/officeDocument/2006/relationships" id="280" r:id="R8e50c55a3c2d4686"/>
-    <p:sldId xmlns:r="http://schemas.openxmlformats.org/officeDocument/2006/relationships" id="281" r:id="R6be7d123b30742e0"/>
-    <p:sldId xmlns:r="http://schemas.openxmlformats.org/officeDocument/2006/relationships" id="282" r:id="Rda475ddd667d4046"/>
-    <p:sldId xmlns:r="http://schemas.openxmlformats.org/officeDocument/2006/relationships" id="283" r:id="R4ac44395c6374311"/>
-    <p:sldId xmlns:r="http://schemas.openxmlformats.org/officeDocument/2006/relationships" id="284" r:id="R93355dd6873e4208"/>
-    <p:sldId xmlns:r="http://schemas.openxmlformats.org/officeDocument/2006/relationships" id="285" r:id="Rf6924f091d8042a5"/>
-    <p:sldId xmlns:r="http://schemas.openxmlformats.org/officeDocument/2006/relationships" id="286" r:id="R4b127cf317c24396"/>
-    <p:sldId xmlns:r="http://schemas.openxmlformats.org/officeDocument/2006/relationships" id="287" r:id="R5760f945163a42ae"/>
-    <p:sldId xmlns:r="http://schemas.openxmlformats.org/officeDocument/2006/relationships" id="288" r:id="R3981a55f007e44c4"/>
-    <p:sldId xmlns:r="http://schemas.openxmlformats.org/officeDocument/2006/relationships" id="289" r:id="R6979533a02e04098"/>
-    <p:sldId xmlns:r="http://schemas.openxmlformats.org/officeDocument/2006/relationships" id="290" r:id="R5e31c1a8460a490b"/>
-    <p:sldId xmlns:r="http://schemas.openxmlformats.org/officeDocument/2006/relationships" id="291" r:id="R17788742207544e7"/>
-    <p:sldId xmlns:r="http://schemas.openxmlformats.org/officeDocument/2006/relationships" id="292" r:id="Rcaa4219f2a85448e"/>
-    <p:sldId xmlns:r="http://schemas.openxmlformats.org/officeDocument/2006/relationships" id="293" r:id="R0bae463872084a62"/>
-    <p:sldId xmlns:r="http://schemas.openxmlformats.org/officeDocument/2006/relationships" id="294" r:id="Rdb9db8cfb720477b"/>
-    <p:sldId xmlns:r="http://schemas.openxmlformats.org/officeDocument/2006/relationships" id="295" r:id="R18ca21dba5d4415e"/>
-    <p:sldId xmlns:r="http://schemas.openxmlformats.org/officeDocument/2006/relationships" id="296" r:id="Rb3ad5b48ec2e4e4e"/>
-    <p:sldId xmlns:r="http://schemas.openxmlformats.org/officeDocument/2006/relationships" id="297" r:id="R2198b084af9c4e1d"/>
-    <p:sldId xmlns:r="http://schemas.openxmlformats.org/officeDocument/2006/relationships" id="298" r:id="R64f6915d173b4d48"/>
-    <p:sldId xmlns:r="http://schemas.openxmlformats.org/officeDocument/2006/relationships" id="299" r:id="R94549c8bdfd34ca0"/>
-    <p:sldId xmlns:r="http://schemas.openxmlformats.org/officeDocument/2006/relationships" id="300" r:id="Rd0dc7048729e4302"/>
-    <p:sldId xmlns:r="http://schemas.openxmlformats.org/officeDocument/2006/relationships" id="301" r:id="R1aa294dea29e492c"/>
-    <p:sldId xmlns:r="http://schemas.openxmlformats.org/officeDocument/2006/relationships" id="302" r:id="R71035958f9a64c89"/>
-    <p:sldId xmlns:r="http://schemas.openxmlformats.org/officeDocument/2006/relationships" id="303" r:id="R18c8deee250c44eb"/>
-    <p:sldId xmlns:r="http://schemas.openxmlformats.org/officeDocument/2006/relationships" id="304" r:id="R954a795631cf4c8f"/>
-    <p:sldId xmlns:r="http://schemas.openxmlformats.org/officeDocument/2006/relationships" id="305" r:id="R3e34eb500ae544e5"/>
-    <p:sldId xmlns:r="http://schemas.openxmlformats.org/officeDocument/2006/relationships" id="306" r:id="Reb62a772e81246cc"/>
-    <p:sldId xmlns:r="http://schemas.openxmlformats.org/officeDocument/2006/relationships" id="307" r:id="R1d246e15cd8d44a9"/>
-    <p:sldId xmlns:r="http://schemas.openxmlformats.org/officeDocument/2006/relationships" id="308" r:id="R45146471dc1f4a24"/>
-    <p:sldId xmlns:r="http://schemas.openxmlformats.org/officeDocument/2006/relationships" id="309" r:id="Rf146c31e1fb9424e"/>
-    <p:sldId xmlns:r="http://schemas.openxmlformats.org/officeDocument/2006/relationships" id="310" r:id="Rc2a9ce2c4a194885"/>
-    <p:sldId xmlns:r="http://schemas.openxmlformats.org/officeDocument/2006/relationships" id="311" r:id="R501ae8eeb06e4d0a"/>
-    <p:sldId xmlns:r="http://schemas.openxmlformats.org/officeDocument/2006/relationships" id="312" r:id="R5b48390d8a0f4104"/>
-    <p:sldId xmlns:r="http://schemas.openxmlformats.org/officeDocument/2006/relationships" id="313" r:id="R8d23e81050cf4400"/>
-    <p:sldId xmlns:r="http://schemas.openxmlformats.org/officeDocument/2006/relationships" id="314" r:id="R3bad07c5cfc046ea"/>
-    <p:sldId xmlns:r="http://schemas.openxmlformats.org/officeDocument/2006/relationships" id="315" r:id="R077ba518e4c14c62"/>
-    <p:sldId xmlns:r="http://schemas.openxmlformats.org/officeDocument/2006/relationships" id="316" r:id="R7e21a870d0d54827"/>
-    <p:sldId xmlns:r="http://schemas.openxmlformats.org/officeDocument/2006/relationships" id="317" r:id="Rb61f047d91174369"/>
-    <p:sldId xmlns:r="http://schemas.openxmlformats.org/officeDocument/2006/relationships" id="318" r:id="Rda53d31be0e947d7"/>
-    <p:sldId xmlns:r="http://schemas.openxmlformats.org/officeDocument/2006/relationships" id="319" r:id="R7dc79591af0447c3"/>
-    <p:sldId xmlns:r="http://schemas.openxmlformats.org/officeDocument/2006/relationships" id="320" r:id="R721e1ca688704332"/>
-    <p:sldId xmlns:r="http://schemas.openxmlformats.org/officeDocument/2006/relationships" id="321" r:id="R3cc148e290b44a45"/>
-    <p:sldId xmlns:r="http://schemas.openxmlformats.org/officeDocument/2006/relationships" id="322" r:id="Rb12d475e6e004f59"/>
-    <p:sldId xmlns:r="http://schemas.openxmlformats.org/officeDocument/2006/relationships" id="323" r:id="R66b9ebefa03e43e4"/>
-    <p:sldId xmlns:r="http://schemas.openxmlformats.org/officeDocument/2006/relationships" id="324" r:id="R13a7bfb0c26d40c5"/>
-    <p:sldId xmlns:r="http://schemas.openxmlformats.org/officeDocument/2006/relationships" id="325" r:id="R9a29ef7e22184619"/>
+    <p:sldId xmlns:r="http://schemas.openxmlformats.org/officeDocument/2006/relationships" id="256" r:id="R263d3605d7c442ba"/>
+    <p:sldId xmlns:r="http://schemas.openxmlformats.org/officeDocument/2006/relationships" id="257" r:id="R0a23b797f5964882"/>
+    <p:sldId xmlns:r="http://schemas.openxmlformats.org/officeDocument/2006/relationships" id="258" r:id="Rea59c41c791f4f45"/>
+    <p:sldId xmlns:r="http://schemas.openxmlformats.org/officeDocument/2006/relationships" id="259" r:id="Rfffc0e65824c4e1c"/>
+    <p:sldId xmlns:r="http://schemas.openxmlformats.org/officeDocument/2006/relationships" id="260" r:id="R3cedbaae20e34eef"/>
+    <p:sldId xmlns:r="http://schemas.openxmlformats.org/officeDocument/2006/relationships" id="261" r:id="Rf6f5567bae494371"/>
+    <p:sldId xmlns:r="http://schemas.openxmlformats.org/officeDocument/2006/relationships" id="262" r:id="Rb8c14f6b24d049ff"/>
+    <p:sldId xmlns:r="http://schemas.openxmlformats.org/officeDocument/2006/relationships" id="263" r:id="R595880edc9bb45e2"/>
+    <p:sldId xmlns:r="http://schemas.openxmlformats.org/officeDocument/2006/relationships" id="264" r:id="Rfb9f2720c17b44ee"/>
+    <p:sldId xmlns:r="http://schemas.openxmlformats.org/officeDocument/2006/relationships" id="265" r:id="R890b13722d4b4c8e"/>
+    <p:sldId xmlns:r="http://schemas.openxmlformats.org/officeDocument/2006/relationships" id="266" r:id="R57354f46b6b54d0e"/>
+    <p:sldId xmlns:r="http://schemas.openxmlformats.org/officeDocument/2006/relationships" id="267" r:id="R68ed89e7b0764b37"/>
+    <p:sldId xmlns:r="http://schemas.openxmlformats.org/officeDocument/2006/relationships" id="268" r:id="Rd1462e5eb3644fd3"/>
+    <p:sldId xmlns:r="http://schemas.openxmlformats.org/officeDocument/2006/relationships" id="269" r:id="Rc1be19952f214a6a"/>
+    <p:sldId xmlns:r="http://schemas.openxmlformats.org/officeDocument/2006/relationships" id="270" r:id="R29f3718665794952"/>
+    <p:sldId xmlns:r="http://schemas.openxmlformats.org/officeDocument/2006/relationships" id="271" r:id="R89380b64c6334732"/>
+    <p:sldId xmlns:r="http://schemas.openxmlformats.org/officeDocument/2006/relationships" id="272" r:id="R3bcbab94d2da42f6"/>
+    <p:sldId xmlns:r="http://schemas.openxmlformats.org/officeDocument/2006/relationships" id="273" r:id="R63f06b6dc0fd4749"/>
+    <p:sldId xmlns:r="http://schemas.openxmlformats.org/officeDocument/2006/relationships" id="274" r:id="Rb246978574954c8f"/>
+    <p:sldId xmlns:r="http://schemas.openxmlformats.org/officeDocument/2006/relationships" id="275" r:id="R4b63c7aa6f81403e"/>
+    <p:sldId xmlns:r="http://schemas.openxmlformats.org/officeDocument/2006/relationships" id="276" r:id="R2c1e36b75e914383"/>
+    <p:sldId xmlns:r="http://schemas.openxmlformats.org/officeDocument/2006/relationships" id="277" r:id="R9a3b405e0a674dac"/>
+    <p:sldId xmlns:r="http://schemas.openxmlformats.org/officeDocument/2006/relationships" id="278" r:id="R36696d51740b460e"/>
+    <p:sldId xmlns:r="http://schemas.openxmlformats.org/officeDocument/2006/relationships" id="279" r:id="R0b7153e7c6f742ad"/>
+    <p:sldId xmlns:r="http://schemas.openxmlformats.org/officeDocument/2006/relationships" id="280" r:id="R2c21c65bf9ce4f03"/>
+    <p:sldId xmlns:r="http://schemas.openxmlformats.org/officeDocument/2006/relationships" id="281" r:id="Rc4faac2dfb074316"/>
+    <p:sldId xmlns:r="http://schemas.openxmlformats.org/officeDocument/2006/relationships" id="282" r:id="Raf54bf1f1393484d"/>
+    <p:sldId xmlns:r="http://schemas.openxmlformats.org/officeDocument/2006/relationships" id="283" r:id="R64562c2a08a948ec"/>
+    <p:sldId xmlns:r="http://schemas.openxmlformats.org/officeDocument/2006/relationships" id="284" r:id="R1fe0acec61124966"/>
+    <p:sldId xmlns:r="http://schemas.openxmlformats.org/officeDocument/2006/relationships" id="285" r:id="Ra2d7fe7ceb78441f"/>
+    <p:sldId xmlns:r="http://schemas.openxmlformats.org/officeDocument/2006/relationships" id="286" r:id="R34373a2f7ab24edb"/>
+    <p:sldId xmlns:r="http://schemas.openxmlformats.org/officeDocument/2006/relationships" id="287" r:id="Ra9dfbdc07cdf494d"/>
+    <p:sldId xmlns:r="http://schemas.openxmlformats.org/officeDocument/2006/relationships" id="288" r:id="Re42ae8fa609a4624"/>
+    <p:sldId xmlns:r="http://schemas.openxmlformats.org/officeDocument/2006/relationships" id="289" r:id="Rfa62d801d8534031"/>
+    <p:sldId xmlns:r="http://schemas.openxmlformats.org/officeDocument/2006/relationships" id="290" r:id="R56612c2dd9d14325"/>
+    <p:sldId xmlns:r="http://schemas.openxmlformats.org/officeDocument/2006/relationships" id="291" r:id="Rd13f623ac44b467c"/>
+    <p:sldId xmlns:r="http://schemas.openxmlformats.org/officeDocument/2006/relationships" id="292" r:id="R875ac604b63c4cfb"/>
+    <p:sldId xmlns:r="http://schemas.openxmlformats.org/officeDocument/2006/relationships" id="293" r:id="Rc18c296d752b4d31"/>
+    <p:sldId xmlns:r="http://schemas.openxmlformats.org/officeDocument/2006/relationships" id="294" r:id="Rfaff693cc21643c3"/>
+    <p:sldId xmlns:r="http://schemas.openxmlformats.org/officeDocument/2006/relationships" id="295" r:id="Rc8f9af84a06a4f34"/>
+    <p:sldId xmlns:r="http://schemas.openxmlformats.org/officeDocument/2006/relationships" id="296" r:id="R5f0353a09b604fb6"/>
+    <p:sldId xmlns:r="http://schemas.openxmlformats.org/officeDocument/2006/relationships" id="297" r:id="R70db40a4ca744433"/>
+    <p:sldId xmlns:r="http://schemas.openxmlformats.org/officeDocument/2006/relationships" id="298" r:id="Rd7cd7f7bcbdb41c3"/>
+    <p:sldId xmlns:r="http://schemas.openxmlformats.org/officeDocument/2006/relationships" id="299" r:id="R8c334720b23544c3"/>
+    <p:sldId xmlns:r="http://schemas.openxmlformats.org/officeDocument/2006/relationships" id="300" r:id="Raab69f0625114dfa"/>
+    <p:sldId xmlns:r="http://schemas.openxmlformats.org/officeDocument/2006/relationships" id="301" r:id="R25e6eb189adc4997"/>
+    <p:sldId xmlns:r="http://schemas.openxmlformats.org/officeDocument/2006/relationships" id="302" r:id="R605571e4abd24a45"/>
+    <p:sldId xmlns:r="http://schemas.openxmlformats.org/officeDocument/2006/relationships" id="303" r:id="Re92fae5905084b20"/>
+    <p:sldId xmlns:r="http://schemas.openxmlformats.org/officeDocument/2006/relationships" id="304" r:id="R4ff2f4db999c446c"/>
+    <p:sldId xmlns:r="http://schemas.openxmlformats.org/officeDocument/2006/relationships" id="305" r:id="R40b564f161ff48d6"/>
+    <p:sldId xmlns:r="http://schemas.openxmlformats.org/officeDocument/2006/relationships" id="306" r:id="R80719c80ca324b29"/>
+    <p:sldId xmlns:r="http://schemas.openxmlformats.org/officeDocument/2006/relationships" id="307" r:id="R64d62cf801a64107"/>
+    <p:sldId xmlns:r="http://schemas.openxmlformats.org/officeDocument/2006/relationships" id="308" r:id="R93197efdad7845d8"/>
+    <p:sldId xmlns:r="http://schemas.openxmlformats.org/officeDocument/2006/relationships" id="309" r:id="Rc89f2256bc7b4bed"/>
+    <p:sldId xmlns:r="http://schemas.openxmlformats.org/officeDocument/2006/relationships" id="310" r:id="Re3a78302625b4333"/>
+    <p:sldId xmlns:r="http://schemas.openxmlformats.org/officeDocument/2006/relationships" id="311" r:id="R04c016ede3034390"/>
+    <p:sldId xmlns:r="http://schemas.openxmlformats.org/officeDocument/2006/relationships" id="312" r:id="Rd43053bea7634689"/>
+    <p:sldId xmlns:r="http://schemas.openxmlformats.org/officeDocument/2006/relationships" id="313" r:id="R254528461a1741a0"/>
+    <p:sldId xmlns:r="http://schemas.openxmlformats.org/officeDocument/2006/relationships" id="314" r:id="R504d641071a749cc"/>
+    <p:sldId xmlns:r="http://schemas.openxmlformats.org/officeDocument/2006/relationships" id="315" r:id="R98e2e93445c14342"/>
+    <p:sldId xmlns:r="http://schemas.openxmlformats.org/officeDocument/2006/relationships" id="316" r:id="Rc6a1a62ac0294989"/>
+    <p:sldId xmlns:r="http://schemas.openxmlformats.org/officeDocument/2006/relationships" id="317" r:id="R9eeea6d87bf748b8"/>
+    <p:sldId xmlns:r="http://schemas.openxmlformats.org/officeDocument/2006/relationships" id="318" r:id="R49131edd18734cb8"/>
+    <p:sldId xmlns:r="http://schemas.openxmlformats.org/officeDocument/2006/relationships" id="319" r:id="R3a796f4dc68543e5"/>
+    <p:sldId xmlns:r="http://schemas.openxmlformats.org/officeDocument/2006/relationships" id="320" r:id="Ra90c6ba2b69d4046"/>
+    <p:sldId xmlns:r="http://schemas.openxmlformats.org/officeDocument/2006/relationships" id="321" r:id="R71968ae4d6424c4e"/>
+    <p:sldId xmlns:r="http://schemas.openxmlformats.org/officeDocument/2006/relationships" id="322" r:id="Ra28a764acf534b24"/>
+    <p:sldId xmlns:r="http://schemas.openxmlformats.org/officeDocument/2006/relationships" id="323" r:id="R55480be78482452d"/>
+    <p:sldId xmlns:r="http://schemas.openxmlformats.org/officeDocument/2006/relationships" id="324" r:id="R51e2c86817c74eb6"/>
+    <p:sldId xmlns:r="http://schemas.openxmlformats.org/officeDocument/2006/relationships" id="325" r:id="R87311f0567314153"/>
   </p:sldIdLst>
   <p:sldSz cx="12192000" cy="6858000"/>
   <p:notesSz cx="6858000" cy="9144000"/>
@@ -1331,7 +1331,7 @@
           <a:lstStyle xmlns:a="http://schemas.openxmlformats.org/drawingml/2006/main"/>
           <a:p xmlns:a="http://schemas.openxmlformats.org/drawingml/2006/main">
             <a:r>
-              <a:t>לומר: Our first English test is on Thursday, October 8. We are starting our preparation today. להבהיר שזהו המועד שפורסם.</a:t>
+              <a:t>לומר: המבחן ביום חמישי, כ״ז בתשרי תשפ״ז (8.10.2026). היום מתחילים להתכונן. להבהיר שזהו המועד שפורסם.</a:t>
             </a:r>
           </a:p>
           <a:p xmlns:a="http://schemas.openxmlformats.org/drawingml/2006/main">
@@ -2156,7 +2156,7 @@
           <a:lstStyle xmlns:a="http://schemas.openxmlformats.org/drawingml/2006/main"/>
           <a:p xmlns:a="http://schemas.openxmlformats.org/drawingml/2006/main">
             <a:r>
-              <a:t>מנקודת המבט של התלמידים ב־14.9: שלושה מפגשים מתוכננים כולל היום, שניים אחריו. חופשת החגים 20.9–3.10. המבחן עצמו אינו נספר כמפגש הכנה. אין להציג את 17.9 כמאושר.</a:t>
+              <a:t>ליום השיעור: שלושה מפגשים מתוכננים כולל היום, שניים אחריו. חופשת החגים מיום ראשון, ט׳ בתשרי תשפ״ז (20.9.2026), עד שבת, כ״ב בתשרי תשפ״ז (3.10.2026). המבחן עצמו אינו נספר כמפגש הכנה. המפגש השני אינו מאושר סופית.</a:t>
             </a:r>
           </a:p>
           <a:p xmlns:a="http://schemas.openxmlformats.org/drawingml/2006/main">
@@ -2381,7 +2381,7 @@
           </a:p>
           <a:p xmlns:a="http://schemas.openxmlformats.org/drawingml/2006/main">
             <a:r>
-              <a:t>Source: https://drive.google.com/file/d/1GJz_c1qY3qMb3NidioFReT7V1l2WebFr/view</a:t>
+              <a:t>Source: https://drive.google.com/file/d/1v5hxzvq6L3lwQonsgvWBEOi9tFcik7v0/view</a:t>
             </a:r>
           </a:p>
         </p:txBody>
@@ -2606,7 +2606,7 @@
           </a:p>
           <a:p xmlns:a="http://schemas.openxmlformats.org/drawingml/2006/main">
             <a:r>
-              <a:t>Source: https://drive.google.com/file/d/1GJz_c1qY3qMb3NidioFReT7V1l2WebFr/view</a:t>
+              <a:t>Source: https://drive.google.com/file/d/1v5hxzvq6L3lwQonsgvWBEOi9tFcik7v0/view</a:t>
             </a:r>
           </a:p>
         </p:txBody>
@@ -2681,7 +2681,7 @@
           </a:p>
           <a:p xmlns:a="http://schemas.openxmlformats.org/drawingml/2006/main">
             <a:r>
-              <a:t>Source: https://drive.google.com/file/d/1GJz_c1qY3qMb3NidioFReT7V1l2WebFr/view</a:t>
+              <a:t>Source: https://drive.google.com/file/d/1v5hxzvq6L3lwQonsgvWBEOi9tFcik7v0/view</a:t>
             </a:r>
           </a:p>
         </p:txBody>
@@ -2756,7 +2756,7 @@
           </a:p>
           <a:p xmlns:a="http://schemas.openxmlformats.org/drawingml/2006/main">
             <a:r>
-              <a:t>Source: https://drive.google.com/file/d/1GJz_c1qY3qMb3NidioFReT7V1l2WebFr/view</a:t>
+              <a:t>Source: https://drive.google.com/file/d/1v5hxzvq6L3lwQonsgvWBEOi9tFcik7v0/view</a:t>
             </a:r>
           </a:p>
         </p:txBody>
@@ -3131,7 +3131,7 @@
           </a:p>
           <a:p xmlns:a="http://schemas.openxmlformats.org/drawingml/2006/main">
             <a:r>
-              <a:t>Source: https://drive.google.com/file/d/1GJz_c1qY3qMb3NidioFReT7V1l2WebFr/view</a:t>
+              <a:t>Source: https://drive.google.com/file/d/1v5hxzvq6L3lwQonsgvWBEOi9tFcik7v0/view</a:t>
             </a:r>
           </a:p>
         </p:txBody>
@@ -3206,7 +3206,7 @@
           </a:p>
           <a:p xmlns:a="http://schemas.openxmlformats.org/drawingml/2006/main">
             <a:r>
-              <a:t>Source: https://drive.google.com/file/d/1GJz_c1qY3qMb3NidioFReT7V1l2WebFr/view</a:t>
+              <a:t>Source: https://drive.google.com/file/d/1v5hxzvq6L3lwQonsgvWBEOi9tFcik7v0/view</a:t>
             </a:r>
           </a:p>
         </p:txBody>
@@ -3581,7 +3581,7 @@
           </a:p>
           <a:p xmlns:a="http://schemas.openxmlformats.org/drawingml/2006/main">
             <a:r>
-              <a:t>Source: https://drive.google.com/file/d/1GJz_c1qY3qMb3NidioFReT7V1l2WebFr/view</a:t>
+              <a:t>Source: https://drive.google.com/file/d/1v5hxzvq6L3lwQonsgvWBEOi9tFcik7v0/view</a:t>
             </a:r>
           </a:p>
         </p:txBody>
@@ -3951,7 +3951,7 @@
           </a:p>
           <a:p xmlns:a="http://schemas.openxmlformats.org/drawingml/2006/main">
             <a:r>
-              <a:t>Source: https://drive.google.com/file/d/1GJz_c1qY3qMb3NidioFReT7V1l2WebFr/view</a:t>
+              <a:t>Source: https://drive.google.com/file/d/1v5hxzvq6L3lwQonsgvWBEOi9tFcik7v0/view</a:t>
             </a:r>
           </a:p>
         </p:txBody>
@@ -4026,7 +4026,7 @@
           </a:p>
           <a:p xmlns:a="http://schemas.openxmlformats.org/drawingml/2006/main">
             <a:r>
-              <a:t>Source: https://drive.google.com/file/d/1GJz_c1qY3qMb3NidioFReT7V1l2WebFr/view</a:t>
+              <a:t>Source: https://drive.google.com/file/d/1v5hxzvq6L3lwQonsgvWBEOi9tFcik7v0/view</a:t>
             </a:r>
           </a:p>
         </p:txBody>
@@ -5336,7 +5336,7 @@
           <a:lstStyle xmlns:a="http://schemas.openxmlformats.org/drawingml/2006/main"/>
           <a:p xmlns:a="http://schemas.openxmlformats.org/drawingml/2006/main">
             <a:r>
-              <a:t>זהו תרגול שנקבע במערך הזה. אין להציג את שלוש המילים שהופיעו במצגת כמכלול 55 מילות הקבוצה. המועד שפורסם לבחינה הוא 8.10.</a:t>
+              <a:t>זהו תרגול שנקבע במערך הזה. אין להציג את שלוש המילים שהופיעו במצגת כמכלול 55 מילות הקבוצה. המועד שפורסם לבחינה הוא יום חמישי, כ״ז בתשרי תשפ״ז (8.10.2026).</a:t>
             </a:r>
           </a:p>
           <a:p xmlns:a="http://schemas.openxmlformats.org/drawingml/2006/main">
@@ -5704,7 +5704,7 @@
   </p:cSld>
   <p:clrMap bg1="lt1" tx1="dk1" bg2="lt2" tx2="dk2" accent1="accent1" accent2="accent2" accent3="accent3" accent4="accent4" accent5="accent5" accent6="accent6" hlink="hlink" folHlink="folHlink"/>
   <p:sldLayoutIdLst>
-    <p:sldLayoutId xmlns:r="http://schemas.openxmlformats.org/officeDocument/2006/relationships" id="2147483649" r:id="R0e99bb819e8f4f0a"/>
+    <p:sldLayoutId xmlns:r="http://schemas.openxmlformats.org/officeDocument/2006/relationships" id="2147483649" r:id="Rf389e2e66dc44209"/>
   </p:sldLayoutIdLst>
   <p:txStyles>
     <p:titleStyle>
@@ -6266,7 +6266,7 @@
           <p:cNvPr id="5" name="text">
             <a:extLst xmlns:a="http://schemas.openxmlformats.org/drawingml/2006/main">
               <a:ext uri="{FF2B5EF4-FFF2-40B4-BE49-F238E27FC236}">
-                <a16:creationId xmlns:a16="http://schemas.microsoft.com/office/drawing/2014/main" id="{20B74ACE-9C86-4023-B7FF-761F1C9B8110}"/>
+                <a16:creationId xmlns:a16="http://schemas.microsoft.com/office/drawing/2014/main" id="{5F65DEBA-4F06-4BB2-A97A-7DFFF65E3AD9}"/>
               </a:ext>
             </a:extLst>
           </p:cNvPr>
@@ -6323,7 +6323,7 @@
           <p:cNvPr id="2" name="text">
             <a:extLst xmlns:a="http://schemas.openxmlformats.org/drawingml/2006/main">
               <a:ext uri="{FF2B5EF4-FFF2-40B4-BE49-F238E27FC236}">
-                <a16:creationId xmlns:a16="http://schemas.microsoft.com/office/drawing/2014/main" id="{7BEBF9BD-ACAD-4829-9772-91247FD95E91}"/>
+                <a16:creationId xmlns:a16="http://schemas.microsoft.com/office/drawing/2014/main" id="{67D3A7B7-8333-40D4-884E-E5C224E24AD3}"/>
               </a:ext>
             </a:extLst>
           </p:cNvPr>
@@ -6380,7 +6380,7 @@
           <p:cNvPr id="3" name="text">
             <a:extLst xmlns:a="http://schemas.openxmlformats.org/drawingml/2006/main">
               <a:ext uri="{FF2B5EF4-FFF2-40B4-BE49-F238E27FC236}">
-                <a16:creationId xmlns:a16="http://schemas.microsoft.com/office/drawing/2014/main" id="{BB85F8AC-BCC5-4ADD-A07D-BBA6CAC0DF15}"/>
+                <a16:creationId xmlns:a16="http://schemas.microsoft.com/office/drawing/2014/main" id="{41A545C7-EA33-4FA6-B6C6-D5D556528D57}"/>
               </a:ext>
             </a:extLst>
           </p:cNvPr>
@@ -6427,7 +6427,7 @@
                 <a:ea typeface="Heebo"/>
                 <a:cs typeface="Heebo"/>
               </a:rPr>
-              <a:t>כיתה ח׳ · אנגלית</a:t>
+              <a:t>כיתה ח׳2 · אנגלית</a:t>
             </a:r>
           </a:p>
         </p:txBody>
@@ -6437,7 +6437,7 @@
           <p:cNvPr id="4" name="text">
             <a:extLst xmlns:a="http://schemas.openxmlformats.org/drawingml/2006/main">
               <a:ext uri="{FF2B5EF4-FFF2-40B4-BE49-F238E27FC236}">
-                <a16:creationId xmlns:a16="http://schemas.microsoft.com/office/drawing/2014/main" id="{15C9AE82-5B3D-43E2-82AD-261737280B3E}"/>
+                <a16:creationId xmlns:a16="http://schemas.microsoft.com/office/drawing/2014/main" id="{61C9EC57-43CC-4260-800C-9A254F05D653}"/>
               </a:ext>
             </a:extLst>
           </p:cNvPr>
@@ -6492,7 +6492,7 @@
     </p:spTree>
     <p:extLst>
       <p:ext uri="{BB962C8B-B14F-4D97-AF65-F5344CB8AC3E}">
-        <p14:creationId xmlns:p14="http://schemas.microsoft.com/office/powerpoint/2010/main" val="1984886351"/>
+        <p14:creationId xmlns:p14="http://schemas.microsoft.com/office/powerpoint/2010/main" val="506420348"/>
       </p:ext>
     </p:extLst>
   </p:cSld>
@@ -6534,7 +6534,7 @@
           <p:cNvPr id="6" name="text">
             <a:extLst xmlns:a="http://schemas.openxmlformats.org/drawingml/2006/main">
               <a:ext uri="{FF2B5EF4-FFF2-40B4-BE49-F238E27FC236}">
-                <a16:creationId xmlns:a16="http://schemas.microsoft.com/office/drawing/2014/main" id="{E5D8E774-49A3-40F2-898D-1A81DB635F2E}"/>
+                <a16:creationId xmlns:a16="http://schemas.microsoft.com/office/drawing/2014/main" id="{0DF56F53-E604-4B29-A30E-CA83EA38CE1C}"/>
               </a:ext>
             </a:extLst>
           </p:cNvPr>
@@ -6591,7 +6591,7 @@
           <p:cNvPr id="2" name="text">
             <a:extLst xmlns:a="http://schemas.openxmlformats.org/drawingml/2006/main">
               <a:ext uri="{FF2B5EF4-FFF2-40B4-BE49-F238E27FC236}">
-                <a16:creationId xmlns:a16="http://schemas.microsoft.com/office/drawing/2014/main" id="{380DA1B4-2B25-491E-9E66-6A47DE34D97A}"/>
+                <a16:creationId xmlns:a16="http://schemas.microsoft.com/office/drawing/2014/main" id="{9C515C4C-BED6-4779-B66C-59121129851C}"/>
               </a:ext>
             </a:extLst>
           </p:cNvPr>
@@ -6648,7 +6648,7 @@
           <p:cNvPr id="3" name="text">
             <a:extLst xmlns:a="http://schemas.openxmlformats.org/drawingml/2006/main">
               <a:ext uri="{FF2B5EF4-FFF2-40B4-BE49-F238E27FC236}">
-                <a16:creationId xmlns:a16="http://schemas.microsoft.com/office/drawing/2014/main" id="{79140CC5-6A6E-421B-8E8F-382A94A59CCB}"/>
+                <a16:creationId xmlns:a16="http://schemas.microsoft.com/office/drawing/2014/main" id="{60EBFD0A-7D68-41C6-85F9-9481E4E29D8F}"/>
               </a:ext>
             </a:extLst>
           </p:cNvPr>
@@ -6705,7 +6705,7 @@
           <p:cNvPr id="4" name="text">
             <a:extLst xmlns:a="http://schemas.openxmlformats.org/drawingml/2006/main">
               <a:ext uri="{FF2B5EF4-FFF2-40B4-BE49-F238E27FC236}">
-                <a16:creationId xmlns:a16="http://schemas.microsoft.com/office/drawing/2014/main" id="{DDC94971-AB69-46D1-8A93-8D247F972DAC}"/>
+                <a16:creationId xmlns:a16="http://schemas.microsoft.com/office/drawing/2014/main" id="{0E4D385D-C3F8-46B4-939A-3CBF2289D6CC}"/>
               </a:ext>
             </a:extLst>
           </p:cNvPr>
@@ -6762,7 +6762,7 @@
           <p:cNvPr id="5" name="text">
             <a:extLst xmlns:a="http://schemas.openxmlformats.org/drawingml/2006/main">
               <a:ext uri="{FF2B5EF4-FFF2-40B4-BE49-F238E27FC236}">
-                <a16:creationId xmlns:a16="http://schemas.microsoft.com/office/drawing/2014/main" id="{C5B9B855-6E77-4F2F-99A5-58101E4A5FEF}"/>
+                <a16:creationId xmlns:a16="http://schemas.microsoft.com/office/drawing/2014/main" id="{577E1334-AB27-4F06-84A0-5C7D879B0488}"/>
               </a:ext>
             </a:extLst>
           </p:cNvPr>
@@ -6817,7 +6817,7 @@
     </p:spTree>
     <p:extLst>
       <p:ext uri="{BB962C8B-B14F-4D97-AF65-F5344CB8AC3E}">
-        <p14:creationId xmlns:p14="http://schemas.microsoft.com/office/powerpoint/2010/main" val="234498946"/>
+        <p14:creationId xmlns:p14="http://schemas.microsoft.com/office/powerpoint/2010/main" val="1911339092"/>
       </p:ext>
     </p:extLst>
   </p:cSld>
@@ -6859,7 +6859,7 @@
           <p:cNvPr id="8" name="text">
             <a:extLst xmlns:a="http://schemas.openxmlformats.org/drawingml/2006/main">
               <a:ext uri="{FF2B5EF4-FFF2-40B4-BE49-F238E27FC236}">
-                <a16:creationId xmlns:a16="http://schemas.microsoft.com/office/drawing/2014/main" id="{CAB474A4-2645-4F1F-B09C-A25643E97B62}"/>
+                <a16:creationId xmlns:a16="http://schemas.microsoft.com/office/drawing/2014/main" id="{F8B342C9-7BF7-4FB3-95DE-3A0011CAAEBB}"/>
               </a:ext>
             </a:extLst>
           </p:cNvPr>
@@ -6916,7 +6916,7 @@
           <p:cNvPr id="2" name="text">
             <a:extLst xmlns:a="http://schemas.openxmlformats.org/drawingml/2006/main">
               <a:ext uri="{FF2B5EF4-FFF2-40B4-BE49-F238E27FC236}">
-                <a16:creationId xmlns:a16="http://schemas.microsoft.com/office/drawing/2014/main" id="{01A7E95F-E3F2-4C6C-94A6-8F4A89E2041F}"/>
+                <a16:creationId xmlns:a16="http://schemas.microsoft.com/office/drawing/2014/main" id="{DAF4A353-0775-4681-BCD8-AD50F9716559}"/>
               </a:ext>
             </a:extLst>
           </p:cNvPr>
@@ -6973,7 +6973,7 @@
           <p:cNvPr id="3" name="text">
             <a:extLst xmlns:a="http://schemas.openxmlformats.org/drawingml/2006/main">
               <a:ext uri="{FF2B5EF4-FFF2-40B4-BE49-F238E27FC236}">
-                <a16:creationId xmlns:a16="http://schemas.microsoft.com/office/drawing/2014/main" id="{461AF013-B47C-498F-80AC-152BF1AF08A9}"/>
+                <a16:creationId xmlns:a16="http://schemas.microsoft.com/office/drawing/2014/main" id="{FCBCCF16-A598-4068-9A92-B91A33B4DDAF}"/>
               </a:ext>
             </a:extLst>
           </p:cNvPr>
@@ -7030,7 +7030,7 @@
           <p:cNvPr id="4" name="text">
             <a:extLst xmlns:a="http://schemas.openxmlformats.org/drawingml/2006/main">
               <a:ext uri="{FF2B5EF4-FFF2-40B4-BE49-F238E27FC236}">
-                <a16:creationId xmlns:a16="http://schemas.microsoft.com/office/drawing/2014/main" id="{D2826034-00CD-4733-B02D-326B12DC73B5}"/>
+                <a16:creationId xmlns:a16="http://schemas.microsoft.com/office/drawing/2014/main" id="{0869EB8B-B4A9-4102-BDDE-1DBD7E9BA0B8}"/>
               </a:ext>
             </a:extLst>
           </p:cNvPr>
@@ -7087,7 +7087,7 @@
           <p:cNvPr id="5" name="text">
             <a:extLst xmlns:a="http://schemas.openxmlformats.org/drawingml/2006/main">
               <a:ext uri="{FF2B5EF4-FFF2-40B4-BE49-F238E27FC236}">
-                <a16:creationId xmlns:a16="http://schemas.microsoft.com/office/drawing/2014/main" id="{4025291C-9259-4ED9-B4C5-6CC9906E9C28}"/>
+                <a16:creationId xmlns:a16="http://schemas.microsoft.com/office/drawing/2014/main" id="{BC89D923-C02B-4D41-A602-46106549A760}"/>
               </a:ext>
             </a:extLst>
           </p:cNvPr>
@@ -7144,7 +7144,7 @@
           <p:cNvPr id="6" name="text">
             <a:extLst xmlns:a="http://schemas.openxmlformats.org/drawingml/2006/main">
               <a:ext uri="{FF2B5EF4-FFF2-40B4-BE49-F238E27FC236}">
-                <a16:creationId xmlns:a16="http://schemas.microsoft.com/office/drawing/2014/main" id="{A3186E6A-43A3-46CE-81E9-BAEAAF432252}"/>
+                <a16:creationId xmlns:a16="http://schemas.microsoft.com/office/drawing/2014/main" id="{AF5B2A44-D3A8-4343-995C-25711F2A810E}"/>
               </a:ext>
             </a:extLst>
           </p:cNvPr>
@@ -7201,7 +7201,7 @@
           <p:cNvPr id="7" name="text">
             <a:extLst xmlns:a="http://schemas.openxmlformats.org/drawingml/2006/main">
               <a:ext uri="{FF2B5EF4-FFF2-40B4-BE49-F238E27FC236}">
-                <a16:creationId xmlns:a16="http://schemas.microsoft.com/office/drawing/2014/main" id="{717EF714-1BA1-4400-9CF8-C9012204621F}"/>
+                <a16:creationId xmlns:a16="http://schemas.microsoft.com/office/drawing/2014/main" id="{380074F0-E983-416F-81D6-733275D28BBC}"/>
               </a:ext>
             </a:extLst>
           </p:cNvPr>
@@ -7256,7 +7256,7 @@
     </p:spTree>
     <p:extLst>
       <p:ext uri="{BB962C8B-B14F-4D97-AF65-F5344CB8AC3E}">
-        <p14:creationId xmlns:p14="http://schemas.microsoft.com/office/powerpoint/2010/main" val="253587682"/>
+        <p14:creationId xmlns:p14="http://schemas.microsoft.com/office/powerpoint/2010/main" val="1601881975"/>
       </p:ext>
     </p:extLst>
   </p:cSld>
@@ -7298,7 +7298,7 @@
           <p:cNvPr id="6" name="text">
             <a:extLst xmlns:a="http://schemas.openxmlformats.org/drawingml/2006/main">
               <a:ext uri="{FF2B5EF4-FFF2-40B4-BE49-F238E27FC236}">
-                <a16:creationId xmlns:a16="http://schemas.microsoft.com/office/drawing/2014/main" id="{FE5120E2-8173-4C1A-AFB3-23F3778FF23B}"/>
+                <a16:creationId xmlns:a16="http://schemas.microsoft.com/office/drawing/2014/main" id="{C31252A8-FAAD-4B99-B024-686C234BD420}"/>
               </a:ext>
             </a:extLst>
           </p:cNvPr>
@@ -7355,7 +7355,7 @@
           <p:cNvPr id="2" name="text">
             <a:extLst xmlns:a="http://schemas.openxmlformats.org/drawingml/2006/main">
               <a:ext uri="{FF2B5EF4-FFF2-40B4-BE49-F238E27FC236}">
-                <a16:creationId xmlns:a16="http://schemas.microsoft.com/office/drawing/2014/main" id="{C737C861-36F4-4EC6-AB93-FB7B97527731}"/>
+                <a16:creationId xmlns:a16="http://schemas.microsoft.com/office/drawing/2014/main" id="{D8273F71-CA87-40E7-9A6F-4150458086A6}"/>
               </a:ext>
             </a:extLst>
           </p:cNvPr>
@@ -7412,7 +7412,7 @@
           <p:cNvPr id="3" name="text">
             <a:extLst xmlns:a="http://schemas.openxmlformats.org/drawingml/2006/main">
               <a:ext uri="{FF2B5EF4-FFF2-40B4-BE49-F238E27FC236}">
-                <a16:creationId xmlns:a16="http://schemas.microsoft.com/office/drawing/2014/main" id="{61D1EF28-DCAF-4D81-9F6F-CC52B0703DB0}"/>
+                <a16:creationId xmlns:a16="http://schemas.microsoft.com/office/drawing/2014/main" id="{E328D9B6-E654-4895-9C42-FC2169C52D91}"/>
               </a:ext>
             </a:extLst>
           </p:cNvPr>
@@ -7469,7 +7469,7 @@
           <p:cNvPr id="4" name="text">
             <a:extLst xmlns:a="http://schemas.openxmlformats.org/drawingml/2006/main">
               <a:ext uri="{FF2B5EF4-FFF2-40B4-BE49-F238E27FC236}">
-                <a16:creationId xmlns:a16="http://schemas.microsoft.com/office/drawing/2014/main" id="{1E1196E1-1461-40EB-9B89-A1523346FFEF}"/>
+                <a16:creationId xmlns:a16="http://schemas.microsoft.com/office/drawing/2014/main" id="{59F5C5B8-45A5-4147-BB66-7F4A51B1F04D}"/>
               </a:ext>
             </a:extLst>
           </p:cNvPr>
@@ -7526,7 +7526,7 @@
           <p:cNvPr id="5" name="text">
             <a:extLst xmlns:a="http://schemas.openxmlformats.org/drawingml/2006/main">
               <a:ext uri="{FF2B5EF4-FFF2-40B4-BE49-F238E27FC236}">
-                <a16:creationId xmlns:a16="http://schemas.microsoft.com/office/drawing/2014/main" id="{BC9404FF-C501-428E-B610-90D1E8C4E2C2}"/>
+                <a16:creationId xmlns:a16="http://schemas.microsoft.com/office/drawing/2014/main" id="{9C07FD97-1BFF-4E1B-A72A-55871A604163}"/>
               </a:ext>
             </a:extLst>
           </p:cNvPr>
@@ -7581,7 +7581,7 @@
     </p:spTree>
     <p:extLst>
       <p:ext uri="{BB962C8B-B14F-4D97-AF65-F5344CB8AC3E}">
-        <p14:creationId xmlns:p14="http://schemas.microsoft.com/office/powerpoint/2010/main" val="943064949"/>
+        <p14:creationId xmlns:p14="http://schemas.microsoft.com/office/powerpoint/2010/main" val="422654575"/>
       </p:ext>
     </p:extLst>
   </p:cSld>
@@ -7623,7 +7623,7 @@
           <p:cNvPr id="8" name="text">
             <a:extLst xmlns:a="http://schemas.openxmlformats.org/drawingml/2006/main">
               <a:ext uri="{FF2B5EF4-FFF2-40B4-BE49-F238E27FC236}">
-                <a16:creationId xmlns:a16="http://schemas.microsoft.com/office/drawing/2014/main" id="{82174755-7B67-40B9-9761-D3C1A7C54C41}"/>
+                <a16:creationId xmlns:a16="http://schemas.microsoft.com/office/drawing/2014/main" id="{33261184-39FB-44B0-B17A-5C430DA22F2D}"/>
               </a:ext>
             </a:extLst>
           </p:cNvPr>
@@ -7680,7 +7680,7 @@
           <p:cNvPr id="2" name="text">
             <a:extLst xmlns:a="http://schemas.openxmlformats.org/drawingml/2006/main">
               <a:ext uri="{FF2B5EF4-FFF2-40B4-BE49-F238E27FC236}">
-                <a16:creationId xmlns:a16="http://schemas.microsoft.com/office/drawing/2014/main" id="{C54EC3C0-4BEE-43AE-A9D4-FEB2E8BDB703}"/>
+                <a16:creationId xmlns:a16="http://schemas.microsoft.com/office/drawing/2014/main" id="{362D55D5-180A-4E80-9F6A-C4A86103594D}"/>
               </a:ext>
             </a:extLst>
           </p:cNvPr>
@@ -7737,7 +7737,7 @@
           <p:cNvPr id="3" name="text">
             <a:extLst xmlns:a="http://schemas.openxmlformats.org/drawingml/2006/main">
               <a:ext uri="{FF2B5EF4-FFF2-40B4-BE49-F238E27FC236}">
-                <a16:creationId xmlns:a16="http://schemas.microsoft.com/office/drawing/2014/main" id="{2CE12041-1A42-40E6-B76C-F5126F36718D}"/>
+                <a16:creationId xmlns:a16="http://schemas.microsoft.com/office/drawing/2014/main" id="{78A5F21E-651D-4C13-9068-4CB6F012C6C3}"/>
               </a:ext>
             </a:extLst>
           </p:cNvPr>
@@ -7794,7 +7794,7 @@
           <p:cNvPr id="4" name="text">
             <a:extLst xmlns:a="http://schemas.openxmlformats.org/drawingml/2006/main">
               <a:ext uri="{FF2B5EF4-FFF2-40B4-BE49-F238E27FC236}">
-                <a16:creationId xmlns:a16="http://schemas.microsoft.com/office/drawing/2014/main" id="{6716013D-881E-40E4-87F1-FCD95D3CA858}"/>
+                <a16:creationId xmlns:a16="http://schemas.microsoft.com/office/drawing/2014/main" id="{C914ED86-83D1-4904-A297-9741D0907B1F}"/>
               </a:ext>
             </a:extLst>
           </p:cNvPr>
@@ -7851,7 +7851,7 @@
           <p:cNvPr id="5" name="text">
             <a:extLst xmlns:a="http://schemas.openxmlformats.org/drawingml/2006/main">
               <a:ext uri="{FF2B5EF4-FFF2-40B4-BE49-F238E27FC236}">
-                <a16:creationId xmlns:a16="http://schemas.microsoft.com/office/drawing/2014/main" id="{5406BE21-85FC-4043-98BB-6A86676EB4DE}"/>
+                <a16:creationId xmlns:a16="http://schemas.microsoft.com/office/drawing/2014/main" id="{426EAF32-A1A5-4376-8AE0-63E8FA023EFD}"/>
               </a:ext>
             </a:extLst>
           </p:cNvPr>
@@ -7908,7 +7908,7 @@
           <p:cNvPr id="6" name="text">
             <a:extLst xmlns:a="http://schemas.openxmlformats.org/drawingml/2006/main">
               <a:ext uri="{FF2B5EF4-FFF2-40B4-BE49-F238E27FC236}">
-                <a16:creationId xmlns:a16="http://schemas.microsoft.com/office/drawing/2014/main" id="{2771DF29-FB36-4163-984D-F65A79C043B7}"/>
+                <a16:creationId xmlns:a16="http://schemas.microsoft.com/office/drawing/2014/main" id="{A103CFFA-B771-4488-84FC-13710327E087}"/>
               </a:ext>
             </a:extLst>
           </p:cNvPr>
@@ -7965,7 +7965,7 @@
           <p:cNvPr id="7" name="text">
             <a:extLst xmlns:a="http://schemas.openxmlformats.org/drawingml/2006/main">
               <a:ext uri="{FF2B5EF4-FFF2-40B4-BE49-F238E27FC236}">
-                <a16:creationId xmlns:a16="http://schemas.microsoft.com/office/drawing/2014/main" id="{514E7AB6-AFF1-47FF-AFEF-6661510CC0FD}"/>
+                <a16:creationId xmlns:a16="http://schemas.microsoft.com/office/drawing/2014/main" id="{7EA21193-6A12-4A3E-8D35-A490679F7621}"/>
               </a:ext>
             </a:extLst>
           </p:cNvPr>
@@ -8020,7 +8020,7 @@
     </p:spTree>
     <p:extLst>
       <p:ext uri="{BB962C8B-B14F-4D97-AF65-F5344CB8AC3E}">
-        <p14:creationId xmlns:p14="http://schemas.microsoft.com/office/powerpoint/2010/main" val="1129672424"/>
+        <p14:creationId xmlns:p14="http://schemas.microsoft.com/office/powerpoint/2010/main" val="1296926229"/>
       </p:ext>
     </p:extLst>
   </p:cSld>
@@ -8062,7 +8062,7 @@
           <p:cNvPr id="6" name="text">
             <a:extLst xmlns:a="http://schemas.openxmlformats.org/drawingml/2006/main">
               <a:ext uri="{FF2B5EF4-FFF2-40B4-BE49-F238E27FC236}">
-                <a16:creationId xmlns:a16="http://schemas.microsoft.com/office/drawing/2014/main" id="{856823C0-EBBD-4A7F-8B30-FB14748A0170}"/>
+                <a16:creationId xmlns:a16="http://schemas.microsoft.com/office/drawing/2014/main" id="{0C3859A0-D86E-4ED2-A9F5-F28BD458407D}"/>
               </a:ext>
             </a:extLst>
           </p:cNvPr>
@@ -8119,7 +8119,7 @@
           <p:cNvPr id="2" name="text">
             <a:extLst xmlns:a="http://schemas.openxmlformats.org/drawingml/2006/main">
               <a:ext uri="{FF2B5EF4-FFF2-40B4-BE49-F238E27FC236}">
-                <a16:creationId xmlns:a16="http://schemas.microsoft.com/office/drawing/2014/main" id="{F625F192-120E-40FA-A641-EBA5E755F40C}"/>
+                <a16:creationId xmlns:a16="http://schemas.microsoft.com/office/drawing/2014/main" id="{680D6D51-7DA2-4E29-B7D6-A447B73601FE}"/>
               </a:ext>
             </a:extLst>
           </p:cNvPr>
@@ -8176,7 +8176,7 @@
           <p:cNvPr id="3" name="text">
             <a:extLst xmlns:a="http://schemas.openxmlformats.org/drawingml/2006/main">
               <a:ext uri="{FF2B5EF4-FFF2-40B4-BE49-F238E27FC236}">
-                <a16:creationId xmlns:a16="http://schemas.microsoft.com/office/drawing/2014/main" id="{DE44F980-7601-433E-B304-57DE3D12B15B}"/>
+                <a16:creationId xmlns:a16="http://schemas.microsoft.com/office/drawing/2014/main" id="{9CC62DE6-006A-4E76-AF54-D49ECA5444DF}"/>
               </a:ext>
             </a:extLst>
           </p:cNvPr>
@@ -8233,7 +8233,7 @@
           <p:cNvPr id="4" name="text">
             <a:extLst xmlns:a="http://schemas.openxmlformats.org/drawingml/2006/main">
               <a:ext uri="{FF2B5EF4-FFF2-40B4-BE49-F238E27FC236}">
-                <a16:creationId xmlns:a16="http://schemas.microsoft.com/office/drawing/2014/main" id="{BBF55F61-DED2-4C0F-A1B6-B1923C95D0A3}"/>
+                <a16:creationId xmlns:a16="http://schemas.microsoft.com/office/drawing/2014/main" id="{F28E402A-7F7F-4763-A759-E94B479D37DA}"/>
               </a:ext>
             </a:extLst>
           </p:cNvPr>
@@ -8290,7 +8290,7 @@
           <p:cNvPr id="5" name="text">
             <a:extLst xmlns:a="http://schemas.openxmlformats.org/drawingml/2006/main">
               <a:ext uri="{FF2B5EF4-FFF2-40B4-BE49-F238E27FC236}">
-                <a16:creationId xmlns:a16="http://schemas.microsoft.com/office/drawing/2014/main" id="{8627DE10-6E10-4E34-9FAF-DFF026682521}"/>
+                <a16:creationId xmlns:a16="http://schemas.microsoft.com/office/drawing/2014/main" id="{24A0D617-EA80-40C9-B86C-5FF2E38F43B9}"/>
               </a:ext>
             </a:extLst>
           </p:cNvPr>
@@ -8345,7 +8345,7 @@
     </p:spTree>
     <p:extLst>
       <p:ext uri="{BB962C8B-B14F-4D97-AF65-F5344CB8AC3E}">
-        <p14:creationId xmlns:p14="http://schemas.microsoft.com/office/powerpoint/2010/main" val="1330579815"/>
+        <p14:creationId xmlns:p14="http://schemas.microsoft.com/office/powerpoint/2010/main" val="179442109"/>
       </p:ext>
     </p:extLst>
   </p:cSld>
@@ -8387,7 +8387,7 @@
           <p:cNvPr id="8" name="text">
             <a:extLst xmlns:a="http://schemas.openxmlformats.org/drawingml/2006/main">
               <a:ext uri="{FF2B5EF4-FFF2-40B4-BE49-F238E27FC236}">
-                <a16:creationId xmlns:a16="http://schemas.microsoft.com/office/drawing/2014/main" id="{35CB3D84-4826-4B59-AD45-A827C8197410}"/>
+                <a16:creationId xmlns:a16="http://schemas.microsoft.com/office/drawing/2014/main" id="{7DCB82AE-CF24-4958-8475-32B2C253BFFD}"/>
               </a:ext>
             </a:extLst>
           </p:cNvPr>
@@ -8444,7 +8444,7 @@
           <p:cNvPr id="2" name="text">
             <a:extLst xmlns:a="http://schemas.openxmlformats.org/drawingml/2006/main">
               <a:ext uri="{FF2B5EF4-FFF2-40B4-BE49-F238E27FC236}">
-                <a16:creationId xmlns:a16="http://schemas.microsoft.com/office/drawing/2014/main" id="{BF248B9F-2F98-421E-B2F0-98ED10FE4471}"/>
+                <a16:creationId xmlns:a16="http://schemas.microsoft.com/office/drawing/2014/main" id="{83FA8E8F-FF7F-44C9-9BBD-B5036E5095D2}"/>
               </a:ext>
             </a:extLst>
           </p:cNvPr>
@@ -8501,7 +8501,7 @@
           <p:cNvPr id="3" name="text">
             <a:extLst xmlns:a="http://schemas.openxmlformats.org/drawingml/2006/main">
               <a:ext uri="{FF2B5EF4-FFF2-40B4-BE49-F238E27FC236}">
-                <a16:creationId xmlns:a16="http://schemas.microsoft.com/office/drawing/2014/main" id="{E8D14805-7A9C-4D66-A083-EEEEE11FBFBE}"/>
+                <a16:creationId xmlns:a16="http://schemas.microsoft.com/office/drawing/2014/main" id="{28B4DFC4-716C-42AD-8910-DBAEFF8A4220}"/>
               </a:ext>
             </a:extLst>
           </p:cNvPr>
@@ -8558,7 +8558,7 @@
           <p:cNvPr id="4" name="text">
             <a:extLst xmlns:a="http://schemas.openxmlformats.org/drawingml/2006/main">
               <a:ext uri="{FF2B5EF4-FFF2-40B4-BE49-F238E27FC236}">
-                <a16:creationId xmlns:a16="http://schemas.microsoft.com/office/drawing/2014/main" id="{A21B4BFC-4DA0-47D5-952E-AB044E79443E}"/>
+                <a16:creationId xmlns:a16="http://schemas.microsoft.com/office/drawing/2014/main" id="{085E9C07-BD89-435B-B8F1-FB2B66ECDF32}"/>
               </a:ext>
             </a:extLst>
           </p:cNvPr>
@@ -8615,7 +8615,7 @@
           <p:cNvPr id="5" name="text">
             <a:extLst xmlns:a="http://schemas.openxmlformats.org/drawingml/2006/main">
               <a:ext uri="{FF2B5EF4-FFF2-40B4-BE49-F238E27FC236}">
-                <a16:creationId xmlns:a16="http://schemas.microsoft.com/office/drawing/2014/main" id="{F66A3D2C-FD8D-4276-957F-B2295210B5BA}"/>
+                <a16:creationId xmlns:a16="http://schemas.microsoft.com/office/drawing/2014/main" id="{75E6F025-319C-484A-9753-F7EF769106BB}"/>
               </a:ext>
             </a:extLst>
           </p:cNvPr>
@@ -8672,7 +8672,7 @@
           <p:cNvPr id="6" name="text">
             <a:extLst xmlns:a="http://schemas.openxmlformats.org/drawingml/2006/main">
               <a:ext uri="{FF2B5EF4-FFF2-40B4-BE49-F238E27FC236}">
-                <a16:creationId xmlns:a16="http://schemas.microsoft.com/office/drawing/2014/main" id="{BD3CB337-D4FD-4B92-8A90-69FCEDC84E0E}"/>
+                <a16:creationId xmlns:a16="http://schemas.microsoft.com/office/drawing/2014/main" id="{07F79375-E75E-417A-B95F-F75A96AB1080}"/>
               </a:ext>
             </a:extLst>
           </p:cNvPr>
@@ -8729,7 +8729,7 @@
           <p:cNvPr id="7" name="text">
             <a:extLst xmlns:a="http://schemas.openxmlformats.org/drawingml/2006/main">
               <a:ext uri="{FF2B5EF4-FFF2-40B4-BE49-F238E27FC236}">
-                <a16:creationId xmlns:a16="http://schemas.microsoft.com/office/drawing/2014/main" id="{CA7B2B48-89D7-4AAC-B9D3-CD5A0BBDCDC3}"/>
+                <a16:creationId xmlns:a16="http://schemas.microsoft.com/office/drawing/2014/main" id="{F9F2E132-633A-4758-BAC4-98887F5E9A40}"/>
               </a:ext>
             </a:extLst>
           </p:cNvPr>
@@ -8784,7 +8784,7 @@
     </p:spTree>
     <p:extLst>
       <p:ext uri="{BB962C8B-B14F-4D97-AF65-F5344CB8AC3E}">
-        <p14:creationId xmlns:p14="http://schemas.microsoft.com/office/powerpoint/2010/main" val="1163040914"/>
+        <p14:creationId xmlns:p14="http://schemas.microsoft.com/office/powerpoint/2010/main" val="1237785627"/>
       </p:ext>
     </p:extLst>
   </p:cSld>
@@ -8826,7 +8826,7 @@
           <p:cNvPr id="6" name="text">
             <a:extLst xmlns:a="http://schemas.openxmlformats.org/drawingml/2006/main">
               <a:ext uri="{FF2B5EF4-FFF2-40B4-BE49-F238E27FC236}">
-                <a16:creationId xmlns:a16="http://schemas.microsoft.com/office/drawing/2014/main" id="{95FBB3EB-FBE5-4ABF-9C16-CF7DD0CE8E1D}"/>
+                <a16:creationId xmlns:a16="http://schemas.microsoft.com/office/drawing/2014/main" id="{3188B38B-6C3D-4916-B107-3913E7D1B737}"/>
               </a:ext>
             </a:extLst>
           </p:cNvPr>
@@ -8883,7 +8883,7 @@
           <p:cNvPr id="2" name="text">
             <a:extLst xmlns:a="http://schemas.openxmlformats.org/drawingml/2006/main">
               <a:ext uri="{FF2B5EF4-FFF2-40B4-BE49-F238E27FC236}">
-                <a16:creationId xmlns:a16="http://schemas.microsoft.com/office/drawing/2014/main" id="{2B846E4C-6227-49CA-96F1-19230F03E4AD}"/>
+                <a16:creationId xmlns:a16="http://schemas.microsoft.com/office/drawing/2014/main" id="{4ED38896-2BAA-49AE-93EF-AEFBD1B58BE5}"/>
               </a:ext>
             </a:extLst>
           </p:cNvPr>
@@ -8940,7 +8940,7 @@
           <p:cNvPr id="3" name="text">
             <a:extLst xmlns:a="http://schemas.openxmlformats.org/drawingml/2006/main">
               <a:ext uri="{FF2B5EF4-FFF2-40B4-BE49-F238E27FC236}">
-                <a16:creationId xmlns:a16="http://schemas.microsoft.com/office/drawing/2014/main" id="{8A9C92AD-4E4D-4A73-BE5F-C2F824CAFE27}"/>
+                <a16:creationId xmlns:a16="http://schemas.microsoft.com/office/drawing/2014/main" id="{DA164301-564F-417C-96EE-5ECFFFA808AB}"/>
               </a:ext>
             </a:extLst>
           </p:cNvPr>
@@ -8997,7 +8997,7 @@
           <p:cNvPr id="4" name="text">
             <a:extLst xmlns:a="http://schemas.openxmlformats.org/drawingml/2006/main">
               <a:ext uri="{FF2B5EF4-FFF2-40B4-BE49-F238E27FC236}">
-                <a16:creationId xmlns:a16="http://schemas.microsoft.com/office/drawing/2014/main" id="{F8B6B159-879E-4428-A0E8-7AD66BD75AE7}"/>
+                <a16:creationId xmlns:a16="http://schemas.microsoft.com/office/drawing/2014/main" id="{7EE5FBD7-DF62-4164-9677-D96E5D38A58F}"/>
               </a:ext>
             </a:extLst>
           </p:cNvPr>
@@ -9054,7 +9054,7 @@
           <p:cNvPr id="5" name="text">
             <a:extLst xmlns:a="http://schemas.openxmlformats.org/drawingml/2006/main">
               <a:ext uri="{FF2B5EF4-FFF2-40B4-BE49-F238E27FC236}">
-                <a16:creationId xmlns:a16="http://schemas.microsoft.com/office/drawing/2014/main" id="{0936A50B-1FB0-4942-9C3B-6DCCF0955AA4}"/>
+                <a16:creationId xmlns:a16="http://schemas.microsoft.com/office/drawing/2014/main" id="{B9D824A6-EB86-4F32-8A86-9426ECB67DF2}"/>
               </a:ext>
             </a:extLst>
           </p:cNvPr>
@@ -9109,7 +9109,7 @@
     </p:spTree>
     <p:extLst>
       <p:ext uri="{BB962C8B-B14F-4D97-AF65-F5344CB8AC3E}">
-        <p14:creationId xmlns:p14="http://schemas.microsoft.com/office/powerpoint/2010/main" val="2061896503"/>
+        <p14:creationId xmlns:p14="http://schemas.microsoft.com/office/powerpoint/2010/main" val="1961690069"/>
       </p:ext>
     </p:extLst>
   </p:cSld>
@@ -9151,7 +9151,7 @@
           <p:cNvPr id="8" name="text">
             <a:extLst xmlns:a="http://schemas.openxmlformats.org/drawingml/2006/main">
               <a:ext uri="{FF2B5EF4-FFF2-40B4-BE49-F238E27FC236}">
-                <a16:creationId xmlns:a16="http://schemas.microsoft.com/office/drawing/2014/main" id="{8B55F11D-53C0-4AC4-AEFC-B02FE6605E1E}"/>
+                <a16:creationId xmlns:a16="http://schemas.microsoft.com/office/drawing/2014/main" id="{1661B638-61AD-4B8B-AF52-C9F8340FC08D}"/>
               </a:ext>
             </a:extLst>
           </p:cNvPr>
@@ -9208,7 +9208,7 @@
           <p:cNvPr id="2" name="text">
             <a:extLst xmlns:a="http://schemas.openxmlformats.org/drawingml/2006/main">
               <a:ext uri="{FF2B5EF4-FFF2-40B4-BE49-F238E27FC236}">
-                <a16:creationId xmlns:a16="http://schemas.microsoft.com/office/drawing/2014/main" id="{C1767F8D-ED8B-4A7E-B380-0B4FF2015715}"/>
+                <a16:creationId xmlns:a16="http://schemas.microsoft.com/office/drawing/2014/main" id="{4832AA4C-7C89-488C-824A-0607B5BC7188}"/>
               </a:ext>
             </a:extLst>
           </p:cNvPr>
@@ -9265,7 +9265,7 @@
           <p:cNvPr id="3" name="text">
             <a:extLst xmlns:a="http://schemas.openxmlformats.org/drawingml/2006/main">
               <a:ext uri="{FF2B5EF4-FFF2-40B4-BE49-F238E27FC236}">
-                <a16:creationId xmlns:a16="http://schemas.microsoft.com/office/drawing/2014/main" id="{D9AB90D0-7A34-4BCA-83E0-C31BFA92E8AC}"/>
+                <a16:creationId xmlns:a16="http://schemas.microsoft.com/office/drawing/2014/main" id="{0E342B34-5C37-48EB-8215-25785B28C643}"/>
               </a:ext>
             </a:extLst>
           </p:cNvPr>
@@ -9322,7 +9322,7 @@
           <p:cNvPr id="4" name="text">
             <a:extLst xmlns:a="http://schemas.openxmlformats.org/drawingml/2006/main">
               <a:ext uri="{FF2B5EF4-FFF2-40B4-BE49-F238E27FC236}">
-                <a16:creationId xmlns:a16="http://schemas.microsoft.com/office/drawing/2014/main" id="{1815F9F4-04E0-4987-88B8-98422C8CA779}"/>
+                <a16:creationId xmlns:a16="http://schemas.microsoft.com/office/drawing/2014/main" id="{559738FB-6364-4603-A5D8-D40A2261490F}"/>
               </a:ext>
             </a:extLst>
           </p:cNvPr>
@@ -9379,7 +9379,7 @@
           <p:cNvPr id="5" name="text">
             <a:extLst xmlns:a="http://schemas.openxmlformats.org/drawingml/2006/main">
               <a:ext uri="{FF2B5EF4-FFF2-40B4-BE49-F238E27FC236}">
-                <a16:creationId xmlns:a16="http://schemas.microsoft.com/office/drawing/2014/main" id="{4E8CB343-9A7A-4FCE-AE38-9766074A7347}"/>
+                <a16:creationId xmlns:a16="http://schemas.microsoft.com/office/drawing/2014/main" id="{AA95025D-942E-4E53-9064-7D2B08F27F0E}"/>
               </a:ext>
             </a:extLst>
           </p:cNvPr>
@@ -9436,7 +9436,7 @@
           <p:cNvPr id="6" name="text">
             <a:extLst xmlns:a="http://schemas.openxmlformats.org/drawingml/2006/main">
               <a:ext uri="{FF2B5EF4-FFF2-40B4-BE49-F238E27FC236}">
-                <a16:creationId xmlns:a16="http://schemas.microsoft.com/office/drawing/2014/main" id="{36D8FEF8-64CE-423A-B049-F76192EAD43A}"/>
+                <a16:creationId xmlns:a16="http://schemas.microsoft.com/office/drawing/2014/main" id="{D092A954-FE86-489F-A03F-E2AEF20DE1B6}"/>
               </a:ext>
             </a:extLst>
           </p:cNvPr>
@@ -9493,7 +9493,7 @@
           <p:cNvPr id="7" name="text">
             <a:extLst xmlns:a="http://schemas.openxmlformats.org/drawingml/2006/main">
               <a:ext uri="{FF2B5EF4-FFF2-40B4-BE49-F238E27FC236}">
-                <a16:creationId xmlns:a16="http://schemas.microsoft.com/office/drawing/2014/main" id="{12D67C87-6603-4144-8D4A-32EE1FE077AB}"/>
+                <a16:creationId xmlns:a16="http://schemas.microsoft.com/office/drawing/2014/main" id="{6076E6EE-C374-43A3-96F0-78D9DDDACDA5}"/>
               </a:ext>
             </a:extLst>
           </p:cNvPr>
@@ -9548,7 +9548,7 @@
     </p:spTree>
     <p:extLst>
       <p:ext uri="{BB962C8B-B14F-4D97-AF65-F5344CB8AC3E}">
-        <p14:creationId xmlns:p14="http://schemas.microsoft.com/office/powerpoint/2010/main" val="1225339475"/>
+        <p14:creationId xmlns:p14="http://schemas.microsoft.com/office/powerpoint/2010/main" val="190541575"/>
       </p:ext>
     </p:extLst>
   </p:cSld>
@@ -9590,7 +9590,7 @@
           <p:cNvPr id="6" name="text">
             <a:extLst xmlns:a="http://schemas.openxmlformats.org/drawingml/2006/main">
               <a:ext uri="{FF2B5EF4-FFF2-40B4-BE49-F238E27FC236}">
-                <a16:creationId xmlns:a16="http://schemas.microsoft.com/office/drawing/2014/main" id="{8EB875B4-B6A8-432B-8D45-F3AF56BFC22B}"/>
+                <a16:creationId xmlns:a16="http://schemas.microsoft.com/office/drawing/2014/main" id="{E3100114-217C-4CAC-95D7-AE4FC67F3231}"/>
               </a:ext>
             </a:extLst>
           </p:cNvPr>
@@ -9647,7 +9647,7 @@
           <p:cNvPr id="2" name="text">
             <a:extLst xmlns:a="http://schemas.openxmlformats.org/drawingml/2006/main">
               <a:ext uri="{FF2B5EF4-FFF2-40B4-BE49-F238E27FC236}">
-                <a16:creationId xmlns:a16="http://schemas.microsoft.com/office/drawing/2014/main" id="{38145C14-7D2E-4F46-BAF3-B251F6AD48A7}"/>
+                <a16:creationId xmlns:a16="http://schemas.microsoft.com/office/drawing/2014/main" id="{A2412498-C753-4AD8-A923-332E28A7659E}"/>
               </a:ext>
             </a:extLst>
           </p:cNvPr>
@@ -9704,7 +9704,7 @@
           <p:cNvPr id="3" name="text">
             <a:extLst xmlns:a="http://schemas.openxmlformats.org/drawingml/2006/main">
               <a:ext uri="{FF2B5EF4-FFF2-40B4-BE49-F238E27FC236}">
-                <a16:creationId xmlns:a16="http://schemas.microsoft.com/office/drawing/2014/main" id="{9BAA9239-E226-4511-A152-778181E2CF87}"/>
+                <a16:creationId xmlns:a16="http://schemas.microsoft.com/office/drawing/2014/main" id="{AFFCEA24-CDB4-477D-A244-6B7349422FA4}"/>
               </a:ext>
             </a:extLst>
           </p:cNvPr>
@@ -9761,7 +9761,7 @@
           <p:cNvPr id="4" name="text">
             <a:extLst xmlns:a="http://schemas.openxmlformats.org/drawingml/2006/main">
               <a:ext uri="{FF2B5EF4-FFF2-40B4-BE49-F238E27FC236}">
-                <a16:creationId xmlns:a16="http://schemas.microsoft.com/office/drawing/2014/main" id="{A78DFA2A-A1A7-4C47-8A4B-F595EF7C42D7}"/>
+                <a16:creationId xmlns:a16="http://schemas.microsoft.com/office/drawing/2014/main" id="{8BBA3CA6-B44D-4639-9E3C-7EF54EAB9C11}"/>
               </a:ext>
             </a:extLst>
           </p:cNvPr>
@@ -9818,7 +9818,7 @@
           <p:cNvPr id="5" name="text">
             <a:extLst xmlns:a="http://schemas.openxmlformats.org/drawingml/2006/main">
               <a:ext uri="{FF2B5EF4-FFF2-40B4-BE49-F238E27FC236}">
-                <a16:creationId xmlns:a16="http://schemas.microsoft.com/office/drawing/2014/main" id="{905F5B04-A448-456D-A9F9-C55FCE5F3458}"/>
+                <a16:creationId xmlns:a16="http://schemas.microsoft.com/office/drawing/2014/main" id="{B3448E1A-E38D-462F-82DE-C491BB30D40B}"/>
               </a:ext>
             </a:extLst>
           </p:cNvPr>
@@ -9873,7 +9873,7 @@
     </p:spTree>
     <p:extLst>
       <p:ext uri="{BB962C8B-B14F-4D97-AF65-F5344CB8AC3E}">
-        <p14:creationId xmlns:p14="http://schemas.microsoft.com/office/powerpoint/2010/main" val="379460938"/>
+        <p14:creationId xmlns:p14="http://schemas.microsoft.com/office/powerpoint/2010/main" val="652496050"/>
       </p:ext>
     </p:extLst>
   </p:cSld>
@@ -9915,7 +9915,7 @@
           <p:cNvPr id="8" name="text">
             <a:extLst xmlns:a="http://schemas.openxmlformats.org/drawingml/2006/main">
               <a:ext uri="{FF2B5EF4-FFF2-40B4-BE49-F238E27FC236}">
-                <a16:creationId xmlns:a16="http://schemas.microsoft.com/office/drawing/2014/main" id="{8BCEBB50-E8F5-4A1F-BB8C-30CBA2C69A64}"/>
+                <a16:creationId xmlns:a16="http://schemas.microsoft.com/office/drawing/2014/main" id="{7921DFF0-25BB-426D-97E7-944ACCABAA9C}"/>
               </a:ext>
             </a:extLst>
           </p:cNvPr>
@@ -9972,7 +9972,7 @@
           <p:cNvPr id="2" name="text">
             <a:extLst xmlns:a="http://schemas.openxmlformats.org/drawingml/2006/main">
               <a:ext uri="{FF2B5EF4-FFF2-40B4-BE49-F238E27FC236}">
-                <a16:creationId xmlns:a16="http://schemas.microsoft.com/office/drawing/2014/main" id="{BB481017-00B4-467F-9DD1-F7EA2F609FC0}"/>
+                <a16:creationId xmlns:a16="http://schemas.microsoft.com/office/drawing/2014/main" id="{3C64AB49-00D6-49F2-BB5B-D095CD39E809}"/>
               </a:ext>
             </a:extLst>
           </p:cNvPr>
@@ -10029,7 +10029,7 @@
           <p:cNvPr id="3" name="text">
             <a:extLst xmlns:a="http://schemas.openxmlformats.org/drawingml/2006/main">
               <a:ext uri="{FF2B5EF4-FFF2-40B4-BE49-F238E27FC236}">
-                <a16:creationId xmlns:a16="http://schemas.microsoft.com/office/drawing/2014/main" id="{606DF08B-771F-4230-B8B4-993870D7EE7E}"/>
+                <a16:creationId xmlns:a16="http://schemas.microsoft.com/office/drawing/2014/main" id="{123B5BF5-C0C0-41BC-971E-6F5B3F299E94}"/>
               </a:ext>
             </a:extLst>
           </p:cNvPr>
@@ -10086,7 +10086,7 @@
           <p:cNvPr id="4" name="text">
             <a:extLst xmlns:a="http://schemas.openxmlformats.org/drawingml/2006/main">
               <a:ext uri="{FF2B5EF4-FFF2-40B4-BE49-F238E27FC236}">
-                <a16:creationId xmlns:a16="http://schemas.microsoft.com/office/drawing/2014/main" id="{EC417D64-FE20-4914-8B0E-59DDAD21E94B}"/>
+                <a16:creationId xmlns:a16="http://schemas.microsoft.com/office/drawing/2014/main" id="{55F590EC-7727-47E0-80B7-17A54C94AA91}"/>
               </a:ext>
             </a:extLst>
           </p:cNvPr>
@@ -10143,7 +10143,7 @@
           <p:cNvPr id="5" name="text">
             <a:extLst xmlns:a="http://schemas.openxmlformats.org/drawingml/2006/main">
               <a:ext uri="{FF2B5EF4-FFF2-40B4-BE49-F238E27FC236}">
-                <a16:creationId xmlns:a16="http://schemas.microsoft.com/office/drawing/2014/main" id="{F2E1187A-3B16-4915-B589-D72C5CA073E8}"/>
+                <a16:creationId xmlns:a16="http://schemas.microsoft.com/office/drawing/2014/main" id="{926F3A2A-3480-44A2-BD64-6BE91C9D81DD}"/>
               </a:ext>
             </a:extLst>
           </p:cNvPr>
@@ -10200,7 +10200,7 @@
           <p:cNvPr id="6" name="text">
             <a:extLst xmlns:a="http://schemas.openxmlformats.org/drawingml/2006/main">
               <a:ext uri="{FF2B5EF4-FFF2-40B4-BE49-F238E27FC236}">
-                <a16:creationId xmlns:a16="http://schemas.microsoft.com/office/drawing/2014/main" id="{E8E6F20B-B159-4E24-809F-46C1F74F2004}"/>
+                <a16:creationId xmlns:a16="http://schemas.microsoft.com/office/drawing/2014/main" id="{58C87BFD-8912-4D37-BD64-E6CA6D61A96D}"/>
               </a:ext>
             </a:extLst>
           </p:cNvPr>
@@ -10257,7 +10257,7 @@
           <p:cNvPr id="7" name="text">
             <a:extLst xmlns:a="http://schemas.openxmlformats.org/drawingml/2006/main">
               <a:ext uri="{FF2B5EF4-FFF2-40B4-BE49-F238E27FC236}">
-                <a16:creationId xmlns:a16="http://schemas.microsoft.com/office/drawing/2014/main" id="{8E60FDDC-018A-448B-AFF8-660F5525A488}"/>
+                <a16:creationId xmlns:a16="http://schemas.microsoft.com/office/drawing/2014/main" id="{9B16ED38-3F12-4952-A4BC-010502C06CE4}"/>
               </a:ext>
             </a:extLst>
           </p:cNvPr>
@@ -10312,7 +10312,7 @@
     </p:spTree>
     <p:extLst>
       <p:ext uri="{BB962C8B-B14F-4D97-AF65-F5344CB8AC3E}">
-        <p14:creationId xmlns:p14="http://schemas.microsoft.com/office/powerpoint/2010/main" val="317324442"/>
+        <p14:creationId xmlns:p14="http://schemas.microsoft.com/office/powerpoint/2010/main" val="1191240660"/>
       </p:ext>
     </p:extLst>
   </p:cSld>
@@ -10354,7 +10354,7 @@
           <p:cNvPr id="7" name="text">
             <a:extLst xmlns:a="http://schemas.openxmlformats.org/drawingml/2006/main">
               <a:ext uri="{FF2B5EF4-FFF2-40B4-BE49-F238E27FC236}">
-                <a16:creationId xmlns:a16="http://schemas.microsoft.com/office/drawing/2014/main" id="{C670D57A-E0A5-480C-A7C7-E3955444821F}"/>
+                <a16:creationId xmlns:a16="http://schemas.microsoft.com/office/drawing/2014/main" id="{A3ABEE82-10E6-4955-8651-6AFF461359B6}"/>
               </a:ext>
             </a:extLst>
           </p:cNvPr>
@@ -10411,7 +10411,7 @@
           <p:cNvPr id="2" name="text">
             <a:extLst xmlns:a="http://schemas.openxmlformats.org/drawingml/2006/main">
               <a:ext uri="{FF2B5EF4-FFF2-40B4-BE49-F238E27FC236}">
-                <a16:creationId xmlns:a16="http://schemas.microsoft.com/office/drawing/2014/main" id="{521FFB42-E24C-4A4B-A525-91905F8B0AC9}"/>
+                <a16:creationId xmlns:a16="http://schemas.microsoft.com/office/drawing/2014/main" id="{7B760254-2123-4995-A16D-E140155AF99F}"/>
               </a:ext>
             </a:extLst>
           </p:cNvPr>
@@ -10439,26 +10439,26 @@
           </a:bodyPr>
           <a:lstStyle xmlns:a="http://schemas.openxmlformats.org/drawingml/2006/main"/>
           <a:p xmlns:a="http://schemas.openxmlformats.org/drawingml/2006/main">
-            <a:pPr algn="ctr">
-              <a:defRPr sz="6750" b="1">
+            <a:pPr algn="ctr" rtl="1">
+              <a:defRPr sz="4800" b="1" lang="he-IL">
                 <a:solidFill>
                   <a:srgbClr val="DFFF5B"/>
                 </a:solidFill>
-                <a:latin typeface="Nunito"/>
-                <a:ea typeface="Nunito"/>
-                <a:cs typeface="Nunito"/>
-              </a:defRPr>
-            </a:pPr>
-            <a:r>
-              <a:rPr sz="6750" b="1">
+                <a:latin typeface="Heebo"/>
+                <a:ea typeface="Heebo"/>
+                <a:cs typeface="Heebo"/>
+              </a:defRPr>
+            </a:pPr>
+            <a:r>
+              <a:rPr sz="4800" b="1" lang="he-IL">
                 <a:solidFill>
                   <a:srgbClr val="DFFF5B"/>
                 </a:solidFill>
-                <a:latin typeface="Nunito"/>
-                <a:ea typeface="Nunito"/>
-                <a:cs typeface="Nunito"/>
-              </a:rPr>
-              <a:t>8 October 2026</a:t>
+                <a:latin typeface="Heebo"/>
+                <a:ea typeface="Heebo"/>
+                <a:cs typeface="Heebo"/>
+              </a:rPr>
+              <a:t>המבחן הראשון באנגלית</a:t>
             </a:r>
           </a:p>
         </p:txBody>
@@ -10468,7 +10468,7 @@
           <p:cNvPr id="3" name="text">
             <a:extLst xmlns:a="http://schemas.openxmlformats.org/drawingml/2006/main">
               <a:ext uri="{FF2B5EF4-FFF2-40B4-BE49-F238E27FC236}">
-                <a16:creationId xmlns:a16="http://schemas.microsoft.com/office/drawing/2014/main" id="{D2DD09E4-9B43-4486-AF4C-0D2DA587F40B}"/>
+                <a16:creationId xmlns:a16="http://schemas.microsoft.com/office/drawing/2014/main" id="{B7A53B7F-7A27-4701-80FF-FE9B97881EA1}"/>
               </a:ext>
             </a:extLst>
           </p:cNvPr>
@@ -10515,7 +10515,7 @@
                 <a:ea typeface="Heebo"/>
                 <a:cs typeface="Heebo"/>
               </a:rPr>
-              <a:t>המבחן הראשון באנגלית</a:t>
+              <a:t>יום חמישי, כ״ז בתשרי תשפ״ז</a:t>
             </a:r>
           </a:p>
         </p:txBody>
@@ -10525,7 +10525,7 @@
           <p:cNvPr id="4" name="text">
             <a:extLst xmlns:a="http://schemas.openxmlformats.org/drawingml/2006/main">
               <a:ext uri="{FF2B5EF4-FFF2-40B4-BE49-F238E27FC236}">
-                <a16:creationId xmlns:a16="http://schemas.microsoft.com/office/drawing/2014/main" id="{F84CAECF-C959-4FED-827B-2307C1689938}"/>
+                <a16:creationId xmlns:a16="http://schemas.microsoft.com/office/drawing/2014/main" id="{643FDDE7-64D3-4C6E-87A1-FEC136933B38}"/>
               </a:ext>
             </a:extLst>
           </p:cNvPr>
@@ -10553,26 +10553,26 @@
           </a:bodyPr>
           <a:lstStyle xmlns:a="http://schemas.openxmlformats.org/drawingml/2006/main"/>
           <a:p xmlns:a="http://schemas.openxmlformats.org/drawingml/2006/main">
-            <a:pPr algn="ctr" rtl="1">
-              <a:defRPr sz="2625" b="1" lang="he-IL">
+            <a:pPr algn="ctr">
+              <a:defRPr sz="2625" b="1">
                 <a:solidFill>
                   <a:srgbClr val="4EE5FF"/>
                 </a:solidFill>
-                <a:latin typeface="Heebo"/>
-                <a:ea typeface="Heebo"/>
-                <a:cs typeface="Heebo"/>
-              </a:defRPr>
-            </a:pPr>
-            <a:r>
-              <a:rPr sz="2625" b="1" lang="he-IL">
+                <a:latin typeface="Nunito"/>
+                <a:ea typeface="Nunito"/>
+                <a:cs typeface="Nunito"/>
+              </a:defRPr>
+            </a:pPr>
+            <a:r>
+              <a:rPr sz="2625" b="1">
                 <a:solidFill>
                   <a:srgbClr val="4EE5FF"/>
                 </a:solidFill>
-                <a:latin typeface="Heebo"/>
-                <a:ea typeface="Heebo"/>
-                <a:cs typeface="Heebo"/>
-              </a:rPr>
-              <a:t>יום חמישי, 8.10.2026</a:t>
+                <a:latin typeface="Nunito"/>
+                <a:ea typeface="Nunito"/>
+                <a:cs typeface="Nunito"/>
+              </a:rPr>
+              <a:t>(8.10.2026)</a:t>
             </a:r>
           </a:p>
         </p:txBody>
@@ -10582,7 +10582,7 @@
           <p:cNvPr id="5" name="text">
             <a:extLst xmlns:a="http://schemas.openxmlformats.org/drawingml/2006/main">
               <a:ext uri="{FF2B5EF4-FFF2-40B4-BE49-F238E27FC236}">
-                <a16:creationId xmlns:a16="http://schemas.microsoft.com/office/drawing/2014/main" id="{D1B4A6F4-AC04-41CC-9CD7-6FD2D18131EE}"/>
+                <a16:creationId xmlns:a16="http://schemas.microsoft.com/office/drawing/2014/main" id="{56C671C5-0D77-4C66-BA23-A718FBF62D75}"/>
               </a:ext>
             </a:extLst>
           </p:cNvPr>
@@ -10639,7 +10639,7 @@
           <p:cNvPr id="6" name="text">
             <a:extLst xmlns:a="http://schemas.openxmlformats.org/drawingml/2006/main">
               <a:ext uri="{FF2B5EF4-FFF2-40B4-BE49-F238E27FC236}">
-                <a16:creationId xmlns:a16="http://schemas.microsoft.com/office/drawing/2014/main" id="{D321232D-E7D5-4374-BDA4-15EC9548D7C8}"/>
+                <a16:creationId xmlns:a16="http://schemas.microsoft.com/office/drawing/2014/main" id="{FFEA96DA-2DC5-4CD6-B4F8-6EB2E6AE78ED}"/>
               </a:ext>
             </a:extLst>
           </p:cNvPr>
@@ -10694,7 +10694,7 @@
     </p:spTree>
     <p:extLst>
       <p:ext uri="{BB962C8B-B14F-4D97-AF65-F5344CB8AC3E}">
-        <p14:creationId xmlns:p14="http://schemas.microsoft.com/office/powerpoint/2010/main" val="1138727912"/>
+        <p14:creationId xmlns:p14="http://schemas.microsoft.com/office/powerpoint/2010/main" val="545157299"/>
       </p:ext>
     </p:extLst>
   </p:cSld>
@@ -10736,7 +10736,7 @@
           <p:cNvPr id="6" name="text">
             <a:extLst xmlns:a="http://schemas.openxmlformats.org/drawingml/2006/main">
               <a:ext uri="{FF2B5EF4-FFF2-40B4-BE49-F238E27FC236}">
-                <a16:creationId xmlns:a16="http://schemas.microsoft.com/office/drawing/2014/main" id="{27AE0A48-28C2-4333-8A8E-F67B13FC2704}"/>
+                <a16:creationId xmlns:a16="http://schemas.microsoft.com/office/drawing/2014/main" id="{6E17D930-F971-4BEA-A59E-89DE0C5EB921}"/>
               </a:ext>
             </a:extLst>
           </p:cNvPr>
@@ -10793,7 +10793,7 @@
           <p:cNvPr id="2" name="text">
             <a:extLst xmlns:a="http://schemas.openxmlformats.org/drawingml/2006/main">
               <a:ext uri="{FF2B5EF4-FFF2-40B4-BE49-F238E27FC236}">
-                <a16:creationId xmlns:a16="http://schemas.microsoft.com/office/drawing/2014/main" id="{5FCED30A-440C-45DA-BC16-446AE78D17E9}"/>
+                <a16:creationId xmlns:a16="http://schemas.microsoft.com/office/drawing/2014/main" id="{0F6D5FEC-DB4F-410E-A7DA-07E2359F64A4}"/>
               </a:ext>
             </a:extLst>
           </p:cNvPr>
@@ -10850,7 +10850,7 @@
           <p:cNvPr id="3" name="text">
             <a:extLst xmlns:a="http://schemas.openxmlformats.org/drawingml/2006/main">
               <a:ext uri="{FF2B5EF4-FFF2-40B4-BE49-F238E27FC236}">
-                <a16:creationId xmlns:a16="http://schemas.microsoft.com/office/drawing/2014/main" id="{8D6D30D7-A959-4945-9D3D-FB3CD7E4AC4E}"/>
+                <a16:creationId xmlns:a16="http://schemas.microsoft.com/office/drawing/2014/main" id="{F8A58AF1-62AC-4487-AC76-59C38917D75B}"/>
               </a:ext>
             </a:extLst>
           </p:cNvPr>
@@ -10907,7 +10907,7 @@
           <p:cNvPr id="4" name="text">
             <a:extLst xmlns:a="http://schemas.openxmlformats.org/drawingml/2006/main">
               <a:ext uri="{FF2B5EF4-FFF2-40B4-BE49-F238E27FC236}">
-                <a16:creationId xmlns:a16="http://schemas.microsoft.com/office/drawing/2014/main" id="{F9217135-663A-44F2-9D1D-95CDD2A60B2B}"/>
+                <a16:creationId xmlns:a16="http://schemas.microsoft.com/office/drawing/2014/main" id="{9A1BDA63-2FC8-4830-9030-71FB8525BF01}"/>
               </a:ext>
             </a:extLst>
           </p:cNvPr>
@@ -10964,7 +10964,7 @@
           <p:cNvPr id="5" name="text">
             <a:extLst xmlns:a="http://schemas.openxmlformats.org/drawingml/2006/main">
               <a:ext uri="{FF2B5EF4-FFF2-40B4-BE49-F238E27FC236}">
-                <a16:creationId xmlns:a16="http://schemas.microsoft.com/office/drawing/2014/main" id="{8CCC90DF-C846-47B8-8B21-28F70BC99B61}"/>
+                <a16:creationId xmlns:a16="http://schemas.microsoft.com/office/drawing/2014/main" id="{155D2076-BFC7-43A2-9A83-508C033C2063}"/>
               </a:ext>
             </a:extLst>
           </p:cNvPr>
@@ -11019,7 +11019,7 @@
     </p:spTree>
     <p:extLst>
       <p:ext uri="{BB962C8B-B14F-4D97-AF65-F5344CB8AC3E}">
-        <p14:creationId xmlns:p14="http://schemas.microsoft.com/office/powerpoint/2010/main" val="339543584"/>
+        <p14:creationId xmlns:p14="http://schemas.microsoft.com/office/powerpoint/2010/main" val="330468324"/>
       </p:ext>
     </p:extLst>
   </p:cSld>
@@ -11061,7 +11061,7 @@
           <p:cNvPr id="8" name="text">
             <a:extLst xmlns:a="http://schemas.openxmlformats.org/drawingml/2006/main">
               <a:ext uri="{FF2B5EF4-FFF2-40B4-BE49-F238E27FC236}">
-                <a16:creationId xmlns:a16="http://schemas.microsoft.com/office/drawing/2014/main" id="{F28EC816-395C-4A81-9E17-352F03F6E071}"/>
+                <a16:creationId xmlns:a16="http://schemas.microsoft.com/office/drawing/2014/main" id="{A834BC0C-BC95-4F65-9F1F-42FD1E27A961}"/>
               </a:ext>
             </a:extLst>
           </p:cNvPr>
@@ -11118,7 +11118,7 @@
           <p:cNvPr id="2" name="text">
             <a:extLst xmlns:a="http://schemas.openxmlformats.org/drawingml/2006/main">
               <a:ext uri="{FF2B5EF4-FFF2-40B4-BE49-F238E27FC236}">
-                <a16:creationId xmlns:a16="http://schemas.microsoft.com/office/drawing/2014/main" id="{02B71497-01B7-42F3-936E-0F0B3A735330}"/>
+                <a16:creationId xmlns:a16="http://schemas.microsoft.com/office/drawing/2014/main" id="{CCAA9FC5-57E9-4F43-B2B2-80B6F825C124}"/>
               </a:ext>
             </a:extLst>
           </p:cNvPr>
@@ -11175,7 +11175,7 @@
           <p:cNvPr id="3" name="text">
             <a:extLst xmlns:a="http://schemas.openxmlformats.org/drawingml/2006/main">
               <a:ext uri="{FF2B5EF4-FFF2-40B4-BE49-F238E27FC236}">
-                <a16:creationId xmlns:a16="http://schemas.microsoft.com/office/drawing/2014/main" id="{6065F251-6CB4-431A-8E5A-2F8021125711}"/>
+                <a16:creationId xmlns:a16="http://schemas.microsoft.com/office/drawing/2014/main" id="{339AA110-5199-4A73-9237-2ADB42A4A16A}"/>
               </a:ext>
             </a:extLst>
           </p:cNvPr>
@@ -11232,7 +11232,7 @@
           <p:cNvPr id="4" name="text">
             <a:extLst xmlns:a="http://schemas.openxmlformats.org/drawingml/2006/main">
               <a:ext uri="{FF2B5EF4-FFF2-40B4-BE49-F238E27FC236}">
-                <a16:creationId xmlns:a16="http://schemas.microsoft.com/office/drawing/2014/main" id="{9B6D8F38-2602-477D-9168-0625E5780111}"/>
+                <a16:creationId xmlns:a16="http://schemas.microsoft.com/office/drawing/2014/main" id="{53083CAF-DEE7-40C7-9AF8-169C4BA8B6C0}"/>
               </a:ext>
             </a:extLst>
           </p:cNvPr>
@@ -11289,7 +11289,7 @@
           <p:cNvPr id="5" name="text">
             <a:extLst xmlns:a="http://schemas.openxmlformats.org/drawingml/2006/main">
               <a:ext uri="{FF2B5EF4-FFF2-40B4-BE49-F238E27FC236}">
-                <a16:creationId xmlns:a16="http://schemas.microsoft.com/office/drawing/2014/main" id="{F9C7A9C8-7E41-4A69-89AB-FB10FFFEAE34}"/>
+                <a16:creationId xmlns:a16="http://schemas.microsoft.com/office/drawing/2014/main" id="{62B9E6DD-4EC1-44C4-9148-E2AC3621A9F3}"/>
               </a:ext>
             </a:extLst>
           </p:cNvPr>
@@ -11346,7 +11346,7 @@
           <p:cNvPr id="6" name="text">
             <a:extLst xmlns:a="http://schemas.openxmlformats.org/drawingml/2006/main">
               <a:ext uri="{FF2B5EF4-FFF2-40B4-BE49-F238E27FC236}">
-                <a16:creationId xmlns:a16="http://schemas.microsoft.com/office/drawing/2014/main" id="{30DACD65-DAF6-488C-B792-84A3D1E34E53}"/>
+                <a16:creationId xmlns:a16="http://schemas.microsoft.com/office/drawing/2014/main" id="{C1443DE3-74AD-4854-B2FA-147338CEE5A3}"/>
               </a:ext>
             </a:extLst>
           </p:cNvPr>
@@ -11403,7 +11403,7 @@
           <p:cNvPr id="7" name="text">
             <a:extLst xmlns:a="http://schemas.openxmlformats.org/drawingml/2006/main">
               <a:ext uri="{FF2B5EF4-FFF2-40B4-BE49-F238E27FC236}">
-                <a16:creationId xmlns:a16="http://schemas.microsoft.com/office/drawing/2014/main" id="{3B7E558F-1BE6-4F65-A93F-E8E0B05E74A4}"/>
+                <a16:creationId xmlns:a16="http://schemas.microsoft.com/office/drawing/2014/main" id="{D5FE604C-089F-490C-A8FA-FAA2E5FB62AF}"/>
               </a:ext>
             </a:extLst>
           </p:cNvPr>
@@ -11458,7 +11458,7 @@
     </p:spTree>
     <p:extLst>
       <p:ext uri="{BB962C8B-B14F-4D97-AF65-F5344CB8AC3E}">
-        <p14:creationId xmlns:p14="http://schemas.microsoft.com/office/powerpoint/2010/main" val="1815746005"/>
+        <p14:creationId xmlns:p14="http://schemas.microsoft.com/office/powerpoint/2010/main" val="879487681"/>
       </p:ext>
     </p:extLst>
   </p:cSld>
@@ -11500,7 +11500,7 @@
           <p:cNvPr id="6" name="text">
             <a:extLst xmlns:a="http://schemas.openxmlformats.org/drawingml/2006/main">
               <a:ext uri="{FF2B5EF4-FFF2-40B4-BE49-F238E27FC236}">
-                <a16:creationId xmlns:a16="http://schemas.microsoft.com/office/drawing/2014/main" id="{D5D2DDCB-7EB1-49ED-A7AC-BD193E3379B2}"/>
+                <a16:creationId xmlns:a16="http://schemas.microsoft.com/office/drawing/2014/main" id="{5D99A89E-21A8-4FB3-B173-70930D716FE8}"/>
               </a:ext>
             </a:extLst>
           </p:cNvPr>
@@ -11557,7 +11557,7 @@
           <p:cNvPr id="2" name="text">
             <a:extLst xmlns:a="http://schemas.openxmlformats.org/drawingml/2006/main">
               <a:ext uri="{FF2B5EF4-FFF2-40B4-BE49-F238E27FC236}">
-                <a16:creationId xmlns:a16="http://schemas.microsoft.com/office/drawing/2014/main" id="{F984E88A-2095-4196-B2A6-F8FCF0B2E927}"/>
+                <a16:creationId xmlns:a16="http://schemas.microsoft.com/office/drawing/2014/main" id="{67AAF436-BA2F-4356-811C-B42AAD2DFDFC}"/>
               </a:ext>
             </a:extLst>
           </p:cNvPr>
@@ -11614,7 +11614,7 @@
           <p:cNvPr id="3" name="text">
             <a:extLst xmlns:a="http://schemas.openxmlformats.org/drawingml/2006/main">
               <a:ext uri="{FF2B5EF4-FFF2-40B4-BE49-F238E27FC236}">
-                <a16:creationId xmlns:a16="http://schemas.microsoft.com/office/drawing/2014/main" id="{3A2FB64F-FB4A-4DA0-AAB3-67692B072093}"/>
+                <a16:creationId xmlns:a16="http://schemas.microsoft.com/office/drawing/2014/main" id="{176EF3F9-6C58-45E0-BD79-CB43986DEED4}"/>
               </a:ext>
             </a:extLst>
           </p:cNvPr>
@@ -11671,7 +11671,7 @@
           <p:cNvPr id="4" name="text">
             <a:extLst xmlns:a="http://schemas.openxmlformats.org/drawingml/2006/main">
               <a:ext uri="{FF2B5EF4-FFF2-40B4-BE49-F238E27FC236}">
-                <a16:creationId xmlns:a16="http://schemas.microsoft.com/office/drawing/2014/main" id="{5D5EC09C-A8C3-4EE5-8A32-4F983E84176C}"/>
+                <a16:creationId xmlns:a16="http://schemas.microsoft.com/office/drawing/2014/main" id="{2BC1A9FC-BFDC-4900-BA37-D08AF2DA5C5A}"/>
               </a:ext>
             </a:extLst>
           </p:cNvPr>
@@ -11728,7 +11728,7 @@
           <p:cNvPr id="5" name="text">
             <a:extLst xmlns:a="http://schemas.openxmlformats.org/drawingml/2006/main">
               <a:ext uri="{FF2B5EF4-FFF2-40B4-BE49-F238E27FC236}">
-                <a16:creationId xmlns:a16="http://schemas.microsoft.com/office/drawing/2014/main" id="{F1AB5F32-97BC-4B0E-8304-A0AEE9697E18}"/>
+                <a16:creationId xmlns:a16="http://schemas.microsoft.com/office/drawing/2014/main" id="{D6681AAB-65C6-4A78-9B62-425CD3EB82AE}"/>
               </a:ext>
             </a:extLst>
           </p:cNvPr>
@@ -11783,7 +11783,7 @@
     </p:spTree>
     <p:extLst>
       <p:ext uri="{BB962C8B-B14F-4D97-AF65-F5344CB8AC3E}">
-        <p14:creationId xmlns:p14="http://schemas.microsoft.com/office/powerpoint/2010/main" val="236822508"/>
+        <p14:creationId xmlns:p14="http://schemas.microsoft.com/office/powerpoint/2010/main" val="413827710"/>
       </p:ext>
     </p:extLst>
   </p:cSld>
@@ -11825,7 +11825,7 @@
           <p:cNvPr id="8" name="text">
             <a:extLst xmlns:a="http://schemas.openxmlformats.org/drawingml/2006/main">
               <a:ext uri="{FF2B5EF4-FFF2-40B4-BE49-F238E27FC236}">
-                <a16:creationId xmlns:a16="http://schemas.microsoft.com/office/drawing/2014/main" id="{67061728-0278-4D40-B7AA-8ECD1043A2E3}"/>
+                <a16:creationId xmlns:a16="http://schemas.microsoft.com/office/drawing/2014/main" id="{DE82F43D-692A-4E25-A8D7-D838B7C77BD2}"/>
               </a:ext>
             </a:extLst>
           </p:cNvPr>
@@ -11882,7 +11882,7 @@
           <p:cNvPr id="2" name="text">
             <a:extLst xmlns:a="http://schemas.openxmlformats.org/drawingml/2006/main">
               <a:ext uri="{FF2B5EF4-FFF2-40B4-BE49-F238E27FC236}">
-                <a16:creationId xmlns:a16="http://schemas.microsoft.com/office/drawing/2014/main" id="{961B6548-D804-4486-9DC0-345FC52DE6AD}"/>
+                <a16:creationId xmlns:a16="http://schemas.microsoft.com/office/drawing/2014/main" id="{04588686-AFC2-4B1B-B107-F05DE870388B}"/>
               </a:ext>
             </a:extLst>
           </p:cNvPr>
@@ -11939,7 +11939,7 @@
           <p:cNvPr id="3" name="text">
             <a:extLst xmlns:a="http://schemas.openxmlformats.org/drawingml/2006/main">
               <a:ext uri="{FF2B5EF4-FFF2-40B4-BE49-F238E27FC236}">
-                <a16:creationId xmlns:a16="http://schemas.microsoft.com/office/drawing/2014/main" id="{563744FC-2DEF-4C78-8B95-EF3644869805}"/>
+                <a16:creationId xmlns:a16="http://schemas.microsoft.com/office/drawing/2014/main" id="{1F8FEB21-C869-4A1E-AB98-2A0976711EF7}"/>
               </a:ext>
             </a:extLst>
           </p:cNvPr>
@@ -11996,7 +11996,7 @@
           <p:cNvPr id="4" name="text">
             <a:extLst xmlns:a="http://schemas.openxmlformats.org/drawingml/2006/main">
               <a:ext uri="{FF2B5EF4-FFF2-40B4-BE49-F238E27FC236}">
-                <a16:creationId xmlns:a16="http://schemas.microsoft.com/office/drawing/2014/main" id="{51AFF7CC-FB63-4867-AF20-D4ED785B543B}"/>
+                <a16:creationId xmlns:a16="http://schemas.microsoft.com/office/drawing/2014/main" id="{CC6C131E-6C0C-4654-833B-42F5AB3A883A}"/>
               </a:ext>
             </a:extLst>
           </p:cNvPr>
@@ -12053,7 +12053,7 @@
           <p:cNvPr id="5" name="text">
             <a:extLst xmlns:a="http://schemas.openxmlformats.org/drawingml/2006/main">
               <a:ext uri="{FF2B5EF4-FFF2-40B4-BE49-F238E27FC236}">
-                <a16:creationId xmlns:a16="http://schemas.microsoft.com/office/drawing/2014/main" id="{E063600F-14F5-4EBF-8F24-EFAF74BB9C41}"/>
+                <a16:creationId xmlns:a16="http://schemas.microsoft.com/office/drawing/2014/main" id="{C2481CAF-34EE-405B-A593-2D001CD08A66}"/>
               </a:ext>
             </a:extLst>
           </p:cNvPr>
@@ -12110,7 +12110,7 @@
           <p:cNvPr id="6" name="text">
             <a:extLst xmlns:a="http://schemas.openxmlformats.org/drawingml/2006/main">
               <a:ext uri="{FF2B5EF4-FFF2-40B4-BE49-F238E27FC236}">
-                <a16:creationId xmlns:a16="http://schemas.microsoft.com/office/drawing/2014/main" id="{8D5E0A71-5117-4DE0-92A2-1026C9A57DAD}"/>
+                <a16:creationId xmlns:a16="http://schemas.microsoft.com/office/drawing/2014/main" id="{AB16CF24-B328-4FDA-9FE1-2F2EB6D789B4}"/>
               </a:ext>
             </a:extLst>
           </p:cNvPr>
@@ -12167,7 +12167,7 @@
           <p:cNvPr id="7" name="text">
             <a:extLst xmlns:a="http://schemas.openxmlformats.org/drawingml/2006/main">
               <a:ext uri="{FF2B5EF4-FFF2-40B4-BE49-F238E27FC236}">
-                <a16:creationId xmlns:a16="http://schemas.microsoft.com/office/drawing/2014/main" id="{D32347A0-90AD-4147-B8B8-CBD62DCE21EF}"/>
+                <a16:creationId xmlns:a16="http://schemas.microsoft.com/office/drawing/2014/main" id="{F38E2130-0630-4DBE-B09D-8091114E23AB}"/>
               </a:ext>
             </a:extLst>
           </p:cNvPr>
@@ -12222,7 +12222,7 @@
     </p:spTree>
     <p:extLst>
       <p:ext uri="{BB962C8B-B14F-4D97-AF65-F5344CB8AC3E}">
-        <p14:creationId xmlns:p14="http://schemas.microsoft.com/office/powerpoint/2010/main" val="1055235769"/>
+        <p14:creationId xmlns:p14="http://schemas.microsoft.com/office/powerpoint/2010/main" val="1411055857"/>
       </p:ext>
     </p:extLst>
   </p:cSld>
@@ -12268,7 +12268,7 @@
           <p:nvPr/>
         </p:nvPicPr>
         <p:blipFill>
-          <a:blip xmlns:r="http://schemas.openxmlformats.org/officeDocument/2006/relationships" xmlns:a="http://schemas.openxmlformats.org/drawingml/2006/main" r:embed="R1c7ec5475c654edf"/>
+          <a:blip xmlns:r="http://schemas.openxmlformats.org/officeDocument/2006/relationships" xmlns:a="http://schemas.openxmlformats.org/drawingml/2006/main" r:embed="R97989286f94745a9"/>
           <a:stretch xmlns:a="http://schemas.openxmlformats.org/drawingml/2006/main"/>
         </p:blipFill>
         <p:spPr>
@@ -12284,7 +12284,7 @@
     </p:spTree>
     <p:extLst>
       <p:ext uri="{BB962C8B-B14F-4D97-AF65-F5344CB8AC3E}">
-        <p14:creationId xmlns:p14="http://schemas.microsoft.com/office/powerpoint/2010/main" val="1074845409"/>
+        <p14:creationId xmlns:p14="http://schemas.microsoft.com/office/powerpoint/2010/main" val="990509806"/>
       </p:ext>
     </p:extLst>
   </p:cSld>
@@ -12326,7 +12326,7 @@
           <p:cNvPr id="6" name="text">
             <a:extLst xmlns:a="http://schemas.openxmlformats.org/drawingml/2006/main">
               <a:ext uri="{FF2B5EF4-FFF2-40B4-BE49-F238E27FC236}">
-                <a16:creationId xmlns:a16="http://schemas.microsoft.com/office/drawing/2014/main" id="{72ECBBDD-6557-49FE-A224-59E5D3746E00}"/>
+                <a16:creationId xmlns:a16="http://schemas.microsoft.com/office/drawing/2014/main" id="{44966B06-E977-4817-9B0A-4F3CF1BF7F9D}"/>
               </a:ext>
             </a:extLst>
           </p:cNvPr>
@@ -12383,7 +12383,7 @@
           <p:cNvPr id="2" name="text">
             <a:extLst xmlns:a="http://schemas.openxmlformats.org/drawingml/2006/main">
               <a:ext uri="{FF2B5EF4-FFF2-40B4-BE49-F238E27FC236}">
-                <a16:creationId xmlns:a16="http://schemas.microsoft.com/office/drawing/2014/main" id="{F6841B96-D690-467B-BA44-0E9420151EEC}"/>
+                <a16:creationId xmlns:a16="http://schemas.microsoft.com/office/drawing/2014/main" id="{A07DC6A1-B557-4EB4-A3B4-AFA1B5799931}"/>
               </a:ext>
             </a:extLst>
           </p:cNvPr>
@@ -12440,7 +12440,7 @@
           <p:cNvPr id="3" name="text">
             <a:extLst xmlns:a="http://schemas.openxmlformats.org/drawingml/2006/main">
               <a:ext uri="{FF2B5EF4-FFF2-40B4-BE49-F238E27FC236}">
-                <a16:creationId xmlns:a16="http://schemas.microsoft.com/office/drawing/2014/main" id="{21CFECB1-4B99-4BF8-872B-8DCDBDAEE8BC}"/>
+                <a16:creationId xmlns:a16="http://schemas.microsoft.com/office/drawing/2014/main" id="{65576B02-6D5F-47AF-9C59-F198EE50D009}"/>
               </a:ext>
             </a:extLst>
           </p:cNvPr>
@@ -12497,7 +12497,7 @@
           <p:cNvPr id="4" name="text">
             <a:extLst xmlns:a="http://schemas.openxmlformats.org/drawingml/2006/main">
               <a:ext uri="{FF2B5EF4-FFF2-40B4-BE49-F238E27FC236}">
-                <a16:creationId xmlns:a16="http://schemas.microsoft.com/office/drawing/2014/main" id="{E1D17E20-3795-4359-8CC5-4D8E27CD8753}"/>
+                <a16:creationId xmlns:a16="http://schemas.microsoft.com/office/drawing/2014/main" id="{152BC730-6CAA-4AE8-BF8C-E9721855C7E6}"/>
               </a:ext>
             </a:extLst>
           </p:cNvPr>
@@ -12554,7 +12554,7 @@
           <p:cNvPr id="5" name="text">
             <a:extLst xmlns:a="http://schemas.openxmlformats.org/drawingml/2006/main">
               <a:ext uri="{FF2B5EF4-FFF2-40B4-BE49-F238E27FC236}">
-                <a16:creationId xmlns:a16="http://schemas.microsoft.com/office/drawing/2014/main" id="{5BBBC36C-6B0D-4677-8501-018EA7CD4C1F}"/>
+                <a16:creationId xmlns:a16="http://schemas.microsoft.com/office/drawing/2014/main" id="{333FE8BF-A433-4BC2-8A68-A1FECB3504D6}"/>
               </a:ext>
             </a:extLst>
           </p:cNvPr>
@@ -12609,7 +12609,7 @@
     </p:spTree>
     <p:extLst>
       <p:ext uri="{BB962C8B-B14F-4D97-AF65-F5344CB8AC3E}">
-        <p14:creationId xmlns:p14="http://schemas.microsoft.com/office/powerpoint/2010/main" val="2133060354"/>
+        <p14:creationId xmlns:p14="http://schemas.microsoft.com/office/powerpoint/2010/main" val="596292760"/>
       </p:ext>
     </p:extLst>
   </p:cSld>
@@ -12651,7 +12651,7 @@
           <p:cNvPr id="8" name="text">
             <a:extLst xmlns:a="http://schemas.openxmlformats.org/drawingml/2006/main">
               <a:ext uri="{FF2B5EF4-FFF2-40B4-BE49-F238E27FC236}">
-                <a16:creationId xmlns:a16="http://schemas.microsoft.com/office/drawing/2014/main" id="{CFC4BA6C-35B8-4810-B71F-D816250C6BAF}"/>
+                <a16:creationId xmlns:a16="http://schemas.microsoft.com/office/drawing/2014/main" id="{22BFFE07-C7D3-4F43-BAE2-74F3C226C8C4}"/>
               </a:ext>
             </a:extLst>
           </p:cNvPr>
@@ -12708,7 +12708,7 @@
           <p:cNvPr id="2" name="text">
             <a:extLst xmlns:a="http://schemas.openxmlformats.org/drawingml/2006/main">
               <a:ext uri="{FF2B5EF4-FFF2-40B4-BE49-F238E27FC236}">
-                <a16:creationId xmlns:a16="http://schemas.microsoft.com/office/drawing/2014/main" id="{8B6F5A46-859B-4DED-8592-0760F628A230}"/>
+                <a16:creationId xmlns:a16="http://schemas.microsoft.com/office/drawing/2014/main" id="{1315396F-1E3C-4E5B-B60E-23C17FBE0390}"/>
               </a:ext>
             </a:extLst>
           </p:cNvPr>
@@ -12765,7 +12765,7 @@
           <p:cNvPr id="3" name="text">
             <a:extLst xmlns:a="http://schemas.openxmlformats.org/drawingml/2006/main">
               <a:ext uri="{FF2B5EF4-FFF2-40B4-BE49-F238E27FC236}">
-                <a16:creationId xmlns:a16="http://schemas.microsoft.com/office/drawing/2014/main" id="{CF9BDEAA-5E0A-4C02-A6B3-247828DAA261}"/>
+                <a16:creationId xmlns:a16="http://schemas.microsoft.com/office/drawing/2014/main" id="{D240330A-EB46-4BE4-B038-6AF2E2ADC29E}"/>
               </a:ext>
             </a:extLst>
           </p:cNvPr>
@@ -12822,7 +12822,7 @@
           <p:cNvPr id="4" name="text">
             <a:extLst xmlns:a="http://schemas.openxmlformats.org/drawingml/2006/main">
               <a:ext uri="{FF2B5EF4-FFF2-40B4-BE49-F238E27FC236}">
-                <a16:creationId xmlns:a16="http://schemas.microsoft.com/office/drawing/2014/main" id="{6B34DB06-43CC-4A0E-9523-A26B542AE984}"/>
+                <a16:creationId xmlns:a16="http://schemas.microsoft.com/office/drawing/2014/main" id="{FC3BFD6B-F0D6-4A14-A464-B4AE375D0D8E}"/>
               </a:ext>
             </a:extLst>
           </p:cNvPr>
@@ -12879,7 +12879,7 @@
           <p:cNvPr id="5" name="text">
             <a:extLst xmlns:a="http://schemas.openxmlformats.org/drawingml/2006/main">
               <a:ext uri="{FF2B5EF4-FFF2-40B4-BE49-F238E27FC236}">
-                <a16:creationId xmlns:a16="http://schemas.microsoft.com/office/drawing/2014/main" id="{619FF92D-A4C1-4C56-BA16-BCAC4695F69E}"/>
+                <a16:creationId xmlns:a16="http://schemas.microsoft.com/office/drawing/2014/main" id="{E19E7B0C-5047-40D5-A4F9-5C1ACF2CDABD}"/>
               </a:ext>
             </a:extLst>
           </p:cNvPr>
@@ -12936,7 +12936,7 @@
           <p:cNvPr id="6" name="text">
             <a:extLst xmlns:a="http://schemas.openxmlformats.org/drawingml/2006/main">
               <a:ext uri="{FF2B5EF4-FFF2-40B4-BE49-F238E27FC236}">
-                <a16:creationId xmlns:a16="http://schemas.microsoft.com/office/drawing/2014/main" id="{E3A9FBC1-360E-4EBE-9829-8EB1E83A8E99}"/>
+                <a16:creationId xmlns:a16="http://schemas.microsoft.com/office/drawing/2014/main" id="{3B3CA77C-EB4C-47D5-A887-C0C096A32523}"/>
               </a:ext>
             </a:extLst>
           </p:cNvPr>
@@ -12993,7 +12993,7 @@
           <p:cNvPr id="7" name="text">
             <a:extLst xmlns:a="http://schemas.openxmlformats.org/drawingml/2006/main">
               <a:ext uri="{FF2B5EF4-FFF2-40B4-BE49-F238E27FC236}">
-                <a16:creationId xmlns:a16="http://schemas.microsoft.com/office/drawing/2014/main" id="{3CAA753E-C662-47BB-9261-0813806208B1}"/>
+                <a16:creationId xmlns:a16="http://schemas.microsoft.com/office/drawing/2014/main" id="{0DD3D2EC-416D-4347-A367-33CE9626933B}"/>
               </a:ext>
             </a:extLst>
           </p:cNvPr>
@@ -13048,7 +13048,7 @@
     </p:spTree>
     <p:extLst>
       <p:ext uri="{BB962C8B-B14F-4D97-AF65-F5344CB8AC3E}">
-        <p14:creationId xmlns:p14="http://schemas.microsoft.com/office/powerpoint/2010/main" val="1124054523"/>
+        <p14:creationId xmlns:p14="http://schemas.microsoft.com/office/powerpoint/2010/main" val="943569985"/>
       </p:ext>
     </p:extLst>
   </p:cSld>
@@ -13090,7 +13090,7 @@
           <p:cNvPr id="6" name="text">
             <a:extLst xmlns:a="http://schemas.openxmlformats.org/drawingml/2006/main">
               <a:ext uri="{FF2B5EF4-FFF2-40B4-BE49-F238E27FC236}">
-                <a16:creationId xmlns:a16="http://schemas.microsoft.com/office/drawing/2014/main" id="{95EAD75C-4BC3-4A5E-B50E-B1691C9D859F}"/>
+                <a16:creationId xmlns:a16="http://schemas.microsoft.com/office/drawing/2014/main" id="{A6646FD7-C46D-486D-BB40-063B56027022}"/>
               </a:ext>
             </a:extLst>
           </p:cNvPr>
@@ -13147,7 +13147,7 @@
           <p:cNvPr id="2" name="text">
             <a:extLst xmlns:a="http://schemas.openxmlformats.org/drawingml/2006/main">
               <a:ext uri="{FF2B5EF4-FFF2-40B4-BE49-F238E27FC236}">
-                <a16:creationId xmlns:a16="http://schemas.microsoft.com/office/drawing/2014/main" id="{7BEAB430-C1D4-4D10-B07A-A4248AC41ED3}"/>
+                <a16:creationId xmlns:a16="http://schemas.microsoft.com/office/drawing/2014/main" id="{56BB6D2F-4153-4CEB-9F30-F6F4C41DBB15}"/>
               </a:ext>
             </a:extLst>
           </p:cNvPr>
@@ -13204,7 +13204,7 @@
           <p:cNvPr id="3" name="text">
             <a:extLst xmlns:a="http://schemas.openxmlformats.org/drawingml/2006/main">
               <a:ext uri="{FF2B5EF4-FFF2-40B4-BE49-F238E27FC236}">
-                <a16:creationId xmlns:a16="http://schemas.microsoft.com/office/drawing/2014/main" id="{E5B909EC-E28A-4881-8617-E9CAAED040AA}"/>
+                <a16:creationId xmlns:a16="http://schemas.microsoft.com/office/drawing/2014/main" id="{87908DCD-0024-45FD-9BA5-4B047E2031B7}"/>
               </a:ext>
             </a:extLst>
           </p:cNvPr>
@@ -13261,7 +13261,7 @@
           <p:cNvPr id="4" name="text">
             <a:extLst xmlns:a="http://schemas.openxmlformats.org/drawingml/2006/main">
               <a:ext uri="{FF2B5EF4-FFF2-40B4-BE49-F238E27FC236}">
-                <a16:creationId xmlns:a16="http://schemas.microsoft.com/office/drawing/2014/main" id="{95DEB15D-96F6-470F-9400-7CA9E548C7E8}"/>
+                <a16:creationId xmlns:a16="http://schemas.microsoft.com/office/drawing/2014/main" id="{9130BC44-2F53-40FF-BF75-C7D475E75B67}"/>
               </a:ext>
             </a:extLst>
           </p:cNvPr>
@@ -13318,7 +13318,7 @@
           <p:cNvPr id="5" name="text">
             <a:extLst xmlns:a="http://schemas.openxmlformats.org/drawingml/2006/main">
               <a:ext uri="{FF2B5EF4-FFF2-40B4-BE49-F238E27FC236}">
-                <a16:creationId xmlns:a16="http://schemas.microsoft.com/office/drawing/2014/main" id="{EDC453F6-48F4-47EE-A2B4-0D0801733998}"/>
+                <a16:creationId xmlns:a16="http://schemas.microsoft.com/office/drawing/2014/main" id="{AC97FF10-5D21-440F-9199-B443500D42FE}"/>
               </a:ext>
             </a:extLst>
           </p:cNvPr>
@@ -13373,7 +13373,7 @@
     </p:spTree>
     <p:extLst>
       <p:ext uri="{BB962C8B-B14F-4D97-AF65-F5344CB8AC3E}">
-        <p14:creationId xmlns:p14="http://schemas.microsoft.com/office/powerpoint/2010/main" val="1664261309"/>
+        <p14:creationId xmlns:p14="http://schemas.microsoft.com/office/powerpoint/2010/main" val="1581995659"/>
       </p:ext>
     </p:extLst>
   </p:cSld>
@@ -13415,7 +13415,7 @@
           <p:cNvPr id="8" name="text">
             <a:extLst xmlns:a="http://schemas.openxmlformats.org/drawingml/2006/main">
               <a:ext uri="{FF2B5EF4-FFF2-40B4-BE49-F238E27FC236}">
-                <a16:creationId xmlns:a16="http://schemas.microsoft.com/office/drawing/2014/main" id="{2DA4854C-50F8-442F-96A1-B7C9047D3386}"/>
+                <a16:creationId xmlns:a16="http://schemas.microsoft.com/office/drawing/2014/main" id="{13B66028-6BB6-498E-B1D7-4830AEB6D470}"/>
               </a:ext>
             </a:extLst>
           </p:cNvPr>
@@ -13472,7 +13472,7 @@
           <p:cNvPr id="2" name="text">
             <a:extLst xmlns:a="http://schemas.openxmlformats.org/drawingml/2006/main">
               <a:ext uri="{FF2B5EF4-FFF2-40B4-BE49-F238E27FC236}">
-                <a16:creationId xmlns:a16="http://schemas.microsoft.com/office/drawing/2014/main" id="{FCB75BCE-121F-4789-A62A-56950B2B17EC}"/>
+                <a16:creationId xmlns:a16="http://schemas.microsoft.com/office/drawing/2014/main" id="{29A24375-68B8-4943-8128-17CC4A7AE334}"/>
               </a:ext>
             </a:extLst>
           </p:cNvPr>
@@ -13529,7 +13529,7 @@
           <p:cNvPr id="3" name="text">
             <a:extLst xmlns:a="http://schemas.openxmlformats.org/drawingml/2006/main">
               <a:ext uri="{FF2B5EF4-FFF2-40B4-BE49-F238E27FC236}">
-                <a16:creationId xmlns:a16="http://schemas.microsoft.com/office/drawing/2014/main" id="{A3F79606-D698-410F-B6E6-5F222C032539}"/>
+                <a16:creationId xmlns:a16="http://schemas.microsoft.com/office/drawing/2014/main" id="{669E51FE-1EEA-4DF6-834F-D118BD0831B2}"/>
               </a:ext>
             </a:extLst>
           </p:cNvPr>
@@ -13586,7 +13586,7 @@
           <p:cNvPr id="4" name="text">
             <a:extLst xmlns:a="http://schemas.openxmlformats.org/drawingml/2006/main">
               <a:ext uri="{FF2B5EF4-FFF2-40B4-BE49-F238E27FC236}">
-                <a16:creationId xmlns:a16="http://schemas.microsoft.com/office/drawing/2014/main" id="{7D0B7619-BB3E-4D71-BE80-D9F1D992DFDE}"/>
+                <a16:creationId xmlns:a16="http://schemas.microsoft.com/office/drawing/2014/main" id="{7A0EF118-3A9B-4692-9B6F-B6E6790B427E}"/>
               </a:ext>
             </a:extLst>
           </p:cNvPr>
@@ -13643,7 +13643,7 @@
           <p:cNvPr id="5" name="text">
             <a:extLst xmlns:a="http://schemas.openxmlformats.org/drawingml/2006/main">
               <a:ext uri="{FF2B5EF4-FFF2-40B4-BE49-F238E27FC236}">
-                <a16:creationId xmlns:a16="http://schemas.microsoft.com/office/drawing/2014/main" id="{C8DD5E2B-D4D3-4EA3-B3E7-150A814A6E4B}"/>
+                <a16:creationId xmlns:a16="http://schemas.microsoft.com/office/drawing/2014/main" id="{D2F5EBD9-156E-4DE9-80CA-167723FBFA6B}"/>
               </a:ext>
             </a:extLst>
           </p:cNvPr>
@@ -13700,7 +13700,7 @@
           <p:cNvPr id="6" name="text">
             <a:extLst xmlns:a="http://schemas.openxmlformats.org/drawingml/2006/main">
               <a:ext uri="{FF2B5EF4-FFF2-40B4-BE49-F238E27FC236}">
-                <a16:creationId xmlns:a16="http://schemas.microsoft.com/office/drawing/2014/main" id="{69970DA0-EACA-45EC-993C-C779130055FD}"/>
+                <a16:creationId xmlns:a16="http://schemas.microsoft.com/office/drawing/2014/main" id="{9C8E98B7-0BC8-4942-9BFA-B4D7DD20C2CD}"/>
               </a:ext>
             </a:extLst>
           </p:cNvPr>
@@ -13757,7 +13757,7 @@
           <p:cNvPr id="7" name="text">
             <a:extLst xmlns:a="http://schemas.openxmlformats.org/drawingml/2006/main">
               <a:ext uri="{FF2B5EF4-FFF2-40B4-BE49-F238E27FC236}">
-                <a16:creationId xmlns:a16="http://schemas.microsoft.com/office/drawing/2014/main" id="{F0A9C985-615E-4E80-970E-5C31342D7392}"/>
+                <a16:creationId xmlns:a16="http://schemas.microsoft.com/office/drawing/2014/main" id="{FF49D8E8-BDB3-465C-BB1D-D2216DE144C2}"/>
               </a:ext>
             </a:extLst>
           </p:cNvPr>
@@ -13812,7 +13812,7 @@
     </p:spTree>
     <p:extLst>
       <p:ext uri="{BB962C8B-B14F-4D97-AF65-F5344CB8AC3E}">
-        <p14:creationId xmlns:p14="http://schemas.microsoft.com/office/powerpoint/2010/main" val="652357390"/>
+        <p14:creationId xmlns:p14="http://schemas.microsoft.com/office/powerpoint/2010/main" val="1320707921"/>
       </p:ext>
     </p:extLst>
   </p:cSld>
@@ -13854,7 +13854,7 @@
           <p:cNvPr id="6" name="text">
             <a:extLst xmlns:a="http://schemas.openxmlformats.org/drawingml/2006/main">
               <a:ext uri="{FF2B5EF4-FFF2-40B4-BE49-F238E27FC236}">
-                <a16:creationId xmlns:a16="http://schemas.microsoft.com/office/drawing/2014/main" id="{D615F7A0-3696-4577-BA64-F3823BFBAAF9}"/>
+                <a16:creationId xmlns:a16="http://schemas.microsoft.com/office/drawing/2014/main" id="{1E24FE12-4BF2-40B8-B66B-9D8A70858C70}"/>
               </a:ext>
             </a:extLst>
           </p:cNvPr>
@@ -13911,7 +13911,7 @@
           <p:cNvPr id="2" name="text">
             <a:extLst xmlns:a="http://schemas.openxmlformats.org/drawingml/2006/main">
               <a:ext uri="{FF2B5EF4-FFF2-40B4-BE49-F238E27FC236}">
-                <a16:creationId xmlns:a16="http://schemas.microsoft.com/office/drawing/2014/main" id="{3490D902-E1EF-4B77-9CE9-133AB6902C8D}"/>
+                <a16:creationId xmlns:a16="http://schemas.microsoft.com/office/drawing/2014/main" id="{99A321E3-145D-48C3-B166-BCBC4642E296}"/>
               </a:ext>
             </a:extLst>
           </p:cNvPr>
@@ -13968,7 +13968,7 @@
           <p:cNvPr id="3" name="text">
             <a:extLst xmlns:a="http://schemas.openxmlformats.org/drawingml/2006/main">
               <a:ext uri="{FF2B5EF4-FFF2-40B4-BE49-F238E27FC236}">
-                <a16:creationId xmlns:a16="http://schemas.microsoft.com/office/drawing/2014/main" id="{38AAC838-30D5-41CD-B81F-B191E8DE6CEA}"/>
+                <a16:creationId xmlns:a16="http://schemas.microsoft.com/office/drawing/2014/main" id="{05F2790D-D6DB-4531-B532-6DA2BC7368A2}"/>
               </a:ext>
             </a:extLst>
           </p:cNvPr>
@@ -14025,7 +14025,7 @@
           <p:cNvPr id="4" name="text">
             <a:extLst xmlns:a="http://schemas.openxmlformats.org/drawingml/2006/main">
               <a:ext uri="{FF2B5EF4-FFF2-40B4-BE49-F238E27FC236}">
-                <a16:creationId xmlns:a16="http://schemas.microsoft.com/office/drawing/2014/main" id="{CEEAC8A9-08F9-49F5-9BDD-0B7D093897CB}"/>
+                <a16:creationId xmlns:a16="http://schemas.microsoft.com/office/drawing/2014/main" id="{37741E49-0E5A-411B-A1AF-3AE1CC17734C}"/>
               </a:ext>
             </a:extLst>
           </p:cNvPr>
@@ -14082,7 +14082,7 @@
           <p:cNvPr id="5" name="text">
             <a:extLst xmlns:a="http://schemas.openxmlformats.org/drawingml/2006/main">
               <a:ext uri="{FF2B5EF4-FFF2-40B4-BE49-F238E27FC236}">
-                <a16:creationId xmlns:a16="http://schemas.microsoft.com/office/drawing/2014/main" id="{69945A47-5FCF-4D01-8C23-32D60584FBCD}"/>
+                <a16:creationId xmlns:a16="http://schemas.microsoft.com/office/drawing/2014/main" id="{6C2A988E-05BC-435A-90D6-60E19FC35A8A}"/>
               </a:ext>
             </a:extLst>
           </p:cNvPr>
@@ -14137,7 +14137,7 @@
     </p:spTree>
     <p:extLst>
       <p:ext uri="{BB962C8B-B14F-4D97-AF65-F5344CB8AC3E}">
-        <p14:creationId xmlns:p14="http://schemas.microsoft.com/office/powerpoint/2010/main" val="1424239137"/>
+        <p14:creationId xmlns:p14="http://schemas.microsoft.com/office/powerpoint/2010/main" val="801977470"/>
       </p:ext>
     </p:extLst>
   </p:cSld>
@@ -14179,7 +14179,7 @@
           <p:cNvPr id="8" name="text">
             <a:extLst xmlns:a="http://schemas.openxmlformats.org/drawingml/2006/main">
               <a:ext uri="{FF2B5EF4-FFF2-40B4-BE49-F238E27FC236}">
-                <a16:creationId xmlns:a16="http://schemas.microsoft.com/office/drawing/2014/main" id="{1620D211-CBD1-47BE-A73E-8563F9E73917}"/>
+                <a16:creationId xmlns:a16="http://schemas.microsoft.com/office/drawing/2014/main" id="{372F13A5-4EBE-4AFC-A3FC-929862BDE26C}"/>
               </a:ext>
             </a:extLst>
           </p:cNvPr>
@@ -14236,7 +14236,7 @@
           <p:cNvPr id="2" name="text">
             <a:extLst xmlns:a="http://schemas.openxmlformats.org/drawingml/2006/main">
               <a:ext uri="{FF2B5EF4-FFF2-40B4-BE49-F238E27FC236}">
-                <a16:creationId xmlns:a16="http://schemas.microsoft.com/office/drawing/2014/main" id="{D4F726DB-3C3D-486C-AB09-93D729607D9B}"/>
+                <a16:creationId xmlns:a16="http://schemas.microsoft.com/office/drawing/2014/main" id="{58D5158C-8392-4422-9F3B-88784653198F}"/>
               </a:ext>
             </a:extLst>
           </p:cNvPr>
@@ -14283,7 +14283,7 @@
                 <a:ea typeface="Heebo"/>
                 <a:cs typeface="Heebo"/>
               </a:rPr>
-              <a:t>3 מפגשים כפולים עד המבחן</a:t>
+              <a:t>נשארו 3 מפגשים כפולים</a:t>
             </a:r>
           </a:p>
         </p:txBody>
@@ -14293,7 +14293,7 @@
           <p:cNvPr id="3" name="text">
             <a:extLst xmlns:a="http://schemas.openxmlformats.org/drawingml/2006/main">
               <a:ext uri="{FF2B5EF4-FFF2-40B4-BE49-F238E27FC236}">
-                <a16:creationId xmlns:a16="http://schemas.microsoft.com/office/drawing/2014/main" id="{25EBA7CD-39F6-4A99-9024-5CBDBE0676B9}"/>
+                <a16:creationId xmlns:a16="http://schemas.microsoft.com/office/drawing/2014/main" id="{4C2E44AC-972E-4B61-B007-330548043A22}"/>
               </a:ext>
             </a:extLst>
           </p:cNvPr>
@@ -14305,7 +14305,7 @@
         <p:spPr>
           <a:xfrm xmlns:a="http://schemas.openxmlformats.org/drawingml/2006/main">
             <a:off x="857250" y="2590800"/>
-            <a:ext cx="10477500" cy="542925"/>
+            <a:ext cx="10477500" cy="781050"/>
           </a:xfrm>
           <a:prstGeom xmlns:a="http://schemas.openxmlformats.org/drawingml/2006/main" prst="rect">
             <a:avLst/>
@@ -14322,7 +14322,7 @@
           <a:lstStyle xmlns:a="http://schemas.openxmlformats.org/drawingml/2006/main"/>
           <a:p xmlns:a="http://schemas.openxmlformats.org/drawingml/2006/main">
             <a:pPr algn="ctr" rtl="1">
-              <a:defRPr sz="2475" b="0" lang="he-IL">
+              <a:defRPr sz="2250" b="0" lang="he-IL">
                 <a:solidFill>
                   <a:srgbClr val="F7F7F2"/>
                 </a:solidFill>
@@ -14332,7 +14332,7 @@
               </a:defRPr>
             </a:pPr>
             <a:r>
-              <a:rPr sz="2475" b="0" lang="he-IL">
+              <a:rPr sz="2250" b="0" lang="he-IL">
                 <a:solidFill>
                   <a:srgbClr val="F7F7F2"/>
                 </a:solidFill>
@@ -14340,7 +14340,30 @@
                 <a:ea typeface="Heebo"/>
                 <a:cs typeface="Heebo"/>
               </a:rPr>
-              <a:t>14.9 · היום בזום</a:t>
+              <a:t>יום שני, ג׳ בתשרי תשפ״ז (14.9.2026)</a:t>
+            </a:r>
+          </a:p>
+          <a:p xmlns:a="http://schemas.openxmlformats.org/drawingml/2006/main">
+            <a:pPr algn="ctr" rtl="1">
+              <a:defRPr sz="2250" b="0" lang="he-IL">
+                <a:solidFill>
+                  <a:srgbClr val="F7F7F2"/>
+                </a:solidFill>
+                <a:latin typeface="Heebo"/>
+                <a:ea typeface="Heebo"/>
+                <a:cs typeface="Heebo"/>
+              </a:defRPr>
+            </a:pPr>
+            <a:r>
+              <a:rPr sz="2250" b="0" lang="he-IL">
+                <a:solidFill>
+                  <a:srgbClr val="F7F7F2"/>
+                </a:solidFill>
+                <a:latin typeface="Heebo"/>
+                <a:ea typeface="Heebo"/>
+                <a:cs typeface="Heebo"/>
+              </a:rPr>
+              <a:t>היום בזום</a:t>
             </a:r>
           </a:p>
         </p:txBody>
@@ -14350,19 +14373,19 @@
           <p:cNvPr id="4" name="text">
             <a:extLst xmlns:a="http://schemas.openxmlformats.org/drawingml/2006/main">
               <a:ext uri="{FF2B5EF4-FFF2-40B4-BE49-F238E27FC236}">
-                <a16:creationId xmlns:a16="http://schemas.microsoft.com/office/drawing/2014/main" id="{A8C13873-2ED3-48E7-B189-1E58E762DDFE}"/>
-              </a:ext>
-            </a:extLst>
-          </p:cNvPr>
-          <p:cNvSpPr>
-            <a:spLocks xmlns:a="http://schemas.openxmlformats.org/drawingml/2006/main" noGrp="1"/>
-          </p:cNvSpPr>
-          <p:nvPr/>
-        </p:nvSpPr>
-        <p:spPr>
-          <a:xfrm xmlns:a="http://schemas.openxmlformats.org/drawingml/2006/main">
-            <a:off x="857250" y="3190875"/>
-            <a:ext cx="10477500" cy="542925"/>
+                <a16:creationId xmlns:a16="http://schemas.microsoft.com/office/drawing/2014/main" id="{539A62B7-35A8-4976-AADA-99073976BCAD}"/>
+              </a:ext>
+            </a:extLst>
+          </p:cNvPr>
+          <p:cNvSpPr>
+            <a:spLocks xmlns:a="http://schemas.openxmlformats.org/drawingml/2006/main" noGrp="1"/>
+          </p:cNvSpPr>
+          <p:nvPr/>
+        </p:nvSpPr>
+        <p:spPr>
+          <a:xfrm xmlns:a="http://schemas.openxmlformats.org/drawingml/2006/main">
+            <a:off x="857250" y="3467100"/>
+            <a:ext cx="10477500" cy="781050"/>
           </a:xfrm>
           <a:prstGeom xmlns:a="http://schemas.openxmlformats.org/drawingml/2006/main" prst="rect">
             <a:avLst/>
@@ -14379,7 +14402,7 @@
           <a:lstStyle xmlns:a="http://schemas.openxmlformats.org/drawingml/2006/main"/>
           <a:p xmlns:a="http://schemas.openxmlformats.org/drawingml/2006/main">
             <a:pPr algn="ctr" rtl="1">
-              <a:defRPr sz="2475" b="0" lang="he-IL">
+              <a:defRPr sz="2250" b="0" lang="he-IL">
                 <a:solidFill>
                   <a:srgbClr val="F7F7F2"/>
                 </a:solidFill>
@@ -14389,7 +14412,7 @@
               </a:defRPr>
             </a:pPr>
             <a:r>
-              <a:rPr sz="2475" b="0" lang="he-IL">
+              <a:rPr sz="2250" b="0" lang="he-IL">
                 <a:solidFill>
                   <a:srgbClr val="F7F7F2"/>
                 </a:solidFill>
@@ -14397,7 +14420,30 @@
                 <a:ea typeface="Heebo"/>
                 <a:cs typeface="Heebo"/>
               </a:rPr>
-              <a:t>17.9 · מתוכנן, טעון בדיקה בגלל מופע סליחות</a:t>
+              <a:t>יום חמישי, ו׳ בתשרי תשפ״ז (17.9.2026)</a:t>
+            </a:r>
+          </a:p>
+          <a:p xmlns:a="http://schemas.openxmlformats.org/drawingml/2006/main">
+            <a:pPr algn="ctr" rtl="1">
+              <a:defRPr sz="2250" b="0" lang="he-IL">
+                <a:solidFill>
+                  <a:srgbClr val="F7F7F2"/>
+                </a:solidFill>
+                <a:latin typeface="Heebo"/>
+                <a:ea typeface="Heebo"/>
+                <a:cs typeface="Heebo"/>
+              </a:defRPr>
+            </a:pPr>
+            <a:r>
+              <a:rPr sz="2250" b="0" lang="he-IL">
+                <a:solidFill>
+                  <a:srgbClr val="F7F7F2"/>
+                </a:solidFill>
+                <a:latin typeface="Heebo"/>
+                <a:ea typeface="Heebo"/>
+                <a:cs typeface="Heebo"/>
+              </a:rPr>
+              <a:t>טעון בדיקה בגלל מופע סליחות</a:t>
             </a:r>
           </a:p>
         </p:txBody>
@@ -14407,19 +14453,19 @@
           <p:cNvPr id="5" name="text">
             <a:extLst xmlns:a="http://schemas.openxmlformats.org/drawingml/2006/main">
               <a:ext uri="{FF2B5EF4-FFF2-40B4-BE49-F238E27FC236}">
-                <a16:creationId xmlns:a16="http://schemas.microsoft.com/office/drawing/2014/main" id="{657695CF-DBB3-451B-A89A-2932802033D0}"/>
-              </a:ext>
-            </a:extLst>
-          </p:cNvPr>
-          <p:cNvSpPr>
-            <a:spLocks xmlns:a="http://schemas.openxmlformats.org/drawingml/2006/main" noGrp="1"/>
-          </p:cNvSpPr>
-          <p:nvPr/>
-        </p:nvSpPr>
-        <p:spPr>
-          <a:xfrm xmlns:a="http://schemas.openxmlformats.org/drawingml/2006/main">
-            <a:off x="857250" y="3790950"/>
-            <a:ext cx="10477500" cy="542925"/>
+                <a16:creationId xmlns:a16="http://schemas.microsoft.com/office/drawing/2014/main" id="{967EE3EA-1863-4D7E-8300-D2CE3E7F3629}"/>
+              </a:ext>
+            </a:extLst>
+          </p:cNvPr>
+          <p:cNvSpPr>
+            <a:spLocks xmlns:a="http://schemas.openxmlformats.org/drawingml/2006/main" noGrp="1"/>
+          </p:cNvSpPr>
+          <p:nvPr/>
+        </p:nvSpPr>
+        <p:spPr>
+          <a:xfrm xmlns:a="http://schemas.openxmlformats.org/drawingml/2006/main">
+            <a:off x="857250" y="4343400"/>
+            <a:ext cx="10477500" cy="781050"/>
           </a:xfrm>
           <a:prstGeom xmlns:a="http://schemas.openxmlformats.org/drawingml/2006/main" prst="rect">
             <a:avLst/>
@@ -14436,7 +14482,7 @@
           <a:lstStyle xmlns:a="http://schemas.openxmlformats.org/drawingml/2006/main"/>
           <a:p xmlns:a="http://schemas.openxmlformats.org/drawingml/2006/main">
             <a:pPr algn="ctr" rtl="1">
-              <a:defRPr sz="2475" b="0" lang="he-IL">
+              <a:defRPr sz="2250" b="0" lang="he-IL">
                 <a:solidFill>
                   <a:srgbClr val="F7F7F2"/>
                 </a:solidFill>
@@ -14446,7 +14492,7 @@
               </a:defRPr>
             </a:pPr>
             <a:r>
-              <a:rPr sz="2475" b="0" lang="he-IL">
+              <a:rPr sz="2250" b="0" lang="he-IL">
                 <a:solidFill>
                   <a:srgbClr val="F7F7F2"/>
                 </a:solidFill>
@@ -14454,7 +14500,30 @@
                 <a:ea typeface="Heebo"/>
                 <a:cs typeface="Heebo"/>
               </a:rPr>
-              <a:t>5.10 · המפגש האחרון לפני המבחן</a:t>
+              <a:t>יום שני, כ״ד בתשרי תשפ״ז (5.10.2026)</a:t>
+            </a:r>
+          </a:p>
+          <a:p xmlns:a="http://schemas.openxmlformats.org/drawingml/2006/main">
+            <a:pPr algn="ctr" rtl="1">
+              <a:defRPr sz="2250" b="0" lang="he-IL">
+                <a:solidFill>
+                  <a:srgbClr val="F7F7F2"/>
+                </a:solidFill>
+                <a:latin typeface="Heebo"/>
+                <a:ea typeface="Heebo"/>
+                <a:cs typeface="Heebo"/>
+              </a:defRPr>
+            </a:pPr>
+            <a:r>
+              <a:rPr sz="2250" b="0" lang="he-IL">
+                <a:solidFill>
+                  <a:srgbClr val="F7F7F2"/>
+                </a:solidFill>
+                <a:latin typeface="Heebo"/>
+                <a:ea typeface="Heebo"/>
+                <a:cs typeface="Heebo"/>
+              </a:rPr>
+              <a:t>המפגש האחרון לפני המבחן</a:t>
             </a:r>
           </a:p>
         </p:txBody>
@@ -14464,19 +14533,19 @@
           <p:cNvPr id="6" name="text">
             <a:extLst xmlns:a="http://schemas.openxmlformats.org/drawingml/2006/main">
               <a:ext uri="{FF2B5EF4-FFF2-40B4-BE49-F238E27FC236}">
-                <a16:creationId xmlns:a16="http://schemas.microsoft.com/office/drawing/2014/main" id="{1DC9E2CE-8FAB-4258-9B39-AFD08B4FD061}"/>
-              </a:ext>
-            </a:extLst>
-          </p:cNvPr>
-          <p:cNvSpPr>
-            <a:spLocks xmlns:a="http://schemas.openxmlformats.org/drawingml/2006/main" noGrp="1"/>
-          </p:cNvSpPr>
-          <p:nvPr/>
-        </p:nvSpPr>
-        <p:spPr>
-          <a:xfrm xmlns:a="http://schemas.openxmlformats.org/drawingml/2006/main">
-            <a:off x="857250" y="5191125"/>
-            <a:ext cx="10477500" cy="714375"/>
+                <a16:creationId xmlns:a16="http://schemas.microsoft.com/office/drawing/2014/main" id="{50D0E964-06B2-4EE2-AB09-A1DC91606EA8}"/>
+              </a:ext>
+            </a:extLst>
+          </p:cNvPr>
+          <p:cNvSpPr>
+            <a:spLocks xmlns:a="http://schemas.openxmlformats.org/drawingml/2006/main" noGrp="1"/>
+          </p:cNvSpPr>
+          <p:nvPr/>
+        </p:nvSpPr>
+        <p:spPr>
+          <a:xfrm xmlns:a="http://schemas.openxmlformats.org/drawingml/2006/main">
+            <a:off x="857250" y="5267325"/>
+            <a:ext cx="10477500" cy="638175"/>
           </a:xfrm>
           <a:prstGeom xmlns:a="http://schemas.openxmlformats.org/drawingml/2006/main" prst="rect">
             <a:avLst/>
@@ -14493,7 +14562,7 @@
           <a:lstStyle xmlns:a="http://schemas.openxmlformats.org/drawingml/2006/main"/>
           <a:p xmlns:a="http://schemas.openxmlformats.org/drawingml/2006/main">
             <a:pPr algn="ctr" rtl="1">
-              <a:defRPr sz="1875" b="0" lang="he-IL">
+              <a:defRPr sz="1800" b="0" lang="he-IL">
                 <a:solidFill>
                   <a:srgbClr val="A9BDD2"/>
                 </a:solidFill>
@@ -14503,7 +14572,7 @@
               </a:defRPr>
             </a:pPr>
             <a:r>
-              <a:rPr sz="1875" b="0" lang="he-IL">
+              <a:rPr sz="1800" b="0" lang="he-IL">
                 <a:solidFill>
                   <a:srgbClr val="A9BDD2"/>
                 </a:solidFill>
@@ -14511,7 +14580,7 @@
                 <a:ea typeface="Heebo"/>
                 <a:cs typeface="Heebo"/>
               </a:rPr>
-              <a:t>כולל היום. אם המפגש ב־17.9 יתבטל, יישארו רק שני מפגשים כולל היום.</a:t>
+              <a:t>כולל היום. אם המפגש השני יתבטל, יישארו שני מפגשים כולל היום.</a:t>
             </a:r>
           </a:p>
         </p:txBody>
@@ -14521,7 +14590,7 @@
           <p:cNvPr id="7" name="text">
             <a:extLst xmlns:a="http://schemas.openxmlformats.org/drawingml/2006/main">
               <a:ext uri="{FF2B5EF4-FFF2-40B4-BE49-F238E27FC236}">
-                <a16:creationId xmlns:a16="http://schemas.microsoft.com/office/drawing/2014/main" id="{D57E9218-418E-4414-BD3B-1EB561A8ED68}"/>
+                <a16:creationId xmlns:a16="http://schemas.microsoft.com/office/drawing/2014/main" id="{BEA4C5E8-6A4F-4490-ADE8-47F83D7FDC8C}"/>
               </a:ext>
             </a:extLst>
           </p:cNvPr>
@@ -14576,7 +14645,7 @@
     </p:spTree>
     <p:extLst>
       <p:ext uri="{BB962C8B-B14F-4D97-AF65-F5344CB8AC3E}">
-        <p14:creationId xmlns:p14="http://schemas.microsoft.com/office/powerpoint/2010/main" val="1537063643"/>
+        <p14:creationId xmlns:p14="http://schemas.microsoft.com/office/powerpoint/2010/main" val="1114147575"/>
       </p:ext>
     </p:extLst>
   </p:cSld>
@@ -14618,7 +14687,7 @@
           <p:cNvPr id="8" name="text">
             <a:extLst xmlns:a="http://schemas.openxmlformats.org/drawingml/2006/main">
               <a:ext uri="{FF2B5EF4-FFF2-40B4-BE49-F238E27FC236}">
-                <a16:creationId xmlns:a16="http://schemas.microsoft.com/office/drawing/2014/main" id="{618D237D-E4E2-435E-A028-74E47B297187}"/>
+                <a16:creationId xmlns:a16="http://schemas.microsoft.com/office/drawing/2014/main" id="{9FF4D086-76CA-4C11-B239-7564A3DDB62D}"/>
               </a:ext>
             </a:extLst>
           </p:cNvPr>
@@ -14675,7 +14744,7 @@
           <p:cNvPr id="2" name="text">
             <a:extLst xmlns:a="http://schemas.openxmlformats.org/drawingml/2006/main">
               <a:ext uri="{FF2B5EF4-FFF2-40B4-BE49-F238E27FC236}">
-                <a16:creationId xmlns:a16="http://schemas.microsoft.com/office/drawing/2014/main" id="{4E112274-CC6B-4D71-A4A9-06FF36686BF2}"/>
+                <a16:creationId xmlns:a16="http://schemas.microsoft.com/office/drawing/2014/main" id="{F5D34587-0A4A-4420-A7E5-8BFC24D9C2D1}"/>
               </a:ext>
             </a:extLst>
           </p:cNvPr>
@@ -14732,7 +14801,7 @@
           <p:cNvPr id="3" name="text">
             <a:extLst xmlns:a="http://schemas.openxmlformats.org/drawingml/2006/main">
               <a:ext uri="{FF2B5EF4-FFF2-40B4-BE49-F238E27FC236}">
-                <a16:creationId xmlns:a16="http://schemas.microsoft.com/office/drawing/2014/main" id="{71953FFE-91C4-47B4-9A0F-5708A9DC6F97}"/>
+                <a16:creationId xmlns:a16="http://schemas.microsoft.com/office/drawing/2014/main" id="{27788F42-8F86-4389-9110-C74068E2C977}"/>
               </a:ext>
             </a:extLst>
           </p:cNvPr>
@@ -14789,7 +14858,7 @@
           <p:cNvPr id="4" name="text">
             <a:extLst xmlns:a="http://schemas.openxmlformats.org/drawingml/2006/main">
               <a:ext uri="{FF2B5EF4-FFF2-40B4-BE49-F238E27FC236}">
-                <a16:creationId xmlns:a16="http://schemas.microsoft.com/office/drawing/2014/main" id="{EB7FA7BD-9B5E-4FB3-B2FF-FC00C8615B5B}"/>
+                <a16:creationId xmlns:a16="http://schemas.microsoft.com/office/drawing/2014/main" id="{89C0941A-398A-4870-8E9C-27825EA2399A}"/>
               </a:ext>
             </a:extLst>
           </p:cNvPr>
@@ -14846,7 +14915,7 @@
           <p:cNvPr id="5" name="text">
             <a:extLst xmlns:a="http://schemas.openxmlformats.org/drawingml/2006/main">
               <a:ext uri="{FF2B5EF4-FFF2-40B4-BE49-F238E27FC236}">
-                <a16:creationId xmlns:a16="http://schemas.microsoft.com/office/drawing/2014/main" id="{4407401C-7119-412E-8FB9-5D146DF65E1C}"/>
+                <a16:creationId xmlns:a16="http://schemas.microsoft.com/office/drawing/2014/main" id="{E540255C-5D42-41B2-A959-B8C3EE844393}"/>
               </a:ext>
             </a:extLst>
           </p:cNvPr>
@@ -14903,7 +14972,7 @@
           <p:cNvPr id="6" name="text">
             <a:extLst xmlns:a="http://schemas.openxmlformats.org/drawingml/2006/main">
               <a:ext uri="{FF2B5EF4-FFF2-40B4-BE49-F238E27FC236}">
-                <a16:creationId xmlns:a16="http://schemas.microsoft.com/office/drawing/2014/main" id="{47953016-3EC9-4F7D-8E97-CA662AEB9234}"/>
+                <a16:creationId xmlns:a16="http://schemas.microsoft.com/office/drawing/2014/main" id="{1DA1AADE-92A0-4B24-8F9D-DC269880C0E3}"/>
               </a:ext>
             </a:extLst>
           </p:cNvPr>
@@ -14960,7 +15029,7 @@
           <p:cNvPr id="7" name="text">
             <a:extLst xmlns:a="http://schemas.openxmlformats.org/drawingml/2006/main">
               <a:ext uri="{FF2B5EF4-FFF2-40B4-BE49-F238E27FC236}">
-                <a16:creationId xmlns:a16="http://schemas.microsoft.com/office/drawing/2014/main" id="{CFB20C20-3009-42F7-B567-4C34CB6F490F}"/>
+                <a16:creationId xmlns:a16="http://schemas.microsoft.com/office/drawing/2014/main" id="{E79D9981-9D22-4D9F-9131-972D21A997BA}"/>
               </a:ext>
             </a:extLst>
           </p:cNvPr>
@@ -15015,7 +15084,7 @@
     </p:spTree>
     <p:extLst>
       <p:ext uri="{BB962C8B-B14F-4D97-AF65-F5344CB8AC3E}">
-        <p14:creationId xmlns:p14="http://schemas.microsoft.com/office/powerpoint/2010/main" val="1812535867"/>
+        <p14:creationId xmlns:p14="http://schemas.microsoft.com/office/powerpoint/2010/main" val="22630848"/>
       </p:ext>
     </p:extLst>
   </p:cSld>
@@ -15057,7 +15126,7 @@
           <p:cNvPr id="8" name="text">
             <a:extLst xmlns:a="http://schemas.openxmlformats.org/drawingml/2006/main">
               <a:ext uri="{FF2B5EF4-FFF2-40B4-BE49-F238E27FC236}">
-                <a16:creationId xmlns:a16="http://schemas.microsoft.com/office/drawing/2014/main" id="{C8D582F7-7C7F-4AA9-AF3E-55B331C81DB9}"/>
+                <a16:creationId xmlns:a16="http://schemas.microsoft.com/office/drawing/2014/main" id="{69535079-286D-44F8-AFAF-8FA1B5B57368}"/>
               </a:ext>
             </a:extLst>
           </p:cNvPr>
@@ -15114,7 +15183,7 @@
           <p:cNvPr id="2" name="text">
             <a:extLst xmlns:a="http://schemas.openxmlformats.org/drawingml/2006/main">
               <a:ext uri="{FF2B5EF4-FFF2-40B4-BE49-F238E27FC236}">
-                <a16:creationId xmlns:a16="http://schemas.microsoft.com/office/drawing/2014/main" id="{01A60D11-4946-42F1-A630-0DF62749B34D}"/>
+                <a16:creationId xmlns:a16="http://schemas.microsoft.com/office/drawing/2014/main" id="{BEE5347A-67F0-43E2-AEC8-D88CE0A781F4}"/>
               </a:ext>
             </a:extLst>
           </p:cNvPr>
@@ -15171,7 +15240,7 @@
           <p:cNvPr id="3" name="text">
             <a:extLst xmlns:a="http://schemas.openxmlformats.org/drawingml/2006/main">
               <a:ext uri="{FF2B5EF4-FFF2-40B4-BE49-F238E27FC236}">
-                <a16:creationId xmlns:a16="http://schemas.microsoft.com/office/drawing/2014/main" id="{71232D95-D47D-4332-AD21-D1C805BD12EC}"/>
+                <a16:creationId xmlns:a16="http://schemas.microsoft.com/office/drawing/2014/main" id="{D693A656-2521-495B-AF4A-AD408421C739}"/>
               </a:ext>
             </a:extLst>
           </p:cNvPr>
@@ -15228,7 +15297,7 @@
           <p:cNvPr id="4" name="text">
             <a:extLst xmlns:a="http://schemas.openxmlformats.org/drawingml/2006/main">
               <a:ext uri="{FF2B5EF4-FFF2-40B4-BE49-F238E27FC236}">
-                <a16:creationId xmlns:a16="http://schemas.microsoft.com/office/drawing/2014/main" id="{5E0788E9-A26D-4E9A-B62A-8E75519ED7A8}"/>
+                <a16:creationId xmlns:a16="http://schemas.microsoft.com/office/drawing/2014/main" id="{964FFA90-456C-4DDE-908B-4BF1DBA0B2E4}"/>
               </a:ext>
             </a:extLst>
           </p:cNvPr>
@@ -15285,7 +15354,7 @@
           <p:cNvPr id="5" name="text">
             <a:extLst xmlns:a="http://schemas.openxmlformats.org/drawingml/2006/main">
               <a:ext uri="{FF2B5EF4-FFF2-40B4-BE49-F238E27FC236}">
-                <a16:creationId xmlns:a16="http://schemas.microsoft.com/office/drawing/2014/main" id="{B5F1E079-E2F6-49AE-AFED-6AC443578A2C}"/>
+                <a16:creationId xmlns:a16="http://schemas.microsoft.com/office/drawing/2014/main" id="{4BA0F52A-3BD7-4E5C-87F8-1B961DD149C0}"/>
               </a:ext>
             </a:extLst>
           </p:cNvPr>
@@ -15342,7 +15411,7 @@
           <p:cNvPr id="6" name="text">
             <a:extLst xmlns:a="http://schemas.openxmlformats.org/drawingml/2006/main">
               <a:ext uri="{FF2B5EF4-FFF2-40B4-BE49-F238E27FC236}">
-                <a16:creationId xmlns:a16="http://schemas.microsoft.com/office/drawing/2014/main" id="{D3B03B3C-3CC1-4D54-89BF-E865B9164281}"/>
+                <a16:creationId xmlns:a16="http://schemas.microsoft.com/office/drawing/2014/main" id="{CD6FA606-0CB1-4AA9-83AF-F7D8A69E215C}"/>
               </a:ext>
             </a:extLst>
           </p:cNvPr>
@@ -15399,7 +15468,7 @@
           <p:cNvPr id="7" name="text">
             <a:extLst xmlns:a="http://schemas.openxmlformats.org/drawingml/2006/main">
               <a:ext uri="{FF2B5EF4-FFF2-40B4-BE49-F238E27FC236}">
-                <a16:creationId xmlns:a16="http://schemas.microsoft.com/office/drawing/2014/main" id="{63667524-84AC-4CAF-B6FB-076CA13B7B6C}"/>
+                <a16:creationId xmlns:a16="http://schemas.microsoft.com/office/drawing/2014/main" id="{B97874A9-3131-4361-B046-6D9B36BB8805}"/>
               </a:ext>
             </a:extLst>
           </p:cNvPr>
@@ -15454,7 +15523,7 @@
     </p:spTree>
     <p:extLst>
       <p:ext uri="{BB962C8B-B14F-4D97-AF65-F5344CB8AC3E}">
-        <p14:creationId xmlns:p14="http://schemas.microsoft.com/office/powerpoint/2010/main" val="1707060921"/>
+        <p14:creationId xmlns:p14="http://schemas.microsoft.com/office/powerpoint/2010/main" val="162937422"/>
       </p:ext>
     </p:extLst>
   </p:cSld>
@@ -15496,7 +15565,7 @@
           <p:cNvPr id="4" name="text">
             <a:extLst xmlns:a="http://schemas.openxmlformats.org/drawingml/2006/main">
               <a:ext uri="{FF2B5EF4-FFF2-40B4-BE49-F238E27FC236}">
-                <a16:creationId xmlns:a16="http://schemas.microsoft.com/office/drawing/2014/main" id="{CB2ADDE9-854A-402A-837C-4F9B8A05554E}"/>
+                <a16:creationId xmlns:a16="http://schemas.microsoft.com/office/drawing/2014/main" id="{E93AF231-7254-4780-8D5B-BD117449CA65}"/>
               </a:ext>
             </a:extLst>
           </p:cNvPr>
@@ -15553,7 +15622,7 @@
           <p:cNvPr id="2" name="text">
             <a:extLst xmlns:a="http://schemas.openxmlformats.org/drawingml/2006/main">
               <a:ext uri="{FF2B5EF4-FFF2-40B4-BE49-F238E27FC236}">
-                <a16:creationId xmlns:a16="http://schemas.microsoft.com/office/drawing/2014/main" id="{5DD3D926-E2CD-4C74-9CF9-448F41EEDB2F}"/>
+                <a16:creationId xmlns:a16="http://schemas.microsoft.com/office/drawing/2014/main" id="{9F518FA2-6278-40E5-9048-644BCDAC48DF}"/>
               </a:ext>
             </a:extLst>
           </p:cNvPr>
@@ -15610,7 +15679,7 @@
           <p:cNvPr id="3" name="text">
             <a:extLst xmlns:a="http://schemas.openxmlformats.org/drawingml/2006/main">
               <a:ext uri="{FF2B5EF4-FFF2-40B4-BE49-F238E27FC236}">
-                <a16:creationId xmlns:a16="http://schemas.microsoft.com/office/drawing/2014/main" id="{DDC756CE-8E5F-4AAA-8C18-0556EAD2A79E}"/>
+                <a16:creationId xmlns:a16="http://schemas.microsoft.com/office/drawing/2014/main" id="{EF600F72-2819-4DE7-9338-CE1E7A1B6336}"/>
               </a:ext>
             </a:extLst>
           </p:cNvPr>
@@ -15665,7 +15734,7 @@
     </p:spTree>
     <p:extLst>
       <p:ext uri="{BB962C8B-B14F-4D97-AF65-F5344CB8AC3E}">
-        <p14:creationId xmlns:p14="http://schemas.microsoft.com/office/powerpoint/2010/main" val="913215615"/>
+        <p14:creationId xmlns:p14="http://schemas.microsoft.com/office/powerpoint/2010/main" val="1531088038"/>
       </p:ext>
     </p:extLst>
   </p:cSld>
@@ -15707,7 +15776,7 @@
           <p:cNvPr id="5" name="text">
             <a:extLst xmlns:a="http://schemas.openxmlformats.org/drawingml/2006/main">
               <a:ext uri="{FF2B5EF4-FFF2-40B4-BE49-F238E27FC236}">
-                <a16:creationId xmlns:a16="http://schemas.microsoft.com/office/drawing/2014/main" id="{D7BCC3E5-14D0-41C1-850F-23EA518C75A2}"/>
+                <a16:creationId xmlns:a16="http://schemas.microsoft.com/office/drawing/2014/main" id="{551038D3-0731-4270-B1D6-F35AEF05C56D}"/>
               </a:ext>
             </a:extLst>
           </p:cNvPr>
@@ -15764,7 +15833,7 @@
           <p:cNvPr id="2" name="text">
             <a:extLst xmlns:a="http://schemas.openxmlformats.org/drawingml/2006/main">
               <a:ext uri="{FF2B5EF4-FFF2-40B4-BE49-F238E27FC236}">
-                <a16:creationId xmlns:a16="http://schemas.microsoft.com/office/drawing/2014/main" id="{10779546-E297-4074-AFCC-D02F64BF3DA6}"/>
+                <a16:creationId xmlns:a16="http://schemas.microsoft.com/office/drawing/2014/main" id="{2FF95F32-1841-49C1-BAFA-70F84F51B05F}"/>
               </a:ext>
             </a:extLst>
           </p:cNvPr>
@@ -15821,7 +15890,7 @@
           <p:cNvPr id="3" name="text">
             <a:extLst xmlns:a="http://schemas.openxmlformats.org/drawingml/2006/main">
               <a:ext uri="{FF2B5EF4-FFF2-40B4-BE49-F238E27FC236}">
-                <a16:creationId xmlns:a16="http://schemas.microsoft.com/office/drawing/2014/main" id="{1E13B873-F7CB-4251-9626-68EA282D4230}"/>
+                <a16:creationId xmlns:a16="http://schemas.microsoft.com/office/drawing/2014/main" id="{426AFAF7-A840-4F57-A767-86D9E753CD16}"/>
               </a:ext>
             </a:extLst>
           </p:cNvPr>
@@ -15878,7 +15947,7 @@
           <p:cNvPr id="4" name="text">
             <a:extLst xmlns:a="http://schemas.openxmlformats.org/drawingml/2006/main">
               <a:ext uri="{FF2B5EF4-FFF2-40B4-BE49-F238E27FC236}">
-                <a16:creationId xmlns:a16="http://schemas.microsoft.com/office/drawing/2014/main" id="{E96107E3-FC3B-4541-9E30-66BF77F40A35}"/>
+                <a16:creationId xmlns:a16="http://schemas.microsoft.com/office/drawing/2014/main" id="{9DD77C6C-D3CE-49BC-B337-D008C41417B0}"/>
               </a:ext>
             </a:extLst>
           </p:cNvPr>
@@ -15933,7 +16002,7 @@
     </p:spTree>
     <p:extLst>
       <p:ext uri="{BB962C8B-B14F-4D97-AF65-F5344CB8AC3E}">
-        <p14:creationId xmlns:p14="http://schemas.microsoft.com/office/powerpoint/2010/main" val="1035718620"/>
+        <p14:creationId xmlns:p14="http://schemas.microsoft.com/office/powerpoint/2010/main" val="420390039"/>
       </p:ext>
     </p:extLst>
   </p:cSld>
@@ -15975,7 +16044,7 @@
           <p:cNvPr id="6" name="text">
             <a:extLst xmlns:a="http://schemas.openxmlformats.org/drawingml/2006/main">
               <a:ext uri="{FF2B5EF4-FFF2-40B4-BE49-F238E27FC236}">
-                <a16:creationId xmlns:a16="http://schemas.microsoft.com/office/drawing/2014/main" id="{E297687F-7B52-4C4E-9EC4-5B40E3A4000F}"/>
+                <a16:creationId xmlns:a16="http://schemas.microsoft.com/office/drawing/2014/main" id="{3E787DA9-BBC7-4BB5-A03E-35063DFF9F54}"/>
               </a:ext>
             </a:extLst>
           </p:cNvPr>
@@ -16032,7 +16101,7 @@
           <p:cNvPr id="2" name="text">
             <a:extLst xmlns:a="http://schemas.openxmlformats.org/drawingml/2006/main">
               <a:ext uri="{FF2B5EF4-FFF2-40B4-BE49-F238E27FC236}">
-                <a16:creationId xmlns:a16="http://schemas.microsoft.com/office/drawing/2014/main" id="{389CB119-F01A-44ED-A080-EDA7E6FB7750}"/>
+                <a16:creationId xmlns:a16="http://schemas.microsoft.com/office/drawing/2014/main" id="{BEAE0DA7-D110-405F-93E8-8A053962DFCD}"/>
               </a:ext>
             </a:extLst>
           </p:cNvPr>
@@ -16089,7 +16158,7 @@
           <p:cNvPr id="3" name="text">
             <a:extLst xmlns:a="http://schemas.openxmlformats.org/drawingml/2006/main">
               <a:ext uri="{FF2B5EF4-FFF2-40B4-BE49-F238E27FC236}">
-                <a16:creationId xmlns:a16="http://schemas.microsoft.com/office/drawing/2014/main" id="{1F7BD343-B8EB-4AA6-9597-2038B93F52AE}"/>
+                <a16:creationId xmlns:a16="http://schemas.microsoft.com/office/drawing/2014/main" id="{BF88D6AE-A4DD-4745-8A97-6B6524611F56}"/>
               </a:ext>
             </a:extLst>
           </p:cNvPr>
@@ -16146,7 +16215,7 @@
           <p:cNvPr id="4" name="text">
             <a:extLst xmlns:a="http://schemas.openxmlformats.org/drawingml/2006/main">
               <a:ext uri="{FF2B5EF4-FFF2-40B4-BE49-F238E27FC236}">
-                <a16:creationId xmlns:a16="http://schemas.microsoft.com/office/drawing/2014/main" id="{6C2D073A-7C12-4160-9355-32B02667D39F}"/>
+                <a16:creationId xmlns:a16="http://schemas.microsoft.com/office/drawing/2014/main" id="{7277A1AC-964D-4012-A83E-006E1A344866}"/>
               </a:ext>
             </a:extLst>
           </p:cNvPr>
@@ -16203,7 +16272,7 @@
           <p:cNvPr id="5" name="text">
             <a:extLst xmlns:a="http://schemas.openxmlformats.org/drawingml/2006/main">
               <a:ext uri="{FF2B5EF4-FFF2-40B4-BE49-F238E27FC236}">
-                <a16:creationId xmlns:a16="http://schemas.microsoft.com/office/drawing/2014/main" id="{F47B030D-D13C-4389-9E33-CAC0B464D9A4}"/>
+                <a16:creationId xmlns:a16="http://schemas.microsoft.com/office/drawing/2014/main" id="{A66FD051-8727-4EFA-A8BD-85D52991ED88}"/>
               </a:ext>
             </a:extLst>
           </p:cNvPr>
@@ -16258,7 +16327,7 @@
     </p:spTree>
     <p:extLst>
       <p:ext uri="{BB962C8B-B14F-4D97-AF65-F5344CB8AC3E}">
-        <p14:creationId xmlns:p14="http://schemas.microsoft.com/office/powerpoint/2010/main" val="1652107986"/>
+        <p14:creationId xmlns:p14="http://schemas.microsoft.com/office/powerpoint/2010/main" val="958505462"/>
       </p:ext>
     </p:extLst>
   </p:cSld>
@@ -16300,7 +16369,7 @@
           <p:cNvPr id="4" name="text">
             <a:extLst xmlns:a="http://schemas.openxmlformats.org/drawingml/2006/main">
               <a:ext uri="{FF2B5EF4-FFF2-40B4-BE49-F238E27FC236}">
-                <a16:creationId xmlns:a16="http://schemas.microsoft.com/office/drawing/2014/main" id="{A8869687-7FF7-4C81-AF57-DFE110CF06A2}"/>
+                <a16:creationId xmlns:a16="http://schemas.microsoft.com/office/drawing/2014/main" id="{D823B3B2-1482-49C6-8460-17DD0D7AB5FE}"/>
               </a:ext>
             </a:extLst>
           </p:cNvPr>
@@ -16357,7 +16426,7 @@
           <p:cNvPr id="2" name="text">
             <a:extLst xmlns:a="http://schemas.openxmlformats.org/drawingml/2006/main">
               <a:ext uri="{FF2B5EF4-FFF2-40B4-BE49-F238E27FC236}">
-                <a16:creationId xmlns:a16="http://schemas.microsoft.com/office/drawing/2014/main" id="{F3518581-033A-4EEE-921B-92AC5462369F}"/>
+                <a16:creationId xmlns:a16="http://schemas.microsoft.com/office/drawing/2014/main" id="{FD6F8D61-400F-43D4-9F9F-38C74A1A3A4C}"/>
               </a:ext>
             </a:extLst>
           </p:cNvPr>
@@ -16414,7 +16483,7 @@
           <p:cNvPr id="3" name="text">
             <a:extLst xmlns:a="http://schemas.openxmlformats.org/drawingml/2006/main">
               <a:ext uri="{FF2B5EF4-FFF2-40B4-BE49-F238E27FC236}">
-                <a16:creationId xmlns:a16="http://schemas.microsoft.com/office/drawing/2014/main" id="{5593432E-8444-49C9-BCD4-4EEE355A4ADE}"/>
+                <a16:creationId xmlns:a16="http://schemas.microsoft.com/office/drawing/2014/main" id="{DFEBB208-EFB3-4250-8114-A7594FC940B0}"/>
               </a:ext>
             </a:extLst>
           </p:cNvPr>
@@ -16469,7 +16538,7 @@
     </p:spTree>
     <p:extLst>
       <p:ext uri="{BB962C8B-B14F-4D97-AF65-F5344CB8AC3E}">
-        <p14:creationId xmlns:p14="http://schemas.microsoft.com/office/powerpoint/2010/main" val="1939298903"/>
+        <p14:creationId xmlns:p14="http://schemas.microsoft.com/office/powerpoint/2010/main" val="1688857736"/>
       </p:ext>
     </p:extLst>
   </p:cSld>
@@ -16511,7 +16580,7 @@
           <p:cNvPr id="4" name="text">
             <a:extLst xmlns:a="http://schemas.openxmlformats.org/drawingml/2006/main">
               <a:ext uri="{FF2B5EF4-FFF2-40B4-BE49-F238E27FC236}">
-                <a16:creationId xmlns:a16="http://schemas.microsoft.com/office/drawing/2014/main" id="{AFFB5BF1-8CE9-44FB-99E8-B84B4F491608}"/>
+                <a16:creationId xmlns:a16="http://schemas.microsoft.com/office/drawing/2014/main" id="{B49274D8-F9B6-4AD8-8246-956FF43BC46C}"/>
               </a:ext>
             </a:extLst>
           </p:cNvPr>
@@ -16568,7 +16637,7 @@
           <p:cNvPr id="2" name="text">
             <a:extLst xmlns:a="http://schemas.openxmlformats.org/drawingml/2006/main">
               <a:ext uri="{FF2B5EF4-FFF2-40B4-BE49-F238E27FC236}">
-                <a16:creationId xmlns:a16="http://schemas.microsoft.com/office/drawing/2014/main" id="{11F4C10F-049A-4BA6-A228-4FD1E15EEEC9}"/>
+                <a16:creationId xmlns:a16="http://schemas.microsoft.com/office/drawing/2014/main" id="{59604910-A4F1-4EB3-BA66-E06836F50C61}"/>
               </a:ext>
             </a:extLst>
           </p:cNvPr>
@@ -16625,7 +16694,7 @@
           <p:cNvPr id="3" name="text">
             <a:extLst xmlns:a="http://schemas.openxmlformats.org/drawingml/2006/main">
               <a:ext uri="{FF2B5EF4-FFF2-40B4-BE49-F238E27FC236}">
-                <a16:creationId xmlns:a16="http://schemas.microsoft.com/office/drawing/2014/main" id="{598AAF32-C2CD-4D4E-9B8D-12898E51A6D7}"/>
+                <a16:creationId xmlns:a16="http://schemas.microsoft.com/office/drawing/2014/main" id="{32FFC404-F645-4FB1-AA16-62580093215D}"/>
               </a:ext>
             </a:extLst>
           </p:cNvPr>
@@ -16680,7 +16749,7 @@
     </p:spTree>
     <p:extLst>
       <p:ext uri="{BB962C8B-B14F-4D97-AF65-F5344CB8AC3E}">
-        <p14:creationId xmlns:p14="http://schemas.microsoft.com/office/powerpoint/2010/main" val="480561946"/>
+        <p14:creationId xmlns:p14="http://schemas.microsoft.com/office/powerpoint/2010/main" val="372688791"/>
       </p:ext>
     </p:extLst>
   </p:cSld>
@@ -16722,7 +16791,7 @@
           <p:cNvPr id="4" name="text">
             <a:extLst xmlns:a="http://schemas.openxmlformats.org/drawingml/2006/main">
               <a:ext uri="{FF2B5EF4-FFF2-40B4-BE49-F238E27FC236}">
-                <a16:creationId xmlns:a16="http://schemas.microsoft.com/office/drawing/2014/main" id="{5410277E-3D79-41B2-A2C5-63B288BB620B}"/>
+                <a16:creationId xmlns:a16="http://schemas.microsoft.com/office/drawing/2014/main" id="{5D7A6B31-FBD9-4E58-B9D5-B3F527900097}"/>
               </a:ext>
             </a:extLst>
           </p:cNvPr>
@@ -16779,7 +16848,7 @@
           <p:cNvPr id="2" name="text">
             <a:extLst xmlns:a="http://schemas.openxmlformats.org/drawingml/2006/main">
               <a:ext uri="{FF2B5EF4-FFF2-40B4-BE49-F238E27FC236}">
-                <a16:creationId xmlns:a16="http://schemas.microsoft.com/office/drawing/2014/main" id="{3961B2E7-E430-4CC3-BBDF-DAFFBA406E05}"/>
+                <a16:creationId xmlns:a16="http://schemas.microsoft.com/office/drawing/2014/main" id="{B61B6924-E871-4621-AB2E-AB9C3402D065}"/>
               </a:ext>
             </a:extLst>
           </p:cNvPr>
@@ -16836,7 +16905,7 @@
           <p:cNvPr id="3" name="text">
             <a:extLst xmlns:a="http://schemas.openxmlformats.org/drawingml/2006/main">
               <a:ext uri="{FF2B5EF4-FFF2-40B4-BE49-F238E27FC236}">
-                <a16:creationId xmlns:a16="http://schemas.microsoft.com/office/drawing/2014/main" id="{BF0BCE8C-CE3C-4E0E-81D4-2125415D0943}"/>
+                <a16:creationId xmlns:a16="http://schemas.microsoft.com/office/drawing/2014/main" id="{5AA1BEE4-A412-4E1D-A9B5-8B7AF58CB3C4}"/>
               </a:ext>
             </a:extLst>
           </p:cNvPr>
@@ -16891,7 +16960,7 @@
     </p:spTree>
     <p:extLst>
       <p:ext uri="{BB962C8B-B14F-4D97-AF65-F5344CB8AC3E}">
-        <p14:creationId xmlns:p14="http://schemas.microsoft.com/office/powerpoint/2010/main" val="1112181594"/>
+        <p14:creationId xmlns:p14="http://schemas.microsoft.com/office/powerpoint/2010/main" val="1300161151"/>
       </p:ext>
     </p:extLst>
   </p:cSld>
@@ -16933,7 +17002,7 @@
           <p:cNvPr id="5" name="text">
             <a:extLst xmlns:a="http://schemas.openxmlformats.org/drawingml/2006/main">
               <a:ext uri="{FF2B5EF4-FFF2-40B4-BE49-F238E27FC236}">
-                <a16:creationId xmlns:a16="http://schemas.microsoft.com/office/drawing/2014/main" id="{75C78ED1-F11B-4961-B17C-10E757F0B83C}"/>
+                <a16:creationId xmlns:a16="http://schemas.microsoft.com/office/drawing/2014/main" id="{F0C4ACA8-6835-4405-B881-81717E324609}"/>
               </a:ext>
             </a:extLst>
           </p:cNvPr>
@@ -16990,7 +17059,7 @@
           <p:cNvPr id="2" name="text">
             <a:extLst xmlns:a="http://schemas.openxmlformats.org/drawingml/2006/main">
               <a:ext uri="{FF2B5EF4-FFF2-40B4-BE49-F238E27FC236}">
-                <a16:creationId xmlns:a16="http://schemas.microsoft.com/office/drawing/2014/main" id="{51BA716F-2772-435D-B59E-A520A8D8B898}"/>
+                <a16:creationId xmlns:a16="http://schemas.microsoft.com/office/drawing/2014/main" id="{1C9FE41C-7D1A-4117-96E4-97485BB941DD}"/>
               </a:ext>
             </a:extLst>
           </p:cNvPr>
@@ -17047,7 +17116,7 @@
           <p:cNvPr id="3" name="text">
             <a:extLst xmlns:a="http://schemas.openxmlformats.org/drawingml/2006/main">
               <a:ext uri="{FF2B5EF4-FFF2-40B4-BE49-F238E27FC236}">
-                <a16:creationId xmlns:a16="http://schemas.microsoft.com/office/drawing/2014/main" id="{89BE6E5B-9162-4694-AEAF-C3CC8E068C65}"/>
+                <a16:creationId xmlns:a16="http://schemas.microsoft.com/office/drawing/2014/main" id="{65A0F265-2819-4DD1-A921-9699F518D464}"/>
               </a:ext>
             </a:extLst>
           </p:cNvPr>
@@ -17104,7 +17173,7 @@
           <p:cNvPr id="4" name="text">
             <a:extLst xmlns:a="http://schemas.openxmlformats.org/drawingml/2006/main">
               <a:ext uri="{FF2B5EF4-FFF2-40B4-BE49-F238E27FC236}">
-                <a16:creationId xmlns:a16="http://schemas.microsoft.com/office/drawing/2014/main" id="{46C11868-B92F-4124-A6EF-C9C1D628658A}"/>
+                <a16:creationId xmlns:a16="http://schemas.microsoft.com/office/drawing/2014/main" id="{15A1B1CE-AD48-4E93-A103-4F75C1EEC4A8}"/>
               </a:ext>
             </a:extLst>
           </p:cNvPr>
@@ -17159,7 +17228,7 @@
     </p:spTree>
     <p:extLst>
       <p:ext uri="{BB962C8B-B14F-4D97-AF65-F5344CB8AC3E}">
-        <p14:creationId xmlns:p14="http://schemas.microsoft.com/office/powerpoint/2010/main" val="2124761407"/>
+        <p14:creationId xmlns:p14="http://schemas.microsoft.com/office/powerpoint/2010/main" val="551720951"/>
       </p:ext>
     </p:extLst>
   </p:cSld>
@@ -17201,7 +17270,7 @@
           <p:cNvPr id="6" name="text">
             <a:extLst xmlns:a="http://schemas.openxmlformats.org/drawingml/2006/main">
               <a:ext uri="{FF2B5EF4-FFF2-40B4-BE49-F238E27FC236}">
-                <a16:creationId xmlns:a16="http://schemas.microsoft.com/office/drawing/2014/main" id="{FEDEDCE6-1F92-4A19-A9D2-FBF6617C08F6}"/>
+                <a16:creationId xmlns:a16="http://schemas.microsoft.com/office/drawing/2014/main" id="{67664A3D-0DA9-4091-B364-88AC1C620A63}"/>
               </a:ext>
             </a:extLst>
           </p:cNvPr>
@@ -17258,7 +17327,7 @@
           <p:cNvPr id="2" name="text">
             <a:extLst xmlns:a="http://schemas.openxmlformats.org/drawingml/2006/main">
               <a:ext uri="{FF2B5EF4-FFF2-40B4-BE49-F238E27FC236}">
-                <a16:creationId xmlns:a16="http://schemas.microsoft.com/office/drawing/2014/main" id="{233C31AE-CAF1-40B6-A4B1-99448A9D9FD9}"/>
+                <a16:creationId xmlns:a16="http://schemas.microsoft.com/office/drawing/2014/main" id="{663879A0-0264-44BC-A936-970EA6936C62}"/>
               </a:ext>
             </a:extLst>
           </p:cNvPr>
@@ -17315,7 +17384,7 @@
           <p:cNvPr id="3" name="text">
             <a:extLst xmlns:a="http://schemas.openxmlformats.org/drawingml/2006/main">
               <a:ext uri="{FF2B5EF4-FFF2-40B4-BE49-F238E27FC236}">
-                <a16:creationId xmlns:a16="http://schemas.microsoft.com/office/drawing/2014/main" id="{F541A0EB-5DE7-4EA0-8050-430785A61908}"/>
+                <a16:creationId xmlns:a16="http://schemas.microsoft.com/office/drawing/2014/main" id="{56808D7D-CD62-4596-B690-64FFFD7E9D7E}"/>
               </a:ext>
             </a:extLst>
           </p:cNvPr>
@@ -17372,7 +17441,7 @@
           <p:cNvPr id="4" name="text">
             <a:extLst xmlns:a="http://schemas.openxmlformats.org/drawingml/2006/main">
               <a:ext uri="{FF2B5EF4-FFF2-40B4-BE49-F238E27FC236}">
-                <a16:creationId xmlns:a16="http://schemas.microsoft.com/office/drawing/2014/main" id="{67AD5A27-6357-45CE-8A55-D5560CD868E9}"/>
+                <a16:creationId xmlns:a16="http://schemas.microsoft.com/office/drawing/2014/main" id="{6F39ECFA-4212-4A02-94A3-9786C58D5CFB}"/>
               </a:ext>
             </a:extLst>
           </p:cNvPr>
@@ -17429,7 +17498,7 @@
           <p:cNvPr id="5" name="text">
             <a:extLst xmlns:a="http://schemas.openxmlformats.org/drawingml/2006/main">
               <a:ext uri="{FF2B5EF4-FFF2-40B4-BE49-F238E27FC236}">
-                <a16:creationId xmlns:a16="http://schemas.microsoft.com/office/drawing/2014/main" id="{794D858E-B2B0-4F5F-9398-567AD02F2202}"/>
+                <a16:creationId xmlns:a16="http://schemas.microsoft.com/office/drawing/2014/main" id="{B5B077E2-3301-4BAD-837A-1FC32444F169}"/>
               </a:ext>
             </a:extLst>
           </p:cNvPr>
@@ -17484,7 +17553,7 @@
     </p:spTree>
     <p:extLst>
       <p:ext uri="{BB962C8B-B14F-4D97-AF65-F5344CB8AC3E}">
-        <p14:creationId xmlns:p14="http://schemas.microsoft.com/office/powerpoint/2010/main" val="623477299"/>
+        <p14:creationId xmlns:p14="http://schemas.microsoft.com/office/powerpoint/2010/main" val="634826128"/>
       </p:ext>
     </p:extLst>
   </p:cSld>
@@ -17526,7 +17595,7 @@
           <p:cNvPr id="8" name="text">
             <a:extLst xmlns:a="http://schemas.openxmlformats.org/drawingml/2006/main">
               <a:ext uri="{FF2B5EF4-FFF2-40B4-BE49-F238E27FC236}">
-                <a16:creationId xmlns:a16="http://schemas.microsoft.com/office/drawing/2014/main" id="{B283E7AF-97A4-46DA-9E1A-2DA6F2280522}"/>
+                <a16:creationId xmlns:a16="http://schemas.microsoft.com/office/drawing/2014/main" id="{9B8DBBCE-154B-4735-8D7A-6F9E0B8F28CD}"/>
               </a:ext>
             </a:extLst>
           </p:cNvPr>
@@ -17583,7 +17652,7 @@
           <p:cNvPr id="2" name="text">
             <a:extLst xmlns:a="http://schemas.openxmlformats.org/drawingml/2006/main">
               <a:ext uri="{FF2B5EF4-FFF2-40B4-BE49-F238E27FC236}">
-                <a16:creationId xmlns:a16="http://schemas.microsoft.com/office/drawing/2014/main" id="{26CCDF56-E242-4660-B226-01321798E082}"/>
+                <a16:creationId xmlns:a16="http://schemas.microsoft.com/office/drawing/2014/main" id="{574EC1A0-2625-4BFF-B06C-873E73756E99}"/>
               </a:ext>
             </a:extLst>
           </p:cNvPr>
@@ -17630,7 +17699,7 @@
                 <a:ea typeface="Heebo"/>
                 <a:cs typeface="Heebo"/>
               </a:rPr>
-              <a:t>ההכנה שלנו למבחן</a:t>
+              <a:t>מה מתרגלים היום?</a:t>
             </a:r>
           </a:p>
         </p:txBody>
@@ -17640,7 +17709,7 @@
           <p:cNvPr id="3" name="text">
             <a:extLst xmlns:a="http://schemas.openxmlformats.org/drawingml/2006/main">
               <a:ext uri="{FF2B5EF4-FFF2-40B4-BE49-F238E27FC236}">
-                <a16:creationId xmlns:a16="http://schemas.microsoft.com/office/drawing/2014/main" id="{840563D8-FAB0-42D3-9E1D-A0058AD03A39}"/>
+                <a16:creationId xmlns:a16="http://schemas.microsoft.com/office/drawing/2014/main" id="{846E43CA-7E5B-430D-BA75-C11CF54F421D}"/>
               </a:ext>
             </a:extLst>
           </p:cNvPr>
@@ -17687,7 +17756,7 @@
                 <a:ea typeface="Heebo"/>
                 <a:cs typeface="Heebo"/>
               </a:rPr>
-              <a:t>אוצר מילים וקבלת מידע מטקסט</a:t>
+              <a:t>אוצר מילים והבנת הנקרא</a:t>
             </a:r>
           </a:p>
         </p:txBody>
@@ -17697,7 +17766,7 @@
           <p:cNvPr id="4" name="text">
             <a:extLst xmlns:a="http://schemas.openxmlformats.org/drawingml/2006/main">
               <a:ext uri="{FF2B5EF4-FFF2-40B4-BE49-F238E27FC236}">
-                <a16:creationId xmlns:a16="http://schemas.microsoft.com/office/drawing/2014/main" id="{731B68C7-1E8A-47C6-8B83-AB7397AA9B1C}"/>
+                <a16:creationId xmlns:a16="http://schemas.microsoft.com/office/drawing/2014/main" id="{FA8D3AE7-D8F9-4753-A587-D2202D9B4C79}"/>
               </a:ext>
             </a:extLst>
           </p:cNvPr>
@@ -17754,7 +17823,7 @@
           <p:cNvPr id="5" name="text">
             <a:extLst xmlns:a="http://schemas.openxmlformats.org/drawingml/2006/main">
               <a:ext uri="{FF2B5EF4-FFF2-40B4-BE49-F238E27FC236}">
-                <a16:creationId xmlns:a16="http://schemas.microsoft.com/office/drawing/2014/main" id="{42194105-2C4E-4DAE-AAF3-FFEC64682E93}"/>
+                <a16:creationId xmlns:a16="http://schemas.microsoft.com/office/drawing/2014/main" id="{32A736D9-E9A4-431C-A7AB-B03B97A204D8}"/>
               </a:ext>
             </a:extLst>
           </p:cNvPr>
@@ -17811,7 +17880,7 @@
           <p:cNvPr id="6" name="text">
             <a:extLst xmlns:a="http://schemas.openxmlformats.org/drawingml/2006/main">
               <a:ext uri="{FF2B5EF4-FFF2-40B4-BE49-F238E27FC236}">
-                <a16:creationId xmlns:a16="http://schemas.microsoft.com/office/drawing/2014/main" id="{6887139C-55ED-48A4-B9F3-980095FF7FC5}"/>
+                <a16:creationId xmlns:a16="http://schemas.microsoft.com/office/drawing/2014/main" id="{64E9B3E0-7634-43A9-A48D-1FA8DB2E90DA}"/>
               </a:ext>
             </a:extLst>
           </p:cNvPr>
@@ -17858,7 +17927,7 @@
                 <a:ea typeface="Heebo"/>
                 <a:cs typeface="Heebo"/>
               </a:rPr>
-              <a:t>היום מתרגלים עם The Monkey Festival ממבחן אוקטובר שבארכיון.</a:t>
+              <a:t>הטקסט מהארכיון מיועד לתרגול. פירוט החומר למבחן יימסר בנפרד.</a:t>
             </a:r>
           </a:p>
         </p:txBody>
@@ -17868,7 +17937,7 @@
           <p:cNvPr id="7" name="text">
             <a:extLst xmlns:a="http://schemas.openxmlformats.org/drawingml/2006/main">
               <a:ext uri="{FF2B5EF4-FFF2-40B4-BE49-F238E27FC236}">
-                <a16:creationId xmlns:a16="http://schemas.microsoft.com/office/drawing/2014/main" id="{F59FF01F-74E3-4BA7-B209-4E58B4DA9929}"/>
+                <a16:creationId xmlns:a16="http://schemas.microsoft.com/office/drawing/2014/main" id="{FAFAB66F-FB83-4F2B-91A8-04F205BED73F}"/>
               </a:ext>
             </a:extLst>
           </p:cNvPr>
@@ -17923,7 +17992,7 @@
     </p:spTree>
     <p:extLst>
       <p:ext uri="{BB962C8B-B14F-4D97-AF65-F5344CB8AC3E}">
-        <p14:creationId xmlns:p14="http://schemas.microsoft.com/office/powerpoint/2010/main" val="2092244424"/>
+        <p14:creationId xmlns:p14="http://schemas.microsoft.com/office/powerpoint/2010/main" val="352279533"/>
       </p:ext>
     </p:extLst>
   </p:cSld>
@@ -17969,7 +18038,7 @@
           <p:nvPr/>
         </p:nvPicPr>
         <p:blipFill>
-          <a:blip xmlns:r="http://schemas.openxmlformats.org/officeDocument/2006/relationships" xmlns:a="http://schemas.openxmlformats.org/drawingml/2006/main" r:embed="R8f221244f61e4962"/>
+          <a:blip xmlns:r="http://schemas.openxmlformats.org/officeDocument/2006/relationships" xmlns:a="http://schemas.openxmlformats.org/drawingml/2006/main" r:embed="R5946cfccb3524da5"/>
           <a:stretch xmlns:a="http://schemas.openxmlformats.org/drawingml/2006/main"/>
         </p:blipFill>
         <p:spPr>
@@ -17985,7 +18054,7 @@
     </p:spTree>
     <p:extLst>
       <p:ext uri="{BB962C8B-B14F-4D97-AF65-F5344CB8AC3E}">
-        <p14:creationId xmlns:p14="http://schemas.microsoft.com/office/powerpoint/2010/main" val="832684499"/>
+        <p14:creationId xmlns:p14="http://schemas.microsoft.com/office/powerpoint/2010/main" val="135954714"/>
       </p:ext>
     </p:extLst>
   </p:cSld>
@@ -18027,7 +18096,7 @@
           <p:cNvPr id="4" name="text">
             <a:extLst xmlns:a="http://schemas.openxmlformats.org/drawingml/2006/main">
               <a:ext uri="{FF2B5EF4-FFF2-40B4-BE49-F238E27FC236}">
-                <a16:creationId xmlns:a16="http://schemas.microsoft.com/office/drawing/2014/main" id="{3370D17C-D321-49CA-A340-0BD503C5AA96}"/>
+                <a16:creationId xmlns:a16="http://schemas.microsoft.com/office/drawing/2014/main" id="{FF5047C0-62E3-46EA-BECA-F4471B688AF2}"/>
               </a:ext>
             </a:extLst>
           </p:cNvPr>
@@ -18084,7 +18153,7 @@
           <p:cNvPr id="2" name="text">
             <a:extLst xmlns:a="http://schemas.openxmlformats.org/drawingml/2006/main">
               <a:ext uri="{FF2B5EF4-FFF2-40B4-BE49-F238E27FC236}">
-                <a16:creationId xmlns:a16="http://schemas.microsoft.com/office/drawing/2014/main" id="{5FE11044-195A-41EC-9D70-B380E3BB37FA}"/>
+                <a16:creationId xmlns:a16="http://schemas.microsoft.com/office/drawing/2014/main" id="{AE9CF666-D1C2-4E87-A7BD-2651118F1CF2}"/>
               </a:ext>
             </a:extLst>
           </p:cNvPr>
@@ -18141,7 +18210,7 @@
           <p:cNvPr id="3" name="text">
             <a:extLst xmlns:a="http://schemas.openxmlformats.org/drawingml/2006/main">
               <a:ext uri="{FF2B5EF4-FFF2-40B4-BE49-F238E27FC236}">
-                <a16:creationId xmlns:a16="http://schemas.microsoft.com/office/drawing/2014/main" id="{84C67536-6E4A-440A-A159-16D9165B777C}"/>
+                <a16:creationId xmlns:a16="http://schemas.microsoft.com/office/drawing/2014/main" id="{D36C5DAC-4B09-40BF-AAF6-E976573B5546}"/>
               </a:ext>
             </a:extLst>
           </p:cNvPr>
@@ -18196,7 +18265,7 @@
     </p:spTree>
     <p:extLst>
       <p:ext uri="{BB962C8B-B14F-4D97-AF65-F5344CB8AC3E}">
-        <p14:creationId xmlns:p14="http://schemas.microsoft.com/office/powerpoint/2010/main" val="966869849"/>
+        <p14:creationId xmlns:p14="http://schemas.microsoft.com/office/powerpoint/2010/main" val="1225811657"/>
       </p:ext>
     </p:extLst>
   </p:cSld>
@@ -18238,7 +18307,7 @@
           <p:cNvPr id="4" name="text">
             <a:extLst xmlns:a="http://schemas.openxmlformats.org/drawingml/2006/main">
               <a:ext uri="{FF2B5EF4-FFF2-40B4-BE49-F238E27FC236}">
-                <a16:creationId xmlns:a16="http://schemas.microsoft.com/office/drawing/2014/main" id="{85148D85-66A5-4BDD-ADAD-B8635A3FF500}"/>
+                <a16:creationId xmlns:a16="http://schemas.microsoft.com/office/drawing/2014/main" id="{EF12A691-E3AD-440D-B3C8-DDBE5DED29E9}"/>
               </a:ext>
             </a:extLst>
           </p:cNvPr>
@@ -18295,7 +18364,7 @@
           <p:cNvPr id="2" name="text">
             <a:extLst xmlns:a="http://schemas.openxmlformats.org/drawingml/2006/main">
               <a:ext uri="{FF2B5EF4-FFF2-40B4-BE49-F238E27FC236}">
-                <a16:creationId xmlns:a16="http://schemas.microsoft.com/office/drawing/2014/main" id="{F561AB23-EA5F-4575-9DC4-11F7CA9C610D}"/>
+                <a16:creationId xmlns:a16="http://schemas.microsoft.com/office/drawing/2014/main" id="{C2C17132-715A-4EDC-8927-F7553BB87470}"/>
               </a:ext>
             </a:extLst>
           </p:cNvPr>
@@ -18352,7 +18421,7 @@
           <p:cNvPr id="3" name="text">
             <a:extLst xmlns:a="http://schemas.openxmlformats.org/drawingml/2006/main">
               <a:ext uri="{FF2B5EF4-FFF2-40B4-BE49-F238E27FC236}">
-                <a16:creationId xmlns:a16="http://schemas.microsoft.com/office/drawing/2014/main" id="{85AD7E83-6FE7-4F16-B3A7-0A67986508E8}"/>
+                <a16:creationId xmlns:a16="http://schemas.microsoft.com/office/drawing/2014/main" id="{BD0D2934-779F-4F80-A388-5EED9B231275}"/>
               </a:ext>
             </a:extLst>
           </p:cNvPr>
@@ -18407,7 +18476,7 @@
     </p:spTree>
     <p:extLst>
       <p:ext uri="{BB962C8B-B14F-4D97-AF65-F5344CB8AC3E}">
-        <p14:creationId xmlns:p14="http://schemas.microsoft.com/office/powerpoint/2010/main" val="923108221"/>
+        <p14:creationId xmlns:p14="http://schemas.microsoft.com/office/powerpoint/2010/main" val="863092708"/>
       </p:ext>
     </p:extLst>
   </p:cSld>
@@ -18449,7 +18518,7 @@
           <p:cNvPr id="5" name="text">
             <a:extLst xmlns:a="http://schemas.openxmlformats.org/drawingml/2006/main">
               <a:ext uri="{FF2B5EF4-FFF2-40B4-BE49-F238E27FC236}">
-                <a16:creationId xmlns:a16="http://schemas.microsoft.com/office/drawing/2014/main" id="{206F7C88-C7FF-4200-830C-9C8FF0D93A49}"/>
+                <a16:creationId xmlns:a16="http://schemas.microsoft.com/office/drawing/2014/main" id="{5C3EE7BA-9363-41AF-A257-538D27A8460F}"/>
               </a:ext>
             </a:extLst>
           </p:cNvPr>
@@ -18506,7 +18575,7 @@
           <p:cNvPr id="2" name="text">
             <a:extLst xmlns:a="http://schemas.openxmlformats.org/drawingml/2006/main">
               <a:ext uri="{FF2B5EF4-FFF2-40B4-BE49-F238E27FC236}">
-                <a16:creationId xmlns:a16="http://schemas.microsoft.com/office/drawing/2014/main" id="{6515EA66-58B3-47B5-9EB7-9B3E51B16DD7}"/>
+                <a16:creationId xmlns:a16="http://schemas.microsoft.com/office/drawing/2014/main" id="{9675305D-1B5D-4818-8F0A-A86135BCD727}"/>
               </a:ext>
             </a:extLst>
           </p:cNvPr>
@@ -18563,7 +18632,7 @@
           <p:cNvPr id="3" name="text">
             <a:extLst xmlns:a="http://schemas.openxmlformats.org/drawingml/2006/main">
               <a:ext uri="{FF2B5EF4-FFF2-40B4-BE49-F238E27FC236}">
-                <a16:creationId xmlns:a16="http://schemas.microsoft.com/office/drawing/2014/main" id="{02C56AF4-A6B8-4BAC-A7E1-10ED64B51F9E}"/>
+                <a16:creationId xmlns:a16="http://schemas.microsoft.com/office/drawing/2014/main" id="{058EEBA8-520D-46BD-9EAE-AAA802CEC426}"/>
               </a:ext>
             </a:extLst>
           </p:cNvPr>
@@ -18620,7 +18689,7 @@
           <p:cNvPr id="4" name="text">
             <a:extLst xmlns:a="http://schemas.openxmlformats.org/drawingml/2006/main">
               <a:ext uri="{FF2B5EF4-FFF2-40B4-BE49-F238E27FC236}">
-                <a16:creationId xmlns:a16="http://schemas.microsoft.com/office/drawing/2014/main" id="{E8874665-3609-43F9-9B8D-21CA1DB60ED0}"/>
+                <a16:creationId xmlns:a16="http://schemas.microsoft.com/office/drawing/2014/main" id="{E54F56B3-FF4A-48B2-A45C-D32C31D5E0C7}"/>
               </a:ext>
             </a:extLst>
           </p:cNvPr>
@@ -18675,7 +18744,7 @@
     </p:spTree>
     <p:extLst>
       <p:ext uri="{BB962C8B-B14F-4D97-AF65-F5344CB8AC3E}">
-        <p14:creationId xmlns:p14="http://schemas.microsoft.com/office/powerpoint/2010/main" val="2115102432"/>
+        <p14:creationId xmlns:p14="http://schemas.microsoft.com/office/powerpoint/2010/main" val="590672818"/>
       </p:ext>
     </p:extLst>
   </p:cSld>
@@ -18717,7 +18786,7 @@
           <p:cNvPr id="6" name="text">
             <a:extLst xmlns:a="http://schemas.openxmlformats.org/drawingml/2006/main">
               <a:ext uri="{FF2B5EF4-FFF2-40B4-BE49-F238E27FC236}">
-                <a16:creationId xmlns:a16="http://schemas.microsoft.com/office/drawing/2014/main" id="{27171A8E-0770-429B-A5AE-DB20904FCF7A}"/>
+                <a16:creationId xmlns:a16="http://schemas.microsoft.com/office/drawing/2014/main" id="{EB9BD144-6B5E-475C-9D6D-41DA51112DBD}"/>
               </a:ext>
             </a:extLst>
           </p:cNvPr>
@@ -18774,7 +18843,7 @@
           <p:cNvPr id="2" name="text">
             <a:extLst xmlns:a="http://schemas.openxmlformats.org/drawingml/2006/main">
               <a:ext uri="{FF2B5EF4-FFF2-40B4-BE49-F238E27FC236}">
-                <a16:creationId xmlns:a16="http://schemas.microsoft.com/office/drawing/2014/main" id="{BCBB9D40-8B0C-4520-AD1E-34DD3892AC78}"/>
+                <a16:creationId xmlns:a16="http://schemas.microsoft.com/office/drawing/2014/main" id="{91BE25FC-185F-4B33-A9F3-22644B0A3BB1}"/>
               </a:ext>
             </a:extLst>
           </p:cNvPr>
@@ -18831,7 +18900,7 @@
           <p:cNvPr id="3" name="text">
             <a:extLst xmlns:a="http://schemas.openxmlformats.org/drawingml/2006/main">
               <a:ext uri="{FF2B5EF4-FFF2-40B4-BE49-F238E27FC236}">
-                <a16:creationId xmlns:a16="http://schemas.microsoft.com/office/drawing/2014/main" id="{B278381F-1454-401C-9B02-8B089F504583}"/>
+                <a16:creationId xmlns:a16="http://schemas.microsoft.com/office/drawing/2014/main" id="{2502C24A-38E5-4DD0-B7B2-7E26A7D08833}"/>
               </a:ext>
             </a:extLst>
           </p:cNvPr>
@@ -18888,7 +18957,7 @@
           <p:cNvPr id="4" name="text">
             <a:extLst xmlns:a="http://schemas.openxmlformats.org/drawingml/2006/main">
               <a:ext uri="{FF2B5EF4-FFF2-40B4-BE49-F238E27FC236}">
-                <a16:creationId xmlns:a16="http://schemas.microsoft.com/office/drawing/2014/main" id="{484D88CB-B963-443A-83FA-B83A4ACF122B}"/>
+                <a16:creationId xmlns:a16="http://schemas.microsoft.com/office/drawing/2014/main" id="{0D07FFB6-03D7-403F-8917-D8F9DD91894D}"/>
               </a:ext>
             </a:extLst>
           </p:cNvPr>
@@ -18945,7 +19014,7 @@
           <p:cNvPr id="5" name="text">
             <a:extLst xmlns:a="http://schemas.openxmlformats.org/drawingml/2006/main">
               <a:ext uri="{FF2B5EF4-FFF2-40B4-BE49-F238E27FC236}">
-                <a16:creationId xmlns:a16="http://schemas.microsoft.com/office/drawing/2014/main" id="{671D5BEB-FD6F-44AB-9241-560002948C53}"/>
+                <a16:creationId xmlns:a16="http://schemas.microsoft.com/office/drawing/2014/main" id="{E0DC5F23-DCDD-44B0-9861-2252ECE7FC9E}"/>
               </a:ext>
             </a:extLst>
           </p:cNvPr>
@@ -19000,7 +19069,7 @@
     </p:spTree>
     <p:extLst>
       <p:ext uri="{BB962C8B-B14F-4D97-AF65-F5344CB8AC3E}">
-        <p14:creationId xmlns:p14="http://schemas.microsoft.com/office/powerpoint/2010/main" val="1219156738"/>
+        <p14:creationId xmlns:p14="http://schemas.microsoft.com/office/powerpoint/2010/main" val="317901317"/>
       </p:ext>
     </p:extLst>
   </p:cSld>
@@ -19042,7 +19111,7 @@
           <p:cNvPr id="5" name="text">
             <a:extLst xmlns:a="http://schemas.openxmlformats.org/drawingml/2006/main">
               <a:ext uri="{FF2B5EF4-FFF2-40B4-BE49-F238E27FC236}">
-                <a16:creationId xmlns:a16="http://schemas.microsoft.com/office/drawing/2014/main" id="{50A90FB9-58B5-48E6-A36B-612D9DD8F4FD}"/>
+                <a16:creationId xmlns:a16="http://schemas.microsoft.com/office/drawing/2014/main" id="{89CD3E4C-7448-4533-8108-FB3FBE06922E}"/>
               </a:ext>
             </a:extLst>
           </p:cNvPr>
@@ -19099,7 +19168,7 @@
           <p:cNvPr id="2" name="text">
             <a:extLst xmlns:a="http://schemas.openxmlformats.org/drawingml/2006/main">
               <a:ext uri="{FF2B5EF4-FFF2-40B4-BE49-F238E27FC236}">
-                <a16:creationId xmlns:a16="http://schemas.microsoft.com/office/drawing/2014/main" id="{0FF1DCF7-24C4-42E2-A2F6-6F410BBC385E}"/>
+                <a16:creationId xmlns:a16="http://schemas.microsoft.com/office/drawing/2014/main" id="{3DAA4D09-5D99-42C6-AEFC-9E978E3AA9A4}"/>
               </a:ext>
             </a:extLst>
           </p:cNvPr>
@@ -19156,7 +19225,7 @@
           <p:cNvPr id="3" name="text">
             <a:extLst xmlns:a="http://schemas.openxmlformats.org/drawingml/2006/main">
               <a:ext uri="{FF2B5EF4-FFF2-40B4-BE49-F238E27FC236}">
-                <a16:creationId xmlns:a16="http://schemas.microsoft.com/office/drawing/2014/main" id="{9034F23F-B6CC-4F4F-B3BC-A695888E951A}"/>
+                <a16:creationId xmlns:a16="http://schemas.microsoft.com/office/drawing/2014/main" id="{D5EDCC68-3420-4A48-BAC1-FE39D306AB1C}"/>
               </a:ext>
             </a:extLst>
           </p:cNvPr>
@@ -19213,7 +19282,7 @@
           <p:cNvPr id="4" name="text">
             <a:extLst xmlns:a="http://schemas.openxmlformats.org/drawingml/2006/main">
               <a:ext uri="{FF2B5EF4-FFF2-40B4-BE49-F238E27FC236}">
-                <a16:creationId xmlns:a16="http://schemas.microsoft.com/office/drawing/2014/main" id="{4A975C6D-8E97-4C8C-8D15-932F6254B3CE}"/>
+                <a16:creationId xmlns:a16="http://schemas.microsoft.com/office/drawing/2014/main" id="{F3A34EA4-5FF2-4D06-8BE7-6E3239F008B7}"/>
               </a:ext>
             </a:extLst>
           </p:cNvPr>
@@ -19268,7 +19337,7 @@
     </p:spTree>
     <p:extLst>
       <p:ext uri="{BB962C8B-B14F-4D97-AF65-F5344CB8AC3E}">
-        <p14:creationId xmlns:p14="http://schemas.microsoft.com/office/powerpoint/2010/main" val="740150580"/>
+        <p14:creationId xmlns:p14="http://schemas.microsoft.com/office/powerpoint/2010/main" val="1506416079"/>
       </p:ext>
     </p:extLst>
   </p:cSld>
@@ -19310,7 +19379,7 @@
           <p:cNvPr id="6" name="text">
             <a:extLst xmlns:a="http://schemas.openxmlformats.org/drawingml/2006/main">
               <a:ext uri="{FF2B5EF4-FFF2-40B4-BE49-F238E27FC236}">
-                <a16:creationId xmlns:a16="http://schemas.microsoft.com/office/drawing/2014/main" id="{738E85C4-5062-45E0-AA54-4731E8CE8A18}"/>
+                <a16:creationId xmlns:a16="http://schemas.microsoft.com/office/drawing/2014/main" id="{406684F2-0B12-454C-9262-617EC27B5D78}"/>
               </a:ext>
             </a:extLst>
           </p:cNvPr>
@@ -19367,7 +19436,7 @@
           <p:cNvPr id="2" name="text">
             <a:extLst xmlns:a="http://schemas.openxmlformats.org/drawingml/2006/main">
               <a:ext uri="{FF2B5EF4-FFF2-40B4-BE49-F238E27FC236}">
-                <a16:creationId xmlns:a16="http://schemas.microsoft.com/office/drawing/2014/main" id="{9ADC083E-C95E-4335-A753-273F3BFF0C7F}"/>
+                <a16:creationId xmlns:a16="http://schemas.microsoft.com/office/drawing/2014/main" id="{D4059FE1-A826-4CF0-B43D-6E9EEB5283DE}"/>
               </a:ext>
             </a:extLst>
           </p:cNvPr>
@@ -19424,7 +19493,7 @@
           <p:cNvPr id="3" name="text">
             <a:extLst xmlns:a="http://schemas.openxmlformats.org/drawingml/2006/main">
               <a:ext uri="{FF2B5EF4-FFF2-40B4-BE49-F238E27FC236}">
-                <a16:creationId xmlns:a16="http://schemas.microsoft.com/office/drawing/2014/main" id="{2661DD3A-3C5D-4940-85C8-D5DA5CAB5B92}"/>
+                <a16:creationId xmlns:a16="http://schemas.microsoft.com/office/drawing/2014/main" id="{52B6A3E4-C7F3-4170-A79F-365738B306D4}"/>
               </a:ext>
             </a:extLst>
           </p:cNvPr>
@@ -19481,7 +19550,7 @@
           <p:cNvPr id="4" name="text">
             <a:extLst xmlns:a="http://schemas.openxmlformats.org/drawingml/2006/main">
               <a:ext uri="{FF2B5EF4-FFF2-40B4-BE49-F238E27FC236}">
-                <a16:creationId xmlns:a16="http://schemas.microsoft.com/office/drawing/2014/main" id="{DCD33771-FDDC-425E-8BE9-A14CEBFE81F5}"/>
+                <a16:creationId xmlns:a16="http://schemas.microsoft.com/office/drawing/2014/main" id="{60CFDF3A-AF53-4D47-B6CB-1E53024328D5}"/>
               </a:ext>
             </a:extLst>
           </p:cNvPr>
@@ -19538,7 +19607,7 @@
           <p:cNvPr id="5" name="text">
             <a:extLst xmlns:a="http://schemas.openxmlformats.org/drawingml/2006/main">
               <a:ext uri="{FF2B5EF4-FFF2-40B4-BE49-F238E27FC236}">
-                <a16:creationId xmlns:a16="http://schemas.microsoft.com/office/drawing/2014/main" id="{EE0C00AF-E875-456E-A8DE-468085C527EB}"/>
+                <a16:creationId xmlns:a16="http://schemas.microsoft.com/office/drawing/2014/main" id="{CF69B1B5-00B2-4907-95EB-6FC90E41774B}"/>
               </a:ext>
             </a:extLst>
           </p:cNvPr>
@@ -19593,7 +19662,7 @@
     </p:spTree>
     <p:extLst>
       <p:ext uri="{BB962C8B-B14F-4D97-AF65-F5344CB8AC3E}">
-        <p14:creationId xmlns:p14="http://schemas.microsoft.com/office/powerpoint/2010/main" val="413677048"/>
+        <p14:creationId xmlns:p14="http://schemas.microsoft.com/office/powerpoint/2010/main" val="705181122"/>
       </p:ext>
     </p:extLst>
   </p:cSld>
@@ -19635,7 +19704,7 @@
           <p:cNvPr id="4" name="text">
             <a:extLst xmlns:a="http://schemas.openxmlformats.org/drawingml/2006/main">
               <a:ext uri="{FF2B5EF4-FFF2-40B4-BE49-F238E27FC236}">
-                <a16:creationId xmlns:a16="http://schemas.microsoft.com/office/drawing/2014/main" id="{D2ED37C2-C9E5-48B5-ACFB-5FE10717D164}"/>
+                <a16:creationId xmlns:a16="http://schemas.microsoft.com/office/drawing/2014/main" id="{2703D45B-431D-4F27-9B27-EC569C670719}"/>
               </a:ext>
             </a:extLst>
           </p:cNvPr>
@@ -19692,7 +19761,7 @@
           <p:cNvPr id="2" name="text">
             <a:extLst xmlns:a="http://schemas.openxmlformats.org/drawingml/2006/main">
               <a:ext uri="{FF2B5EF4-FFF2-40B4-BE49-F238E27FC236}">
-                <a16:creationId xmlns:a16="http://schemas.microsoft.com/office/drawing/2014/main" id="{B1C53D1B-2B4F-4458-8BC4-2CEA0712387D}"/>
+                <a16:creationId xmlns:a16="http://schemas.microsoft.com/office/drawing/2014/main" id="{57C45373-A0B6-4323-9C5D-BBDD5957A3A8}"/>
               </a:ext>
             </a:extLst>
           </p:cNvPr>
@@ -19749,7 +19818,7 @@
           <p:cNvPr id="3" name="text">
             <a:extLst xmlns:a="http://schemas.openxmlformats.org/drawingml/2006/main">
               <a:ext uri="{FF2B5EF4-FFF2-40B4-BE49-F238E27FC236}">
-                <a16:creationId xmlns:a16="http://schemas.microsoft.com/office/drawing/2014/main" id="{DD0CC11E-3F2A-4AF1-A056-2A9EB88AE5B0}"/>
+                <a16:creationId xmlns:a16="http://schemas.microsoft.com/office/drawing/2014/main" id="{27977583-0C6B-4631-B27F-06AB1AE83823}"/>
               </a:ext>
             </a:extLst>
           </p:cNvPr>
@@ -19804,7 +19873,7 @@
     </p:spTree>
     <p:extLst>
       <p:ext uri="{BB962C8B-B14F-4D97-AF65-F5344CB8AC3E}">
-        <p14:creationId xmlns:p14="http://schemas.microsoft.com/office/powerpoint/2010/main" val="365435458"/>
+        <p14:creationId xmlns:p14="http://schemas.microsoft.com/office/powerpoint/2010/main" val="1665890848"/>
       </p:ext>
     </p:extLst>
   </p:cSld>
@@ -19846,7 +19915,7 @@
           <p:cNvPr id="5" name="text">
             <a:extLst xmlns:a="http://schemas.openxmlformats.org/drawingml/2006/main">
               <a:ext uri="{FF2B5EF4-FFF2-40B4-BE49-F238E27FC236}">
-                <a16:creationId xmlns:a16="http://schemas.microsoft.com/office/drawing/2014/main" id="{F47E25BA-0780-45C8-8059-FEFA4217202C}"/>
+                <a16:creationId xmlns:a16="http://schemas.microsoft.com/office/drawing/2014/main" id="{C34A1F7F-69BD-409D-884E-259A9004F631}"/>
               </a:ext>
             </a:extLst>
           </p:cNvPr>
@@ -19903,7 +19972,7 @@
           <p:cNvPr id="2" name="text">
             <a:extLst xmlns:a="http://schemas.openxmlformats.org/drawingml/2006/main">
               <a:ext uri="{FF2B5EF4-FFF2-40B4-BE49-F238E27FC236}">
-                <a16:creationId xmlns:a16="http://schemas.microsoft.com/office/drawing/2014/main" id="{3E65FBCB-63EF-4566-97A6-E41D7F75811B}"/>
+                <a16:creationId xmlns:a16="http://schemas.microsoft.com/office/drawing/2014/main" id="{9D948083-A253-4D1B-A0B2-C6C6879125E3}"/>
               </a:ext>
             </a:extLst>
           </p:cNvPr>
@@ -19960,7 +20029,7 @@
           <p:cNvPr id="3" name="text">
             <a:extLst xmlns:a="http://schemas.openxmlformats.org/drawingml/2006/main">
               <a:ext uri="{FF2B5EF4-FFF2-40B4-BE49-F238E27FC236}">
-                <a16:creationId xmlns:a16="http://schemas.microsoft.com/office/drawing/2014/main" id="{4989ED4C-FCC1-407B-86C0-3DE95EE577C6}"/>
+                <a16:creationId xmlns:a16="http://schemas.microsoft.com/office/drawing/2014/main" id="{45512834-B525-4784-86C3-04057CC7E521}"/>
               </a:ext>
             </a:extLst>
           </p:cNvPr>
@@ -20017,7 +20086,7 @@
           <p:cNvPr id="4" name="text">
             <a:extLst xmlns:a="http://schemas.openxmlformats.org/drawingml/2006/main">
               <a:ext uri="{FF2B5EF4-FFF2-40B4-BE49-F238E27FC236}">
-                <a16:creationId xmlns:a16="http://schemas.microsoft.com/office/drawing/2014/main" id="{6BD60976-4E19-4F12-B2DD-218A3026413E}"/>
+                <a16:creationId xmlns:a16="http://schemas.microsoft.com/office/drawing/2014/main" id="{3413DA62-0718-4053-9253-0B5ECDF9B065}"/>
               </a:ext>
             </a:extLst>
           </p:cNvPr>
@@ -20072,7 +20141,7 @@
     </p:spTree>
     <p:extLst>
       <p:ext uri="{BB962C8B-B14F-4D97-AF65-F5344CB8AC3E}">
-        <p14:creationId xmlns:p14="http://schemas.microsoft.com/office/powerpoint/2010/main" val="2081431777"/>
+        <p14:creationId xmlns:p14="http://schemas.microsoft.com/office/powerpoint/2010/main" val="639860446"/>
       </p:ext>
     </p:extLst>
   </p:cSld>
@@ -20114,7 +20183,7 @@
           <p:cNvPr id="6" name="text">
             <a:extLst xmlns:a="http://schemas.openxmlformats.org/drawingml/2006/main">
               <a:ext uri="{FF2B5EF4-FFF2-40B4-BE49-F238E27FC236}">
-                <a16:creationId xmlns:a16="http://schemas.microsoft.com/office/drawing/2014/main" id="{1189F8BE-6830-4DF7-B91F-409C09235A16}"/>
+                <a16:creationId xmlns:a16="http://schemas.microsoft.com/office/drawing/2014/main" id="{23F1D868-0821-4B73-B417-C1D1AA24E4ED}"/>
               </a:ext>
             </a:extLst>
           </p:cNvPr>
@@ -20171,7 +20240,7 @@
           <p:cNvPr id="2" name="text">
             <a:extLst xmlns:a="http://schemas.openxmlformats.org/drawingml/2006/main">
               <a:ext uri="{FF2B5EF4-FFF2-40B4-BE49-F238E27FC236}">
-                <a16:creationId xmlns:a16="http://schemas.microsoft.com/office/drawing/2014/main" id="{23A9001E-CA3A-457B-A93E-E17A870C6D32}"/>
+                <a16:creationId xmlns:a16="http://schemas.microsoft.com/office/drawing/2014/main" id="{40A47E29-483B-46AD-B073-E02EC1A54D0C}"/>
               </a:ext>
             </a:extLst>
           </p:cNvPr>
@@ -20228,7 +20297,7 @@
           <p:cNvPr id="3" name="text">
             <a:extLst xmlns:a="http://schemas.openxmlformats.org/drawingml/2006/main">
               <a:ext uri="{FF2B5EF4-FFF2-40B4-BE49-F238E27FC236}">
-                <a16:creationId xmlns:a16="http://schemas.microsoft.com/office/drawing/2014/main" id="{1ED505EB-F01B-404B-8C67-7E72E99F79AB}"/>
+                <a16:creationId xmlns:a16="http://schemas.microsoft.com/office/drawing/2014/main" id="{EA905FB5-0712-47AD-AD2C-8319691409F3}"/>
               </a:ext>
             </a:extLst>
           </p:cNvPr>
@@ -20285,7 +20354,7 @@
           <p:cNvPr id="4" name="text">
             <a:extLst xmlns:a="http://schemas.openxmlformats.org/drawingml/2006/main">
               <a:ext uri="{FF2B5EF4-FFF2-40B4-BE49-F238E27FC236}">
-                <a16:creationId xmlns:a16="http://schemas.microsoft.com/office/drawing/2014/main" id="{CCD0568B-CAEF-4741-9490-BB4CB9E64A15}"/>
+                <a16:creationId xmlns:a16="http://schemas.microsoft.com/office/drawing/2014/main" id="{87AF4493-4C19-4910-80AC-3BC5D10250BE}"/>
               </a:ext>
             </a:extLst>
           </p:cNvPr>
@@ -20342,7 +20411,7 @@
           <p:cNvPr id="5" name="text">
             <a:extLst xmlns:a="http://schemas.openxmlformats.org/drawingml/2006/main">
               <a:ext uri="{FF2B5EF4-FFF2-40B4-BE49-F238E27FC236}">
-                <a16:creationId xmlns:a16="http://schemas.microsoft.com/office/drawing/2014/main" id="{C2877C94-5CD7-449B-99FA-F75B9A72A357}"/>
+                <a16:creationId xmlns:a16="http://schemas.microsoft.com/office/drawing/2014/main" id="{2D19AB80-CC77-4BA3-83B8-44CCF83BBC65}"/>
               </a:ext>
             </a:extLst>
           </p:cNvPr>
@@ -20397,7 +20466,7 @@
     </p:spTree>
     <p:extLst>
       <p:ext uri="{BB962C8B-B14F-4D97-AF65-F5344CB8AC3E}">
-        <p14:creationId xmlns:p14="http://schemas.microsoft.com/office/powerpoint/2010/main" val="845811638"/>
+        <p14:creationId xmlns:p14="http://schemas.microsoft.com/office/powerpoint/2010/main" val="1855590231"/>
       </p:ext>
     </p:extLst>
   </p:cSld>
@@ -20439,7 +20508,7 @@
           <p:cNvPr id="8" name="text">
             <a:extLst xmlns:a="http://schemas.openxmlformats.org/drawingml/2006/main">
               <a:ext uri="{FF2B5EF4-FFF2-40B4-BE49-F238E27FC236}">
-                <a16:creationId xmlns:a16="http://schemas.microsoft.com/office/drawing/2014/main" id="{6B1B7887-A2CA-4FE3-B507-FA3DFE5D2147}"/>
+                <a16:creationId xmlns:a16="http://schemas.microsoft.com/office/drawing/2014/main" id="{A1A2A693-739E-4779-87D0-4BE74599427C}"/>
               </a:ext>
             </a:extLst>
           </p:cNvPr>
@@ -20496,7 +20565,7 @@
           <p:cNvPr id="2" name="text">
             <a:extLst xmlns:a="http://schemas.openxmlformats.org/drawingml/2006/main">
               <a:ext uri="{FF2B5EF4-FFF2-40B4-BE49-F238E27FC236}">
-                <a16:creationId xmlns:a16="http://schemas.microsoft.com/office/drawing/2014/main" id="{740843BE-F296-4286-B589-B675986A5BE8}"/>
+                <a16:creationId xmlns:a16="http://schemas.microsoft.com/office/drawing/2014/main" id="{D191F977-CEF7-43B8-BA16-0E95E7C5F370}"/>
               </a:ext>
             </a:extLst>
           </p:cNvPr>
@@ -20553,7 +20622,7 @@
           <p:cNvPr id="3" name="text">
             <a:extLst xmlns:a="http://schemas.openxmlformats.org/drawingml/2006/main">
               <a:ext uri="{FF2B5EF4-FFF2-40B4-BE49-F238E27FC236}">
-                <a16:creationId xmlns:a16="http://schemas.microsoft.com/office/drawing/2014/main" id="{11A8741D-4DA9-416C-8353-D600B547A55B}"/>
+                <a16:creationId xmlns:a16="http://schemas.microsoft.com/office/drawing/2014/main" id="{12731DA5-7C1F-423A-8ABA-47E1D3EA1CD8}"/>
               </a:ext>
             </a:extLst>
           </p:cNvPr>
@@ -20600,7 +20669,7 @@
                 <a:ea typeface="Heebo"/>
                 <a:cs typeface="Heebo"/>
               </a:rPr>
-              <a:t>11:10–11:50 · זום ותרגול יחד</a:t>
+              <a:t>‎11:10–11:50‎ · זום ותרגול יחד</a:t>
             </a:r>
           </a:p>
         </p:txBody>
@@ -20610,7 +20679,7 @@
           <p:cNvPr id="4" name="text">
             <a:extLst xmlns:a="http://schemas.openxmlformats.org/drawingml/2006/main">
               <a:ext uri="{FF2B5EF4-FFF2-40B4-BE49-F238E27FC236}">
-                <a16:creationId xmlns:a16="http://schemas.microsoft.com/office/drawing/2014/main" id="{478DCE36-63FB-45F9-A9B5-773CA4B3F51B}"/>
+                <a16:creationId xmlns:a16="http://schemas.microsoft.com/office/drawing/2014/main" id="{65F292CA-4EE4-4F00-A2DD-586DA903D335}"/>
               </a:ext>
             </a:extLst>
           </p:cNvPr>
@@ -20657,7 +20726,7 @@
                 <a:ea typeface="Heebo"/>
                 <a:cs typeface="Heebo"/>
               </a:rPr>
-              <a:t>12:00–12:25 · עבודה עצמאית</a:t>
+              <a:t>‎12:00–12:25‎ · עבודה עצמאית</a:t>
             </a:r>
           </a:p>
         </p:txBody>
@@ -20667,7 +20736,7 @@
           <p:cNvPr id="5" name="text">
             <a:extLst xmlns:a="http://schemas.openxmlformats.org/drawingml/2006/main">
               <a:ext uri="{FF2B5EF4-FFF2-40B4-BE49-F238E27FC236}">
-                <a16:creationId xmlns:a16="http://schemas.microsoft.com/office/drawing/2014/main" id="{75396EB5-03D3-48B1-B6B0-B97DB87F1335}"/>
+                <a16:creationId xmlns:a16="http://schemas.microsoft.com/office/drawing/2014/main" id="{4FE9A9BC-6BA1-4728-A56D-C960830F69F6}"/>
               </a:ext>
             </a:extLst>
           </p:cNvPr>
@@ -20724,7 +20793,7 @@
           <p:cNvPr id="6" name="text">
             <a:extLst xmlns:a="http://schemas.openxmlformats.org/drawingml/2006/main">
               <a:ext uri="{FF2B5EF4-FFF2-40B4-BE49-F238E27FC236}">
-                <a16:creationId xmlns:a16="http://schemas.microsoft.com/office/drawing/2014/main" id="{AF5C28F8-41F3-4129-8BC5-75A9C7F51DC9}"/>
+                <a16:creationId xmlns:a16="http://schemas.microsoft.com/office/drawing/2014/main" id="{EFE75F54-13AF-40CE-AF9B-E0840F358423}"/>
               </a:ext>
             </a:extLst>
           </p:cNvPr>
@@ -20781,7 +20850,7 @@
           <p:cNvPr id="7" name="text">
             <a:extLst xmlns:a="http://schemas.openxmlformats.org/drawingml/2006/main">
               <a:ext uri="{FF2B5EF4-FFF2-40B4-BE49-F238E27FC236}">
-                <a16:creationId xmlns:a16="http://schemas.microsoft.com/office/drawing/2014/main" id="{F2D02D7F-0655-469F-BD93-6D217E9B1E03}"/>
+                <a16:creationId xmlns:a16="http://schemas.microsoft.com/office/drawing/2014/main" id="{2ED27501-0442-43C5-9F12-ADE0718DFF6A}"/>
               </a:ext>
             </a:extLst>
           </p:cNvPr>
@@ -20836,7 +20905,7 @@
     </p:spTree>
     <p:extLst>
       <p:ext uri="{BB962C8B-B14F-4D97-AF65-F5344CB8AC3E}">
-        <p14:creationId xmlns:p14="http://schemas.microsoft.com/office/powerpoint/2010/main" val="1607249393"/>
+        <p14:creationId xmlns:p14="http://schemas.microsoft.com/office/powerpoint/2010/main" val="2092658259"/>
       </p:ext>
     </p:extLst>
   </p:cSld>
@@ -20882,7 +20951,7 @@
           <p:nvPr/>
         </p:nvPicPr>
         <p:blipFill>
-          <a:blip xmlns:r="http://schemas.openxmlformats.org/officeDocument/2006/relationships" xmlns:a="http://schemas.openxmlformats.org/drawingml/2006/main" r:embed="R4795ea483f66410e"/>
+          <a:blip xmlns:r="http://schemas.openxmlformats.org/officeDocument/2006/relationships" xmlns:a="http://schemas.openxmlformats.org/drawingml/2006/main" r:embed="R29bfc3a0e2554d0b"/>
           <a:stretch xmlns:a="http://schemas.openxmlformats.org/drawingml/2006/main"/>
         </p:blipFill>
         <p:spPr>
@@ -20898,7 +20967,7 @@
     </p:spTree>
     <p:extLst>
       <p:ext uri="{BB962C8B-B14F-4D97-AF65-F5344CB8AC3E}">
-        <p14:creationId xmlns:p14="http://schemas.microsoft.com/office/powerpoint/2010/main" val="13301917"/>
+        <p14:creationId xmlns:p14="http://schemas.microsoft.com/office/powerpoint/2010/main" val="1466702654"/>
       </p:ext>
     </p:extLst>
   </p:cSld>
@@ -20940,7 +21009,7 @@
           <p:cNvPr id="4" name="text">
             <a:extLst xmlns:a="http://schemas.openxmlformats.org/drawingml/2006/main">
               <a:ext uri="{FF2B5EF4-FFF2-40B4-BE49-F238E27FC236}">
-                <a16:creationId xmlns:a16="http://schemas.microsoft.com/office/drawing/2014/main" id="{CF8A8216-E03B-4C68-A04A-8C3EE8CD48E8}"/>
+                <a16:creationId xmlns:a16="http://schemas.microsoft.com/office/drawing/2014/main" id="{9FD31343-481E-4354-94EA-FA444D38D854}"/>
               </a:ext>
             </a:extLst>
           </p:cNvPr>
@@ -20997,7 +21066,7 @@
           <p:cNvPr id="2" name="text">
             <a:extLst xmlns:a="http://schemas.openxmlformats.org/drawingml/2006/main">
               <a:ext uri="{FF2B5EF4-FFF2-40B4-BE49-F238E27FC236}">
-                <a16:creationId xmlns:a16="http://schemas.microsoft.com/office/drawing/2014/main" id="{ED76BD8E-D1F4-44ED-BA47-42BE2336B7C7}"/>
+                <a16:creationId xmlns:a16="http://schemas.microsoft.com/office/drawing/2014/main" id="{73E90982-C262-484B-882E-2C4A337EEC67}"/>
               </a:ext>
             </a:extLst>
           </p:cNvPr>
@@ -21054,7 +21123,7 @@
           <p:cNvPr id="3" name="text">
             <a:extLst xmlns:a="http://schemas.openxmlformats.org/drawingml/2006/main">
               <a:ext uri="{FF2B5EF4-FFF2-40B4-BE49-F238E27FC236}">
-                <a16:creationId xmlns:a16="http://schemas.microsoft.com/office/drawing/2014/main" id="{AD7759D5-16FD-46EA-BA5F-35693EAE585F}"/>
+                <a16:creationId xmlns:a16="http://schemas.microsoft.com/office/drawing/2014/main" id="{D2418181-3F1C-4E75-B32E-4F295D57AD2B}"/>
               </a:ext>
             </a:extLst>
           </p:cNvPr>
@@ -21109,7 +21178,7 @@
     </p:spTree>
     <p:extLst>
       <p:ext uri="{BB962C8B-B14F-4D97-AF65-F5344CB8AC3E}">
-        <p14:creationId xmlns:p14="http://schemas.microsoft.com/office/powerpoint/2010/main" val="1087979236"/>
+        <p14:creationId xmlns:p14="http://schemas.microsoft.com/office/powerpoint/2010/main" val="1768082848"/>
       </p:ext>
     </p:extLst>
   </p:cSld>
@@ -21151,7 +21220,7 @@
           <p:cNvPr id="4" name="text">
             <a:extLst xmlns:a="http://schemas.openxmlformats.org/drawingml/2006/main">
               <a:ext uri="{FF2B5EF4-FFF2-40B4-BE49-F238E27FC236}">
-                <a16:creationId xmlns:a16="http://schemas.microsoft.com/office/drawing/2014/main" id="{969EC904-198D-4772-B5D8-7E75249B25D1}"/>
+                <a16:creationId xmlns:a16="http://schemas.microsoft.com/office/drawing/2014/main" id="{35E0D37D-CC3A-4054-A64F-AEF26B00A9DF}"/>
               </a:ext>
             </a:extLst>
           </p:cNvPr>
@@ -21208,7 +21277,7 @@
           <p:cNvPr id="2" name="text">
             <a:extLst xmlns:a="http://schemas.openxmlformats.org/drawingml/2006/main">
               <a:ext uri="{FF2B5EF4-FFF2-40B4-BE49-F238E27FC236}">
-                <a16:creationId xmlns:a16="http://schemas.microsoft.com/office/drawing/2014/main" id="{1E6D5893-0417-43DC-BE4D-4402DA4FA9DC}"/>
+                <a16:creationId xmlns:a16="http://schemas.microsoft.com/office/drawing/2014/main" id="{BCF01BC6-B7E9-4B9A-832C-6D6690226645}"/>
               </a:ext>
             </a:extLst>
           </p:cNvPr>
@@ -21265,7 +21334,7 @@
           <p:cNvPr id="3" name="text">
             <a:extLst xmlns:a="http://schemas.openxmlformats.org/drawingml/2006/main">
               <a:ext uri="{FF2B5EF4-FFF2-40B4-BE49-F238E27FC236}">
-                <a16:creationId xmlns:a16="http://schemas.microsoft.com/office/drawing/2014/main" id="{5A4CD448-58DF-4EEC-9CED-A1AA79D9DCA4}"/>
+                <a16:creationId xmlns:a16="http://schemas.microsoft.com/office/drawing/2014/main" id="{945FFE2F-E29A-4EF1-A84A-056DADD45DFA}"/>
               </a:ext>
             </a:extLst>
           </p:cNvPr>
@@ -21320,7 +21389,7 @@
     </p:spTree>
     <p:extLst>
       <p:ext uri="{BB962C8B-B14F-4D97-AF65-F5344CB8AC3E}">
-        <p14:creationId xmlns:p14="http://schemas.microsoft.com/office/powerpoint/2010/main" val="661977550"/>
+        <p14:creationId xmlns:p14="http://schemas.microsoft.com/office/powerpoint/2010/main" val="959585038"/>
       </p:ext>
     </p:extLst>
   </p:cSld>
@@ -21362,7 +21431,7 @@
           <p:cNvPr id="5" name="text">
             <a:extLst xmlns:a="http://schemas.openxmlformats.org/drawingml/2006/main">
               <a:ext uri="{FF2B5EF4-FFF2-40B4-BE49-F238E27FC236}">
-                <a16:creationId xmlns:a16="http://schemas.microsoft.com/office/drawing/2014/main" id="{F3804A14-E23D-4B18-A5DF-F9F527386027}"/>
+                <a16:creationId xmlns:a16="http://schemas.microsoft.com/office/drawing/2014/main" id="{48DA75A2-0E67-4C46-801E-43381DC4B709}"/>
               </a:ext>
             </a:extLst>
           </p:cNvPr>
@@ -21419,7 +21488,7 @@
           <p:cNvPr id="2" name="text">
             <a:extLst xmlns:a="http://schemas.openxmlformats.org/drawingml/2006/main">
               <a:ext uri="{FF2B5EF4-FFF2-40B4-BE49-F238E27FC236}">
-                <a16:creationId xmlns:a16="http://schemas.microsoft.com/office/drawing/2014/main" id="{53F04AA3-B536-4423-B11A-D793623823CA}"/>
+                <a16:creationId xmlns:a16="http://schemas.microsoft.com/office/drawing/2014/main" id="{2D4C82AA-DF15-48D8-ADA4-320A4FC47A39}"/>
               </a:ext>
             </a:extLst>
           </p:cNvPr>
@@ -21476,7 +21545,7 @@
           <p:cNvPr id="3" name="text">
             <a:extLst xmlns:a="http://schemas.openxmlformats.org/drawingml/2006/main">
               <a:ext uri="{FF2B5EF4-FFF2-40B4-BE49-F238E27FC236}">
-                <a16:creationId xmlns:a16="http://schemas.microsoft.com/office/drawing/2014/main" id="{CE269620-082D-4DDF-96FB-78AB8D217382}"/>
+                <a16:creationId xmlns:a16="http://schemas.microsoft.com/office/drawing/2014/main" id="{B15967AB-0EA3-41EF-8BB0-CD4A166DE4B8}"/>
               </a:ext>
             </a:extLst>
           </p:cNvPr>
@@ -21533,7 +21602,7 @@
           <p:cNvPr id="4" name="text">
             <a:extLst xmlns:a="http://schemas.openxmlformats.org/drawingml/2006/main">
               <a:ext uri="{FF2B5EF4-FFF2-40B4-BE49-F238E27FC236}">
-                <a16:creationId xmlns:a16="http://schemas.microsoft.com/office/drawing/2014/main" id="{2B792342-A7DF-4BD9-91E8-56D929A96F4E}"/>
+                <a16:creationId xmlns:a16="http://schemas.microsoft.com/office/drawing/2014/main" id="{A132427C-F75C-451B-B4BE-9E18DFF03801}"/>
               </a:ext>
             </a:extLst>
           </p:cNvPr>
@@ -21588,7 +21657,7 @@
     </p:spTree>
     <p:extLst>
       <p:ext uri="{BB962C8B-B14F-4D97-AF65-F5344CB8AC3E}">
-        <p14:creationId xmlns:p14="http://schemas.microsoft.com/office/powerpoint/2010/main" val="981621177"/>
+        <p14:creationId xmlns:p14="http://schemas.microsoft.com/office/powerpoint/2010/main" val="1564755993"/>
       </p:ext>
     </p:extLst>
   </p:cSld>
@@ -21630,7 +21699,7 @@
           <p:cNvPr id="6" name="text">
             <a:extLst xmlns:a="http://schemas.openxmlformats.org/drawingml/2006/main">
               <a:ext uri="{FF2B5EF4-FFF2-40B4-BE49-F238E27FC236}">
-                <a16:creationId xmlns:a16="http://schemas.microsoft.com/office/drawing/2014/main" id="{48B4B7B0-CD5B-429B-A43E-184856A432B1}"/>
+                <a16:creationId xmlns:a16="http://schemas.microsoft.com/office/drawing/2014/main" id="{5E5A474C-E87E-429B-8B11-8DF7A98C3B73}"/>
               </a:ext>
             </a:extLst>
           </p:cNvPr>
@@ -21687,7 +21756,7 @@
           <p:cNvPr id="2" name="text">
             <a:extLst xmlns:a="http://schemas.openxmlformats.org/drawingml/2006/main">
               <a:ext uri="{FF2B5EF4-FFF2-40B4-BE49-F238E27FC236}">
-                <a16:creationId xmlns:a16="http://schemas.microsoft.com/office/drawing/2014/main" id="{36F4CE28-2A51-4A93-A0FD-5D7A060B3CEB}"/>
+                <a16:creationId xmlns:a16="http://schemas.microsoft.com/office/drawing/2014/main" id="{521E3540-D4EA-4488-85D6-FAB6C4A2D50D}"/>
               </a:ext>
             </a:extLst>
           </p:cNvPr>
@@ -21744,7 +21813,7 @@
           <p:cNvPr id="3" name="text">
             <a:extLst xmlns:a="http://schemas.openxmlformats.org/drawingml/2006/main">
               <a:ext uri="{FF2B5EF4-FFF2-40B4-BE49-F238E27FC236}">
-                <a16:creationId xmlns:a16="http://schemas.microsoft.com/office/drawing/2014/main" id="{E10ADF90-19B9-4E03-9B63-F0E6D83BDAC9}"/>
+                <a16:creationId xmlns:a16="http://schemas.microsoft.com/office/drawing/2014/main" id="{0AC6F5F1-7D45-4127-965E-3CAC6316438F}"/>
               </a:ext>
             </a:extLst>
           </p:cNvPr>
@@ -21801,7 +21870,7 @@
           <p:cNvPr id="4" name="text">
             <a:extLst xmlns:a="http://schemas.openxmlformats.org/drawingml/2006/main">
               <a:ext uri="{FF2B5EF4-FFF2-40B4-BE49-F238E27FC236}">
-                <a16:creationId xmlns:a16="http://schemas.microsoft.com/office/drawing/2014/main" id="{62F781FE-DE4C-4081-80C7-B5D5F2550588}"/>
+                <a16:creationId xmlns:a16="http://schemas.microsoft.com/office/drawing/2014/main" id="{A49ADF5B-ECD6-448E-A91B-81A872A8C507}"/>
               </a:ext>
             </a:extLst>
           </p:cNvPr>
@@ -21858,7 +21927,7 @@
           <p:cNvPr id="5" name="text">
             <a:extLst xmlns:a="http://schemas.openxmlformats.org/drawingml/2006/main">
               <a:ext uri="{FF2B5EF4-FFF2-40B4-BE49-F238E27FC236}">
-                <a16:creationId xmlns:a16="http://schemas.microsoft.com/office/drawing/2014/main" id="{370EEBC9-6A25-40E5-BD8D-5C6B17F1427C}"/>
+                <a16:creationId xmlns:a16="http://schemas.microsoft.com/office/drawing/2014/main" id="{4445B2F9-465B-4CF3-B04D-1DBEC2A5D240}"/>
               </a:ext>
             </a:extLst>
           </p:cNvPr>
@@ -21913,7 +21982,7 @@
     </p:spTree>
     <p:extLst>
       <p:ext uri="{BB962C8B-B14F-4D97-AF65-F5344CB8AC3E}">
-        <p14:creationId xmlns:p14="http://schemas.microsoft.com/office/powerpoint/2010/main" val="450377486"/>
+        <p14:creationId xmlns:p14="http://schemas.microsoft.com/office/powerpoint/2010/main" val="1889706536"/>
       </p:ext>
     </p:extLst>
   </p:cSld>
@@ -21955,7 +22024,7 @@
           <p:cNvPr id="5" name="text">
             <a:extLst xmlns:a="http://schemas.openxmlformats.org/drawingml/2006/main">
               <a:ext uri="{FF2B5EF4-FFF2-40B4-BE49-F238E27FC236}">
-                <a16:creationId xmlns:a16="http://schemas.microsoft.com/office/drawing/2014/main" id="{8C8A13E2-E951-46B0-9B77-46980A83080C}"/>
+                <a16:creationId xmlns:a16="http://schemas.microsoft.com/office/drawing/2014/main" id="{C099E8D3-DC29-4124-894A-7DF51997B62B}"/>
               </a:ext>
             </a:extLst>
           </p:cNvPr>
@@ -22012,7 +22081,7 @@
           <p:cNvPr id="2" name="text">
             <a:extLst xmlns:a="http://schemas.openxmlformats.org/drawingml/2006/main">
               <a:ext uri="{FF2B5EF4-FFF2-40B4-BE49-F238E27FC236}">
-                <a16:creationId xmlns:a16="http://schemas.microsoft.com/office/drawing/2014/main" id="{8045DC4F-F2B2-4669-8250-4162B2B21025}"/>
+                <a16:creationId xmlns:a16="http://schemas.microsoft.com/office/drawing/2014/main" id="{8A4F45A8-961F-4998-B15E-574CBABE6817}"/>
               </a:ext>
             </a:extLst>
           </p:cNvPr>
@@ -22069,7 +22138,7 @@
           <p:cNvPr id="3" name="text">
             <a:extLst xmlns:a="http://schemas.openxmlformats.org/drawingml/2006/main">
               <a:ext uri="{FF2B5EF4-FFF2-40B4-BE49-F238E27FC236}">
-                <a16:creationId xmlns:a16="http://schemas.microsoft.com/office/drawing/2014/main" id="{A762B37B-2E15-4461-99B1-A5FC888C0842}"/>
+                <a16:creationId xmlns:a16="http://schemas.microsoft.com/office/drawing/2014/main" id="{DF203DF9-8CA3-428A-89E4-3C54193FD151}"/>
               </a:ext>
             </a:extLst>
           </p:cNvPr>
@@ -22126,7 +22195,7 @@
           <p:cNvPr id="4" name="text">
             <a:extLst xmlns:a="http://schemas.openxmlformats.org/drawingml/2006/main">
               <a:ext uri="{FF2B5EF4-FFF2-40B4-BE49-F238E27FC236}">
-                <a16:creationId xmlns:a16="http://schemas.microsoft.com/office/drawing/2014/main" id="{346EEFCF-843C-4C2A-B194-655336103F5E}"/>
+                <a16:creationId xmlns:a16="http://schemas.microsoft.com/office/drawing/2014/main" id="{854647CF-DAC8-4F45-AEEB-71E3B14135DB}"/>
               </a:ext>
             </a:extLst>
           </p:cNvPr>
@@ -22181,7 +22250,7 @@
     </p:spTree>
     <p:extLst>
       <p:ext uri="{BB962C8B-B14F-4D97-AF65-F5344CB8AC3E}">
-        <p14:creationId xmlns:p14="http://schemas.microsoft.com/office/powerpoint/2010/main" val="236997468"/>
+        <p14:creationId xmlns:p14="http://schemas.microsoft.com/office/powerpoint/2010/main" val="985393710"/>
       </p:ext>
     </p:extLst>
   </p:cSld>
@@ -22223,7 +22292,7 @@
           <p:cNvPr id="6" name="text">
             <a:extLst xmlns:a="http://schemas.openxmlformats.org/drawingml/2006/main">
               <a:ext uri="{FF2B5EF4-FFF2-40B4-BE49-F238E27FC236}">
-                <a16:creationId xmlns:a16="http://schemas.microsoft.com/office/drawing/2014/main" id="{F42D31B7-7A62-405B-A8FF-2E3688198CF7}"/>
+                <a16:creationId xmlns:a16="http://schemas.microsoft.com/office/drawing/2014/main" id="{30FCD1A8-646C-4A9C-9890-36D8BCDFB1C1}"/>
               </a:ext>
             </a:extLst>
           </p:cNvPr>
@@ -22280,7 +22349,7 @@
           <p:cNvPr id="2" name="text">
             <a:extLst xmlns:a="http://schemas.openxmlformats.org/drawingml/2006/main">
               <a:ext uri="{FF2B5EF4-FFF2-40B4-BE49-F238E27FC236}">
-                <a16:creationId xmlns:a16="http://schemas.microsoft.com/office/drawing/2014/main" id="{7B90A6A4-CCBC-4C4C-AF09-B47597364AB1}"/>
+                <a16:creationId xmlns:a16="http://schemas.microsoft.com/office/drawing/2014/main" id="{196B5FDA-F423-43D1-96E1-08309C6E47ED}"/>
               </a:ext>
             </a:extLst>
           </p:cNvPr>
@@ -22337,7 +22406,7 @@
           <p:cNvPr id="3" name="text">
             <a:extLst xmlns:a="http://schemas.openxmlformats.org/drawingml/2006/main">
               <a:ext uri="{FF2B5EF4-FFF2-40B4-BE49-F238E27FC236}">
-                <a16:creationId xmlns:a16="http://schemas.microsoft.com/office/drawing/2014/main" id="{CE08F0F8-3037-4C9E-8DE3-B6C9CC96357B}"/>
+                <a16:creationId xmlns:a16="http://schemas.microsoft.com/office/drawing/2014/main" id="{C6F5071D-CDFF-4A5D-B0FF-AF90840FF40D}"/>
               </a:ext>
             </a:extLst>
           </p:cNvPr>
@@ -22394,7 +22463,7 @@
           <p:cNvPr id="4" name="text">
             <a:extLst xmlns:a="http://schemas.openxmlformats.org/drawingml/2006/main">
               <a:ext uri="{FF2B5EF4-FFF2-40B4-BE49-F238E27FC236}">
-                <a16:creationId xmlns:a16="http://schemas.microsoft.com/office/drawing/2014/main" id="{3A787AB5-6053-49B8-BCE6-C89B0B8F0012}"/>
+                <a16:creationId xmlns:a16="http://schemas.microsoft.com/office/drawing/2014/main" id="{5C5E6C27-11D4-4BCC-8386-17CD26D4FE40}"/>
               </a:ext>
             </a:extLst>
           </p:cNvPr>
@@ -22451,7 +22520,7 @@
           <p:cNvPr id="5" name="text">
             <a:extLst xmlns:a="http://schemas.openxmlformats.org/drawingml/2006/main">
               <a:ext uri="{FF2B5EF4-FFF2-40B4-BE49-F238E27FC236}">
-                <a16:creationId xmlns:a16="http://schemas.microsoft.com/office/drawing/2014/main" id="{B267E1EE-9006-4A2A-88C2-1D033A3B233C}"/>
+                <a16:creationId xmlns:a16="http://schemas.microsoft.com/office/drawing/2014/main" id="{0EB53C07-3650-4BF0-AA21-A927BB20EBFB}"/>
               </a:ext>
             </a:extLst>
           </p:cNvPr>
@@ -22506,7 +22575,7 @@
     </p:spTree>
     <p:extLst>
       <p:ext uri="{BB962C8B-B14F-4D97-AF65-F5344CB8AC3E}">
-        <p14:creationId xmlns:p14="http://schemas.microsoft.com/office/powerpoint/2010/main" val="852752459"/>
+        <p14:creationId xmlns:p14="http://schemas.microsoft.com/office/powerpoint/2010/main" val="989275361"/>
       </p:ext>
     </p:extLst>
   </p:cSld>
@@ -22548,7 +22617,7 @@
           <p:cNvPr id="8" name="text">
             <a:extLst xmlns:a="http://schemas.openxmlformats.org/drawingml/2006/main">
               <a:ext uri="{FF2B5EF4-FFF2-40B4-BE49-F238E27FC236}">
-                <a16:creationId xmlns:a16="http://schemas.microsoft.com/office/drawing/2014/main" id="{48DF30B5-E365-4E08-BA85-DB4EE44DCE8F}"/>
+                <a16:creationId xmlns:a16="http://schemas.microsoft.com/office/drawing/2014/main" id="{49CD380F-07FE-494A-A8C7-674075E435C3}"/>
               </a:ext>
             </a:extLst>
           </p:cNvPr>
@@ -22605,7 +22674,7 @@
           <p:cNvPr id="2" name="text">
             <a:extLst xmlns:a="http://schemas.openxmlformats.org/drawingml/2006/main">
               <a:ext uri="{FF2B5EF4-FFF2-40B4-BE49-F238E27FC236}">
-                <a16:creationId xmlns:a16="http://schemas.microsoft.com/office/drawing/2014/main" id="{93A34789-B133-4521-9ACF-B9526A8DAE94}"/>
+                <a16:creationId xmlns:a16="http://schemas.microsoft.com/office/drawing/2014/main" id="{9DA5FFA6-F644-433B-859E-C6400DFA48B1}"/>
               </a:ext>
             </a:extLst>
           </p:cNvPr>
@@ -22662,7 +22731,7 @@
           <p:cNvPr id="3" name="text">
             <a:extLst xmlns:a="http://schemas.openxmlformats.org/drawingml/2006/main">
               <a:ext uri="{FF2B5EF4-FFF2-40B4-BE49-F238E27FC236}">
-                <a16:creationId xmlns:a16="http://schemas.microsoft.com/office/drawing/2014/main" id="{5257E3DB-2B04-4D13-A33D-98A301C1C603}"/>
+                <a16:creationId xmlns:a16="http://schemas.microsoft.com/office/drawing/2014/main" id="{0086A919-FE3F-4ECE-A71F-CED4AD5C31B3}"/>
               </a:ext>
             </a:extLst>
           </p:cNvPr>
@@ -22719,7 +22788,7 @@
           <p:cNvPr id="4" name="text">
             <a:extLst xmlns:a="http://schemas.openxmlformats.org/drawingml/2006/main">
               <a:ext uri="{FF2B5EF4-FFF2-40B4-BE49-F238E27FC236}">
-                <a16:creationId xmlns:a16="http://schemas.microsoft.com/office/drawing/2014/main" id="{E815BFC5-FEE2-43E7-A635-7B7736AF076C}"/>
+                <a16:creationId xmlns:a16="http://schemas.microsoft.com/office/drawing/2014/main" id="{1A246ABD-34B4-49F2-B861-D04E390C1AAE}"/>
               </a:ext>
             </a:extLst>
           </p:cNvPr>
@@ -22776,7 +22845,7 @@
           <p:cNvPr id="5" name="text">
             <a:extLst xmlns:a="http://schemas.openxmlformats.org/drawingml/2006/main">
               <a:ext uri="{FF2B5EF4-FFF2-40B4-BE49-F238E27FC236}">
-                <a16:creationId xmlns:a16="http://schemas.microsoft.com/office/drawing/2014/main" id="{760FD6F4-20D1-462B-8CED-832363F9CD9C}"/>
+                <a16:creationId xmlns:a16="http://schemas.microsoft.com/office/drawing/2014/main" id="{7300559F-FAB0-4A69-9F49-972544F294FF}"/>
               </a:ext>
             </a:extLst>
           </p:cNvPr>
@@ -22833,7 +22902,7 @@
           <p:cNvPr id="6" name="text">
             <a:extLst xmlns:a="http://schemas.openxmlformats.org/drawingml/2006/main">
               <a:ext uri="{FF2B5EF4-FFF2-40B4-BE49-F238E27FC236}">
-                <a16:creationId xmlns:a16="http://schemas.microsoft.com/office/drawing/2014/main" id="{F80A8D9D-09E9-4701-915B-8EB5AACA194E}"/>
+                <a16:creationId xmlns:a16="http://schemas.microsoft.com/office/drawing/2014/main" id="{0ED7BADE-20FF-43F9-B8C4-DB8FA5DA880E}"/>
               </a:ext>
             </a:extLst>
           </p:cNvPr>
@@ -22890,7 +22959,7 @@
           <p:cNvPr id="7" name="text">
             <a:extLst xmlns:a="http://schemas.openxmlformats.org/drawingml/2006/main">
               <a:ext uri="{FF2B5EF4-FFF2-40B4-BE49-F238E27FC236}">
-                <a16:creationId xmlns:a16="http://schemas.microsoft.com/office/drawing/2014/main" id="{11223028-BA6E-4123-866D-73498823D8E6}"/>
+                <a16:creationId xmlns:a16="http://schemas.microsoft.com/office/drawing/2014/main" id="{AF48E96A-C361-4685-85A6-49BEC97C2438}"/>
               </a:ext>
             </a:extLst>
           </p:cNvPr>
@@ -22945,7 +23014,7 @@
     </p:spTree>
     <p:extLst>
       <p:ext uri="{BB962C8B-B14F-4D97-AF65-F5344CB8AC3E}">
-        <p14:creationId xmlns:p14="http://schemas.microsoft.com/office/powerpoint/2010/main" val="1676161213"/>
+        <p14:creationId xmlns:p14="http://schemas.microsoft.com/office/powerpoint/2010/main" val="1095904385"/>
       </p:ext>
     </p:extLst>
   </p:cSld>
@@ -22991,7 +23060,7 @@
           <p:nvPr/>
         </p:nvPicPr>
         <p:blipFill>
-          <a:blip xmlns:r="http://schemas.openxmlformats.org/officeDocument/2006/relationships" xmlns:a="http://schemas.openxmlformats.org/drawingml/2006/main" r:embed="R2fa8b4fb18e44151"/>
+          <a:blip xmlns:r="http://schemas.openxmlformats.org/officeDocument/2006/relationships" xmlns:a="http://schemas.openxmlformats.org/drawingml/2006/main" r:embed="R0908d3c2474a401d"/>
           <a:stretch xmlns:a="http://schemas.openxmlformats.org/drawingml/2006/main"/>
         </p:blipFill>
         <p:spPr>
@@ -23007,7 +23076,7 @@
     </p:spTree>
     <p:extLst>
       <p:ext uri="{BB962C8B-B14F-4D97-AF65-F5344CB8AC3E}">
-        <p14:creationId xmlns:p14="http://schemas.microsoft.com/office/powerpoint/2010/main" val="1366435839"/>
+        <p14:creationId xmlns:p14="http://schemas.microsoft.com/office/powerpoint/2010/main" val="106673147"/>
       </p:ext>
     </p:extLst>
   </p:cSld>
@@ -23049,7 +23118,7 @@
           <p:cNvPr id="6" name="text">
             <a:extLst xmlns:a="http://schemas.openxmlformats.org/drawingml/2006/main">
               <a:ext uri="{FF2B5EF4-FFF2-40B4-BE49-F238E27FC236}">
-                <a16:creationId xmlns:a16="http://schemas.microsoft.com/office/drawing/2014/main" id="{5E143CD2-4984-46C0-A58E-BCD33740ED55}"/>
+                <a16:creationId xmlns:a16="http://schemas.microsoft.com/office/drawing/2014/main" id="{4EE2D499-57BC-442B-9506-3C0081CFE1F7}"/>
               </a:ext>
             </a:extLst>
           </p:cNvPr>
@@ -23106,7 +23175,7 @@
           <p:cNvPr id="2" name="text">
             <a:extLst xmlns:a="http://schemas.openxmlformats.org/drawingml/2006/main">
               <a:ext uri="{FF2B5EF4-FFF2-40B4-BE49-F238E27FC236}">
-                <a16:creationId xmlns:a16="http://schemas.microsoft.com/office/drawing/2014/main" id="{3B8761D9-4C7C-4A1E-B88E-4D3601F94E0E}"/>
+                <a16:creationId xmlns:a16="http://schemas.microsoft.com/office/drawing/2014/main" id="{0FF94ADD-B4FF-4D86-AB33-59F9BFD456F0}"/>
               </a:ext>
             </a:extLst>
           </p:cNvPr>
@@ -23163,7 +23232,7 @@
           <p:cNvPr id="3" name="text">
             <a:extLst xmlns:a="http://schemas.openxmlformats.org/drawingml/2006/main">
               <a:ext uri="{FF2B5EF4-FFF2-40B4-BE49-F238E27FC236}">
-                <a16:creationId xmlns:a16="http://schemas.microsoft.com/office/drawing/2014/main" id="{E7F171A7-37DD-42FA-A918-18BC7BC5F2B4}"/>
+                <a16:creationId xmlns:a16="http://schemas.microsoft.com/office/drawing/2014/main" id="{491AD024-804A-4AF0-BD80-7A97BA3DE258}"/>
               </a:ext>
             </a:extLst>
           </p:cNvPr>
@@ -23220,7 +23289,7 @@
           <p:cNvPr id="4" name="text">
             <a:extLst xmlns:a="http://schemas.openxmlformats.org/drawingml/2006/main">
               <a:ext uri="{FF2B5EF4-FFF2-40B4-BE49-F238E27FC236}">
-                <a16:creationId xmlns:a16="http://schemas.microsoft.com/office/drawing/2014/main" id="{8682F20C-FA17-4BB3-8CE7-6C661E9F6839}"/>
+                <a16:creationId xmlns:a16="http://schemas.microsoft.com/office/drawing/2014/main" id="{9E3C1291-C9E2-4121-B88A-8FFAB5763FFC}"/>
               </a:ext>
             </a:extLst>
           </p:cNvPr>
@@ -23277,7 +23346,7 @@
           <p:cNvPr id="5" name="text">
             <a:extLst xmlns:a="http://schemas.openxmlformats.org/drawingml/2006/main">
               <a:ext uri="{FF2B5EF4-FFF2-40B4-BE49-F238E27FC236}">
-                <a16:creationId xmlns:a16="http://schemas.microsoft.com/office/drawing/2014/main" id="{A2CD7055-5A8B-4932-BD08-2DDA04A5DBFA}"/>
+                <a16:creationId xmlns:a16="http://schemas.microsoft.com/office/drawing/2014/main" id="{0D7AE60E-A61E-4042-942A-F5292D36459E}"/>
               </a:ext>
             </a:extLst>
           </p:cNvPr>
@@ -23332,7 +23401,7 @@
     </p:spTree>
     <p:extLst>
       <p:ext uri="{BB962C8B-B14F-4D97-AF65-F5344CB8AC3E}">
-        <p14:creationId xmlns:p14="http://schemas.microsoft.com/office/powerpoint/2010/main" val="1752352949"/>
+        <p14:creationId xmlns:p14="http://schemas.microsoft.com/office/powerpoint/2010/main" val="139522462"/>
       </p:ext>
     </p:extLst>
   </p:cSld>
@@ -23374,7 +23443,7 @@
           <p:cNvPr id="6" name="text">
             <a:extLst xmlns:a="http://schemas.openxmlformats.org/drawingml/2006/main">
               <a:ext uri="{FF2B5EF4-FFF2-40B4-BE49-F238E27FC236}">
-                <a16:creationId xmlns:a16="http://schemas.microsoft.com/office/drawing/2014/main" id="{17153549-55F7-4C58-B2C7-955ABB53B32B}"/>
+                <a16:creationId xmlns:a16="http://schemas.microsoft.com/office/drawing/2014/main" id="{8D2FE5CC-16AC-4C81-B8C4-FFD414C03AB9}"/>
               </a:ext>
             </a:extLst>
           </p:cNvPr>
@@ -23431,7 +23500,7 @@
           <p:cNvPr id="2" name="text">
             <a:extLst xmlns:a="http://schemas.openxmlformats.org/drawingml/2006/main">
               <a:ext uri="{FF2B5EF4-FFF2-40B4-BE49-F238E27FC236}">
-                <a16:creationId xmlns:a16="http://schemas.microsoft.com/office/drawing/2014/main" id="{8D201B08-48BD-4AFB-BD57-53C4366E187C}"/>
+                <a16:creationId xmlns:a16="http://schemas.microsoft.com/office/drawing/2014/main" id="{043C3C49-F4AA-4D9F-A9AD-68877E1FD0CF}"/>
               </a:ext>
             </a:extLst>
           </p:cNvPr>
@@ -23488,7 +23557,7 @@
           <p:cNvPr id="3" name="text">
             <a:extLst xmlns:a="http://schemas.openxmlformats.org/drawingml/2006/main">
               <a:ext uri="{FF2B5EF4-FFF2-40B4-BE49-F238E27FC236}">
-                <a16:creationId xmlns:a16="http://schemas.microsoft.com/office/drawing/2014/main" id="{2FD65212-3038-4A52-A510-6683209E5674}"/>
+                <a16:creationId xmlns:a16="http://schemas.microsoft.com/office/drawing/2014/main" id="{9B735410-6DD8-445B-B1E6-29D1B4B335CC}"/>
               </a:ext>
             </a:extLst>
           </p:cNvPr>
@@ -23545,7 +23614,7 @@
           <p:cNvPr id="4" name="text">
             <a:extLst xmlns:a="http://schemas.openxmlformats.org/drawingml/2006/main">
               <a:ext uri="{FF2B5EF4-FFF2-40B4-BE49-F238E27FC236}">
-                <a16:creationId xmlns:a16="http://schemas.microsoft.com/office/drawing/2014/main" id="{EF62D12C-B018-443B-B1A5-6E23ED8B9C34}"/>
+                <a16:creationId xmlns:a16="http://schemas.microsoft.com/office/drawing/2014/main" id="{67C655EF-9FF3-48E5-BB5F-30F0B6BEB439}"/>
               </a:ext>
             </a:extLst>
           </p:cNvPr>
@@ -23602,7 +23671,7 @@
           <p:cNvPr id="5" name="text">
             <a:extLst xmlns:a="http://schemas.openxmlformats.org/drawingml/2006/main">
               <a:ext uri="{FF2B5EF4-FFF2-40B4-BE49-F238E27FC236}">
-                <a16:creationId xmlns:a16="http://schemas.microsoft.com/office/drawing/2014/main" id="{3D5E3858-42B9-4C8E-BA48-0B34E4D111B8}"/>
+                <a16:creationId xmlns:a16="http://schemas.microsoft.com/office/drawing/2014/main" id="{C4538C24-7DF8-4A40-BD0D-AA4514F92B32}"/>
               </a:ext>
             </a:extLst>
           </p:cNvPr>
@@ -23657,7 +23726,7 @@
     </p:spTree>
     <p:extLst>
       <p:ext uri="{BB962C8B-B14F-4D97-AF65-F5344CB8AC3E}">
-        <p14:creationId xmlns:p14="http://schemas.microsoft.com/office/powerpoint/2010/main" val="124664136"/>
+        <p14:creationId xmlns:p14="http://schemas.microsoft.com/office/powerpoint/2010/main" val="23833042"/>
       </p:ext>
     </p:extLst>
   </p:cSld>
@@ -23699,7 +23768,7 @@
           <p:cNvPr id="9" name="text">
             <a:extLst xmlns:a="http://schemas.openxmlformats.org/drawingml/2006/main">
               <a:ext uri="{FF2B5EF4-FFF2-40B4-BE49-F238E27FC236}">
-                <a16:creationId xmlns:a16="http://schemas.microsoft.com/office/drawing/2014/main" id="{40322907-B9CC-4129-A55A-10D1E42B14A9}"/>
+                <a16:creationId xmlns:a16="http://schemas.microsoft.com/office/drawing/2014/main" id="{84614EAC-0161-409D-AB7F-59960ECF93EE}"/>
               </a:ext>
             </a:extLst>
           </p:cNvPr>
@@ -23756,7 +23825,7 @@
           <p:cNvPr id="2" name="text">
             <a:extLst xmlns:a="http://schemas.openxmlformats.org/drawingml/2006/main">
               <a:ext uri="{FF2B5EF4-FFF2-40B4-BE49-F238E27FC236}">
-                <a16:creationId xmlns:a16="http://schemas.microsoft.com/office/drawing/2014/main" id="{37A93BDF-883D-4AF2-9084-876FD47F0B01}"/>
+                <a16:creationId xmlns:a16="http://schemas.microsoft.com/office/drawing/2014/main" id="{EEA10A82-60DD-48BB-AAAF-48929511F21D}"/>
               </a:ext>
             </a:extLst>
           </p:cNvPr>
@@ -23813,7 +23882,7 @@
           <p:cNvPr id="3" name="text">
             <a:extLst xmlns:a="http://schemas.openxmlformats.org/drawingml/2006/main">
               <a:ext uri="{FF2B5EF4-FFF2-40B4-BE49-F238E27FC236}">
-                <a16:creationId xmlns:a16="http://schemas.microsoft.com/office/drawing/2014/main" id="{1D85CD3D-048C-4268-820F-69338EBAEBEF}"/>
+                <a16:creationId xmlns:a16="http://schemas.microsoft.com/office/drawing/2014/main" id="{347891D6-F289-4F9F-AD98-B86690470A12}"/>
               </a:ext>
             </a:extLst>
           </p:cNvPr>
@@ -23870,7 +23939,7 @@
           <p:cNvPr id="4" name="text">
             <a:extLst xmlns:a="http://schemas.openxmlformats.org/drawingml/2006/main">
               <a:ext uri="{FF2B5EF4-FFF2-40B4-BE49-F238E27FC236}">
-                <a16:creationId xmlns:a16="http://schemas.microsoft.com/office/drawing/2014/main" id="{52C43A22-EB14-4CC7-BC10-8F764E19AF3D}"/>
+                <a16:creationId xmlns:a16="http://schemas.microsoft.com/office/drawing/2014/main" id="{4C457A06-36D1-4CCE-B0C1-F27345043F1F}"/>
               </a:ext>
             </a:extLst>
           </p:cNvPr>
@@ -23927,7 +23996,7 @@
           <p:cNvPr id="5" name="text">
             <a:extLst xmlns:a="http://schemas.openxmlformats.org/drawingml/2006/main">
               <a:ext uri="{FF2B5EF4-FFF2-40B4-BE49-F238E27FC236}">
-                <a16:creationId xmlns:a16="http://schemas.microsoft.com/office/drawing/2014/main" id="{E4F609C4-3EDA-42B8-BD78-9FCEADBC831E}"/>
+                <a16:creationId xmlns:a16="http://schemas.microsoft.com/office/drawing/2014/main" id="{8C90EC3A-0A63-4C57-9531-5CCB73950DD6}"/>
               </a:ext>
             </a:extLst>
           </p:cNvPr>
@@ -23984,7 +24053,7 @@
           <p:cNvPr id="6" name="text">
             <a:extLst xmlns:a="http://schemas.openxmlformats.org/drawingml/2006/main">
               <a:ext uri="{FF2B5EF4-FFF2-40B4-BE49-F238E27FC236}">
-                <a16:creationId xmlns:a16="http://schemas.microsoft.com/office/drawing/2014/main" id="{390FEC52-D9C1-47DE-8419-81EC3C8B2786}"/>
+                <a16:creationId xmlns:a16="http://schemas.microsoft.com/office/drawing/2014/main" id="{790129E8-61C0-4FFF-B0D6-0CD8D8534800}"/>
               </a:ext>
             </a:extLst>
           </p:cNvPr>
@@ -24041,7 +24110,7 @@
           <p:cNvPr id="7" name="text">
             <a:extLst xmlns:a="http://schemas.openxmlformats.org/drawingml/2006/main">
               <a:ext uri="{FF2B5EF4-FFF2-40B4-BE49-F238E27FC236}">
-                <a16:creationId xmlns:a16="http://schemas.microsoft.com/office/drawing/2014/main" id="{1533DE36-87B9-4C8A-AFCB-8F3EDE4FEEF1}"/>
+                <a16:creationId xmlns:a16="http://schemas.microsoft.com/office/drawing/2014/main" id="{CFE60C9C-ABFA-4A6F-B5FD-4D47A34D5916}"/>
               </a:ext>
             </a:extLst>
           </p:cNvPr>
@@ -24087,7 +24156,7 @@
                 <a:latin typeface="Heebo"/>
                 <a:ea typeface="Heebo"/>
                 <a:cs typeface="Heebo"/>
-                <a:hlinkClick xmlns:r="http://schemas.openxmlformats.org/officeDocument/2006/relationships" r:id="Rd0fbef3260e24fe1"/>
+                <a:hlinkClick xmlns:r="http://schemas.openxmlformats.org/officeDocument/2006/relationships" r:id="R7abdcd3dbfcc427d"/>
               </a:rPr>
               <a:t>דף תרגול · PDF</a:t>
             </a:r>
@@ -24099,7 +24168,7 @@
           <p:cNvPr id="8" name="text">
             <a:extLst xmlns:a="http://schemas.openxmlformats.org/drawingml/2006/main">
               <a:ext uri="{FF2B5EF4-FFF2-40B4-BE49-F238E27FC236}">
-                <a16:creationId xmlns:a16="http://schemas.microsoft.com/office/drawing/2014/main" id="{602C3E29-803F-4C63-A647-A67725782879}"/>
+                <a16:creationId xmlns:a16="http://schemas.microsoft.com/office/drawing/2014/main" id="{8ADCF699-AB4E-42C6-87C4-5E78302354F8}"/>
               </a:ext>
             </a:extLst>
           </p:cNvPr>
@@ -24154,7 +24223,7 @@
     </p:spTree>
     <p:extLst>
       <p:ext uri="{BB962C8B-B14F-4D97-AF65-F5344CB8AC3E}">
-        <p14:creationId xmlns:p14="http://schemas.microsoft.com/office/powerpoint/2010/main" val="1395732435"/>
+        <p14:creationId xmlns:p14="http://schemas.microsoft.com/office/powerpoint/2010/main" val="1707862230"/>
       </p:ext>
     </p:extLst>
   </p:cSld>
@@ -24196,7 +24265,7 @@
           <p:cNvPr id="9" name="text">
             <a:extLst xmlns:a="http://schemas.openxmlformats.org/drawingml/2006/main">
               <a:ext uri="{FF2B5EF4-FFF2-40B4-BE49-F238E27FC236}">
-                <a16:creationId xmlns:a16="http://schemas.microsoft.com/office/drawing/2014/main" id="{7956314C-1EBA-446E-B859-DC9A0BE7B22C}"/>
+                <a16:creationId xmlns:a16="http://schemas.microsoft.com/office/drawing/2014/main" id="{E9D7CD11-9A62-4B7B-80C2-703C588A9535}"/>
               </a:ext>
             </a:extLst>
           </p:cNvPr>
@@ -24253,7 +24322,7 @@
           <p:cNvPr id="2" name="text">
             <a:extLst xmlns:a="http://schemas.openxmlformats.org/drawingml/2006/main">
               <a:ext uri="{FF2B5EF4-FFF2-40B4-BE49-F238E27FC236}">
-                <a16:creationId xmlns:a16="http://schemas.microsoft.com/office/drawing/2014/main" id="{D22EDCD9-244D-4757-8233-7FA77896649D}"/>
+                <a16:creationId xmlns:a16="http://schemas.microsoft.com/office/drawing/2014/main" id="{7653BBB9-126E-4E1D-8C42-2ABAD3BBC218}"/>
               </a:ext>
             </a:extLst>
           </p:cNvPr>
@@ -24310,7 +24379,7 @@
           <p:cNvPr id="3" name="text">
             <a:extLst xmlns:a="http://schemas.openxmlformats.org/drawingml/2006/main">
               <a:ext uri="{FF2B5EF4-FFF2-40B4-BE49-F238E27FC236}">
-                <a16:creationId xmlns:a16="http://schemas.microsoft.com/office/drawing/2014/main" id="{0A003AF6-27E3-45C9-A776-04031F2E85D3}"/>
+                <a16:creationId xmlns:a16="http://schemas.microsoft.com/office/drawing/2014/main" id="{E4686CB4-8199-46B9-AA6C-B0F3ED73403B}"/>
               </a:ext>
             </a:extLst>
           </p:cNvPr>
@@ -24367,7 +24436,7 @@
           <p:cNvPr id="4" name="text">
             <a:extLst xmlns:a="http://schemas.openxmlformats.org/drawingml/2006/main">
               <a:ext uri="{FF2B5EF4-FFF2-40B4-BE49-F238E27FC236}">
-                <a16:creationId xmlns:a16="http://schemas.microsoft.com/office/drawing/2014/main" id="{2F9390E4-A8D2-402C-AD08-A4323023B2C5}"/>
+                <a16:creationId xmlns:a16="http://schemas.microsoft.com/office/drawing/2014/main" id="{05C280E2-DED6-4F2B-8E1B-0685336FB6D2}"/>
               </a:ext>
             </a:extLst>
           </p:cNvPr>
@@ -24424,7 +24493,7 @@
           <p:cNvPr id="5" name="text">
             <a:extLst xmlns:a="http://schemas.openxmlformats.org/drawingml/2006/main">
               <a:ext uri="{FF2B5EF4-FFF2-40B4-BE49-F238E27FC236}">
-                <a16:creationId xmlns:a16="http://schemas.microsoft.com/office/drawing/2014/main" id="{78C1DD11-BEC5-459F-9285-0624CE195E91}"/>
+                <a16:creationId xmlns:a16="http://schemas.microsoft.com/office/drawing/2014/main" id="{8B1C0185-B34E-46CA-BE77-3851C50DFA0C}"/>
               </a:ext>
             </a:extLst>
           </p:cNvPr>
@@ -24481,7 +24550,7 @@
           <p:cNvPr id="6" name="text">
             <a:extLst xmlns:a="http://schemas.openxmlformats.org/drawingml/2006/main">
               <a:ext uri="{FF2B5EF4-FFF2-40B4-BE49-F238E27FC236}">
-                <a16:creationId xmlns:a16="http://schemas.microsoft.com/office/drawing/2014/main" id="{BB6C7DA5-B2B2-4EBE-9E61-7818C7D2A46C}"/>
+                <a16:creationId xmlns:a16="http://schemas.microsoft.com/office/drawing/2014/main" id="{AF54E25E-8AFA-46F2-A3BF-A09CADA0CA96}"/>
               </a:ext>
             </a:extLst>
           </p:cNvPr>
@@ -24538,7 +24607,7 @@
           <p:cNvPr id="7" name="text">
             <a:extLst xmlns:a="http://schemas.openxmlformats.org/drawingml/2006/main">
               <a:ext uri="{FF2B5EF4-FFF2-40B4-BE49-F238E27FC236}">
-                <a16:creationId xmlns:a16="http://schemas.microsoft.com/office/drawing/2014/main" id="{8C8737D4-7288-4955-A955-C70FDF5E118D}"/>
+                <a16:creationId xmlns:a16="http://schemas.microsoft.com/office/drawing/2014/main" id="{E70DF3A9-B13B-4422-B146-F134340EEB2E}"/>
               </a:ext>
             </a:extLst>
           </p:cNvPr>
@@ -24595,7 +24664,7 @@
           <p:cNvPr id="8" name="text">
             <a:extLst xmlns:a="http://schemas.openxmlformats.org/drawingml/2006/main">
               <a:ext uri="{FF2B5EF4-FFF2-40B4-BE49-F238E27FC236}">
-                <a16:creationId xmlns:a16="http://schemas.microsoft.com/office/drawing/2014/main" id="{E697449C-2841-4B69-978E-8C61D00D73F7}"/>
+                <a16:creationId xmlns:a16="http://schemas.microsoft.com/office/drawing/2014/main" id="{CB275E08-AF04-4EE8-B562-E79C2AE875B8}"/>
               </a:ext>
             </a:extLst>
           </p:cNvPr>
@@ -24650,7 +24719,7 @@
     </p:spTree>
     <p:extLst>
       <p:ext uri="{BB962C8B-B14F-4D97-AF65-F5344CB8AC3E}">
-        <p14:creationId xmlns:p14="http://schemas.microsoft.com/office/powerpoint/2010/main" val="1754525862"/>
+        <p14:creationId xmlns:p14="http://schemas.microsoft.com/office/powerpoint/2010/main" val="2138551588"/>
       </p:ext>
     </p:extLst>
   </p:cSld>
@@ -24692,7 +24761,7 @@
           <p:cNvPr id="6" name="text">
             <a:extLst xmlns:a="http://schemas.openxmlformats.org/drawingml/2006/main">
               <a:ext uri="{FF2B5EF4-FFF2-40B4-BE49-F238E27FC236}">
-                <a16:creationId xmlns:a16="http://schemas.microsoft.com/office/drawing/2014/main" id="{1B7602F6-DAA3-452E-B25D-886508A322F3}"/>
+                <a16:creationId xmlns:a16="http://schemas.microsoft.com/office/drawing/2014/main" id="{CDC961E6-AF02-4C89-AF21-B3D48FF27B98}"/>
               </a:ext>
             </a:extLst>
           </p:cNvPr>
@@ -24749,7 +24818,7 @@
           <p:cNvPr id="2" name="text">
             <a:extLst xmlns:a="http://schemas.openxmlformats.org/drawingml/2006/main">
               <a:ext uri="{FF2B5EF4-FFF2-40B4-BE49-F238E27FC236}">
-                <a16:creationId xmlns:a16="http://schemas.microsoft.com/office/drawing/2014/main" id="{CF0ED9FD-7A84-4704-A59A-E867B47B47B6}"/>
+                <a16:creationId xmlns:a16="http://schemas.microsoft.com/office/drawing/2014/main" id="{3D040E64-E319-468F-9968-512E7899CEDE}"/>
               </a:ext>
             </a:extLst>
           </p:cNvPr>
@@ -24806,7 +24875,7 @@
           <p:cNvPr id="3" name="text">
             <a:extLst xmlns:a="http://schemas.openxmlformats.org/drawingml/2006/main">
               <a:ext uri="{FF2B5EF4-FFF2-40B4-BE49-F238E27FC236}">
-                <a16:creationId xmlns:a16="http://schemas.microsoft.com/office/drawing/2014/main" id="{DEB92F5C-B7F5-44BA-A699-B559DE721A71}"/>
+                <a16:creationId xmlns:a16="http://schemas.microsoft.com/office/drawing/2014/main" id="{FA93CB66-52D6-4408-9566-C1AE59EB20F2}"/>
               </a:ext>
             </a:extLst>
           </p:cNvPr>
@@ -24863,7 +24932,7 @@
           <p:cNvPr id="4" name="text">
             <a:extLst xmlns:a="http://schemas.openxmlformats.org/drawingml/2006/main">
               <a:ext uri="{FF2B5EF4-FFF2-40B4-BE49-F238E27FC236}">
-                <a16:creationId xmlns:a16="http://schemas.microsoft.com/office/drawing/2014/main" id="{4538CEDB-9686-4523-8364-A119F141D12F}"/>
+                <a16:creationId xmlns:a16="http://schemas.microsoft.com/office/drawing/2014/main" id="{DAE28DB6-40B1-4EF1-BD90-B14818261295}"/>
               </a:ext>
             </a:extLst>
           </p:cNvPr>
@@ -24920,7 +24989,7 @@
           <p:cNvPr id="5" name="text">
             <a:extLst xmlns:a="http://schemas.openxmlformats.org/drawingml/2006/main">
               <a:ext uri="{FF2B5EF4-FFF2-40B4-BE49-F238E27FC236}">
-                <a16:creationId xmlns:a16="http://schemas.microsoft.com/office/drawing/2014/main" id="{8134542D-5431-4328-AED6-39521F1118A6}"/>
+                <a16:creationId xmlns:a16="http://schemas.microsoft.com/office/drawing/2014/main" id="{AFD11336-0D30-45C7-AB6F-295F6D924287}"/>
               </a:ext>
             </a:extLst>
           </p:cNvPr>
@@ -24975,7 +25044,7 @@
     </p:spTree>
     <p:extLst>
       <p:ext uri="{BB962C8B-B14F-4D97-AF65-F5344CB8AC3E}">
-        <p14:creationId xmlns:p14="http://schemas.microsoft.com/office/powerpoint/2010/main" val="963226373"/>
+        <p14:creationId xmlns:p14="http://schemas.microsoft.com/office/powerpoint/2010/main" val="1647820272"/>
       </p:ext>
     </p:extLst>
   </p:cSld>
@@ -25017,7 +25086,7 @@
           <p:cNvPr id="5" name="text">
             <a:extLst xmlns:a="http://schemas.openxmlformats.org/drawingml/2006/main">
               <a:ext uri="{FF2B5EF4-FFF2-40B4-BE49-F238E27FC236}">
-                <a16:creationId xmlns:a16="http://schemas.microsoft.com/office/drawing/2014/main" id="{9DEC9606-EA06-4D75-A032-653D9787F145}"/>
+                <a16:creationId xmlns:a16="http://schemas.microsoft.com/office/drawing/2014/main" id="{CDB1BBBD-B435-4CC1-A36E-28711CA3912B}"/>
               </a:ext>
             </a:extLst>
           </p:cNvPr>
@@ -25074,7 +25143,7 @@
           <p:cNvPr id="2" name="text">
             <a:extLst xmlns:a="http://schemas.openxmlformats.org/drawingml/2006/main">
               <a:ext uri="{FF2B5EF4-FFF2-40B4-BE49-F238E27FC236}">
-                <a16:creationId xmlns:a16="http://schemas.microsoft.com/office/drawing/2014/main" id="{D0D8D304-25E1-4F76-86BA-D4AE1193431E}"/>
+                <a16:creationId xmlns:a16="http://schemas.microsoft.com/office/drawing/2014/main" id="{8A3D3D36-14C6-4EE4-89BE-2C6081B35A15}"/>
               </a:ext>
             </a:extLst>
           </p:cNvPr>
@@ -25131,7 +25200,7 @@
           <p:cNvPr id="3" name="text">
             <a:extLst xmlns:a="http://schemas.openxmlformats.org/drawingml/2006/main">
               <a:ext uri="{FF2B5EF4-FFF2-40B4-BE49-F238E27FC236}">
-                <a16:creationId xmlns:a16="http://schemas.microsoft.com/office/drawing/2014/main" id="{1FD4A029-42BB-4BB8-94F0-7B39255E1C53}"/>
+                <a16:creationId xmlns:a16="http://schemas.microsoft.com/office/drawing/2014/main" id="{CBDB515D-CC1E-455C-B392-6DEFE78A6114}"/>
               </a:ext>
             </a:extLst>
           </p:cNvPr>
@@ -25188,7 +25257,7 @@
           <p:cNvPr id="4" name="text">
             <a:extLst xmlns:a="http://schemas.openxmlformats.org/drawingml/2006/main">
               <a:ext uri="{FF2B5EF4-FFF2-40B4-BE49-F238E27FC236}">
-                <a16:creationId xmlns:a16="http://schemas.microsoft.com/office/drawing/2014/main" id="{8B3E8403-26F6-437C-BA88-60BBDBC2BE31}"/>
+                <a16:creationId xmlns:a16="http://schemas.microsoft.com/office/drawing/2014/main" id="{9588E7B3-980E-4C28-A033-DCB224704923}"/>
               </a:ext>
             </a:extLst>
           </p:cNvPr>
@@ -25243,7 +25312,7 @@
     </p:spTree>
     <p:extLst>
       <p:ext uri="{BB962C8B-B14F-4D97-AF65-F5344CB8AC3E}">
-        <p14:creationId xmlns:p14="http://schemas.microsoft.com/office/powerpoint/2010/main" val="78696874"/>
+        <p14:creationId xmlns:p14="http://schemas.microsoft.com/office/powerpoint/2010/main" val="19750200"/>
       </p:ext>
     </p:extLst>
   </p:cSld>
@@ -25285,7 +25354,7 @@
           <p:cNvPr id="6" name="text">
             <a:extLst xmlns:a="http://schemas.openxmlformats.org/drawingml/2006/main">
               <a:ext uri="{FF2B5EF4-FFF2-40B4-BE49-F238E27FC236}">
-                <a16:creationId xmlns:a16="http://schemas.microsoft.com/office/drawing/2014/main" id="{B1671B8E-C1BF-4DEF-8673-9392E6FB2070}"/>
+                <a16:creationId xmlns:a16="http://schemas.microsoft.com/office/drawing/2014/main" id="{EBEE8B91-4C78-4B01-9531-D4F36CFC57B9}"/>
               </a:ext>
             </a:extLst>
           </p:cNvPr>
@@ -25342,7 +25411,7 @@
           <p:cNvPr id="2" name="text">
             <a:extLst xmlns:a="http://schemas.openxmlformats.org/drawingml/2006/main">
               <a:ext uri="{FF2B5EF4-FFF2-40B4-BE49-F238E27FC236}">
-                <a16:creationId xmlns:a16="http://schemas.microsoft.com/office/drawing/2014/main" id="{F1CCAFA7-01EA-4443-8F82-ED1D195D32C0}"/>
+                <a16:creationId xmlns:a16="http://schemas.microsoft.com/office/drawing/2014/main" id="{729D224B-B6FB-4678-B87F-0EEB46CDD2C0}"/>
               </a:ext>
             </a:extLst>
           </p:cNvPr>
@@ -25399,7 +25468,7 @@
           <p:cNvPr id="3" name="text">
             <a:extLst xmlns:a="http://schemas.openxmlformats.org/drawingml/2006/main">
               <a:ext uri="{FF2B5EF4-FFF2-40B4-BE49-F238E27FC236}">
-                <a16:creationId xmlns:a16="http://schemas.microsoft.com/office/drawing/2014/main" id="{92A9841C-A78F-45DF-9446-0270B9031F94}"/>
+                <a16:creationId xmlns:a16="http://schemas.microsoft.com/office/drawing/2014/main" id="{8C831CA1-FC53-40A1-9758-7E8058D9CE59}"/>
               </a:ext>
             </a:extLst>
           </p:cNvPr>
@@ -25456,7 +25525,7 @@
           <p:cNvPr id="4" name="text">
             <a:extLst xmlns:a="http://schemas.openxmlformats.org/drawingml/2006/main">
               <a:ext uri="{FF2B5EF4-FFF2-40B4-BE49-F238E27FC236}">
-                <a16:creationId xmlns:a16="http://schemas.microsoft.com/office/drawing/2014/main" id="{CA46F8C2-8039-4E2D-928E-E4B5EC5151D5}"/>
+                <a16:creationId xmlns:a16="http://schemas.microsoft.com/office/drawing/2014/main" id="{F3EFC003-B65C-469E-AADB-345DDD13C3CE}"/>
               </a:ext>
             </a:extLst>
           </p:cNvPr>
@@ -25513,7 +25582,7 @@
           <p:cNvPr id="5" name="text">
             <a:extLst xmlns:a="http://schemas.openxmlformats.org/drawingml/2006/main">
               <a:ext uri="{FF2B5EF4-FFF2-40B4-BE49-F238E27FC236}">
-                <a16:creationId xmlns:a16="http://schemas.microsoft.com/office/drawing/2014/main" id="{3BED695F-AF77-45C8-AF8A-1F05B21B5C1B}"/>
+                <a16:creationId xmlns:a16="http://schemas.microsoft.com/office/drawing/2014/main" id="{F8DA06C9-59D8-4C0D-BB92-8C90876275F4}"/>
               </a:ext>
             </a:extLst>
           </p:cNvPr>
@@ -25568,7 +25637,7 @@
     </p:spTree>
     <p:extLst>
       <p:ext uri="{BB962C8B-B14F-4D97-AF65-F5344CB8AC3E}">
-        <p14:creationId xmlns:p14="http://schemas.microsoft.com/office/powerpoint/2010/main" val="1994835349"/>
+        <p14:creationId xmlns:p14="http://schemas.microsoft.com/office/powerpoint/2010/main" val="69426638"/>
       </p:ext>
     </p:extLst>
   </p:cSld>
@@ -25610,7 +25679,7 @@
           <p:cNvPr id="5" name="text">
             <a:extLst xmlns:a="http://schemas.openxmlformats.org/drawingml/2006/main">
               <a:ext uri="{FF2B5EF4-FFF2-40B4-BE49-F238E27FC236}">
-                <a16:creationId xmlns:a16="http://schemas.microsoft.com/office/drawing/2014/main" id="{E8296AAD-714C-43D4-8577-3DA226A5E14E}"/>
+                <a16:creationId xmlns:a16="http://schemas.microsoft.com/office/drawing/2014/main" id="{61391A9E-55FE-4BA1-888A-189CA189ED00}"/>
               </a:ext>
             </a:extLst>
           </p:cNvPr>
@@ -25667,7 +25736,7 @@
           <p:cNvPr id="2" name="text">
             <a:extLst xmlns:a="http://schemas.openxmlformats.org/drawingml/2006/main">
               <a:ext uri="{FF2B5EF4-FFF2-40B4-BE49-F238E27FC236}">
-                <a16:creationId xmlns:a16="http://schemas.microsoft.com/office/drawing/2014/main" id="{0A5077E3-710E-4ACD-B3FF-982F84E6360F}"/>
+                <a16:creationId xmlns:a16="http://schemas.microsoft.com/office/drawing/2014/main" id="{A3277D05-B9E7-4C89-9516-A6549AD3F6E6}"/>
               </a:ext>
             </a:extLst>
           </p:cNvPr>
@@ -25724,7 +25793,7 @@
           <p:cNvPr id="3" name="text">
             <a:extLst xmlns:a="http://schemas.openxmlformats.org/drawingml/2006/main">
               <a:ext uri="{FF2B5EF4-FFF2-40B4-BE49-F238E27FC236}">
-                <a16:creationId xmlns:a16="http://schemas.microsoft.com/office/drawing/2014/main" id="{E79AD800-4C58-48E9-8C34-D696904613D6}"/>
+                <a16:creationId xmlns:a16="http://schemas.microsoft.com/office/drawing/2014/main" id="{74A87F93-DB7E-4B0A-9D6C-7E3DB3C28C13}"/>
               </a:ext>
             </a:extLst>
           </p:cNvPr>
@@ -25781,7 +25850,7 @@
           <p:cNvPr id="4" name="text">
             <a:extLst xmlns:a="http://schemas.openxmlformats.org/drawingml/2006/main">
               <a:ext uri="{FF2B5EF4-FFF2-40B4-BE49-F238E27FC236}">
-                <a16:creationId xmlns:a16="http://schemas.microsoft.com/office/drawing/2014/main" id="{58AD727C-4DDB-405E-BBF1-F484A81F6CB9}"/>
+                <a16:creationId xmlns:a16="http://schemas.microsoft.com/office/drawing/2014/main" id="{0E41FA53-A785-4699-93AF-07BD9B8BB7FF}"/>
               </a:ext>
             </a:extLst>
           </p:cNvPr>
@@ -25836,7 +25905,7 @@
     </p:spTree>
     <p:extLst>
       <p:ext uri="{BB962C8B-B14F-4D97-AF65-F5344CB8AC3E}">
-        <p14:creationId xmlns:p14="http://schemas.microsoft.com/office/powerpoint/2010/main" val="1898206214"/>
+        <p14:creationId xmlns:p14="http://schemas.microsoft.com/office/powerpoint/2010/main" val="447906367"/>
       </p:ext>
     </p:extLst>
   </p:cSld>
@@ -25878,7 +25947,7 @@
           <p:cNvPr id="6" name="text">
             <a:extLst xmlns:a="http://schemas.openxmlformats.org/drawingml/2006/main">
               <a:ext uri="{FF2B5EF4-FFF2-40B4-BE49-F238E27FC236}">
-                <a16:creationId xmlns:a16="http://schemas.microsoft.com/office/drawing/2014/main" id="{622E00D4-7AF0-4994-9318-30D3147568E2}"/>
+                <a16:creationId xmlns:a16="http://schemas.microsoft.com/office/drawing/2014/main" id="{3B4617F7-84BC-4CF7-A7E0-DDE5DB9F8685}"/>
               </a:ext>
             </a:extLst>
           </p:cNvPr>
@@ -25935,7 +26004,7 @@
           <p:cNvPr id="2" name="text">
             <a:extLst xmlns:a="http://schemas.openxmlformats.org/drawingml/2006/main">
               <a:ext uri="{FF2B5EF4-FFF2-40B4-BE49-F238E27FC236}">
-                <a16:creationId xmlns:a16="http://schemas.microsoft.com/office/drawing/2014/main" id="{BE445023-6508-4AF9-AF6F-999B4D714F24}"/>
+                <a16:creationId xmlns:a16="http://schemas.microsoft.com/office/drawing/2014/main" id="{7F7F2392-A0C2-449F-9675-A8AF72CD7894}"/>
               </a:ext>
             </a:extLst>
           </p:cNvPr>
@@ -25992,7 +26061,7 @@
           <p:cNvPr id="3" name="text">
             <a:extLst xmlns:a="http://schemas.openxmlformats.org/drawingml/2006/main">
               <a:ext uri="{FF2B5EF4-FFF2-40B4-BE49-F238E27FC236}">
-                <a16:creationId xmlns:a16="http://schemas.microsoft.com/office/drawing/2014/main" id="{FF93D50B-F162-4145-A582-DB192740EE33}"/>
+                <a16:creationId xmlns:a16="http://schemas.microsoft.com/office/drawing/2014/main" id="{A03A4F9E-7199-4F61-B4B2-75EEC312129F}"/>
               </a:ext>
             </a:extLst>
           </p:cNvPr>
@@ -26049,7 +26118,7 @@
           <p:cNvPr id="4" name="text">
             <a:extLst xmlns:a="http://schemas.openxmlformats.org/drawingml/2006/main">
               <a:ext uri="{FF2B5EF4-FFF2-40B4-BE49-F238E27FC236}">
-                <a16:creationId xmlns:a16="http://schemas.microsoft.com/office/drawing/2014/main" id="{F62C5F8F-C54E-48DF-839A-CE2285D1FD56}"/>
+                <a16:creationId xmlns:a16="http://schemas.microsoft.com/office/drawing/2014/main" id="{2DE53701-A2DB-44A0-89B5-156479C158D1}"/>
               </a:ext>
             </a:extLst>
           </p:cNvPr>
@@ -26106,7 +26175,7 @@
           <p:cNvPr id="5" name="text">
             <a:extLst xmlns:a="http://schemas.openxmlformats.org/drawingml/2006/main">
               <a:ext uri="{FF2B5EF4-FFF2-40B4-BE49-F238E27FC236}">
-                <a16:creationId xmlns:a16="http://schemas.microsoft.com/office/drawing/2014/main" id="{CDD490A3-799E-4941-AFEF-D282529FC22A}"/>
+                <a16:creationId xmlns:a16="http://schemas.microsoft.com/office/drawing/2014/main" id="{6C7838E5-24EA-4A22-8C5C-E25140DC006E}"/>
               </a:ext>
             </a:extLst>
           </p:cNvPr>
@@ -26161,7 +26230,7 @@
     </p:spTree>
     <p:extLst>
       <p:ext uri="{BB962C8B-B14F-4D97-AF65-F5344CB8AC3E}">
-        <p14:creationId xmlns:p14="http://schemas.microsoft.com/office/powerpoint/2010/main" val="775084883"/>
+        <p14:creationId xmlns:p14="http://schemas.microsoft.com/office/powerpoint/2010/main" val="1774158829"/>
       </p:ext>
     </p:extLst>
   </p:cSld>
@@ -26203,7 +26272,7 @@
           <p:cNvPr id="5" name="text">
             <a:extLst xmlns:a="http://schemas.openxmlformats.org/drawingml/2006/main">
               <a:ext uri="{FF2B5EF4-FFF2-40B4-BE49-F238E27FC236}">
-                <a16:creationId xmlns:a16="http://schemas.microsoft.com/office/drawing/2014/main" id="{BE25859D-8A37-4E8E-8CAA-28417A380DEA}"/>
+                <a16:creationId xmlns:a16="http://schemas.microsoft.com/office/drawing/2014/main" id="{6C7B6068-4A67-4DF4-BF23-3D7A01DE1CA8}"/>
               </a:ext>
             </a:extLst>
           </p:cNvPr>
@@ -26260,7 +26329,7 @@
           <p:cNvPr id="2" name="text">
             <a:extLst xmlns:a="http://schemas.openxmlformats.org/drawingml/2006/main">
               <a:ext uri="{FF2B5EF4-FFF2-40B4-BE49-F238E27FC236}">
-                <a16:creationId xmlns:a16="http://schemas.microsoft.com/office/drawing/2014/main" id="{FC406055-1804-41C9-BC6A-85703FFD63F9}"/>
+                <a16:creationId xmlns:a16="http://schemas.microsoft.com/office/drawing/2014/main" id="{5B894769-346A-40B7-8140-850FEC5BFF57}"/>
               </a:ext>
             </a:extLst>
           </p:cNvPr>
@@ -26317,7 +26386,7 @@
           <p:cNvPr id="3" name="text">
             <a:extLst xmlns:a="http://schemas.openxmlformats.org/drawingml/2006/main">
               <a:ext uri="{FF2B5EF4-FFF2-40B4-BE49-F238E27FC236}">
-                <a16:creationId xmlns:a16="http://schemas.microsoft.com/office/drawing/2014/main" id="{B915AF62-DF1B-4093-99DD-A307A6DF3706}"/>
+                <a16:creationId xmlns:a16="http://schemas.microsoft.com/office/drawing/2014/main" id="{AACDFBAA-7257-47FB-A2F2-F661D37C9142}"/>
               </a:ext>
             </a:extLst>
           </p:cNvPr>
@@ -26374,7 +26443,7 @@
           <p:cNvPr id="4" name="text">
             <a:extLst xmlns:a="http://schemas.openxmlformats.org/drawingml/2006/main">
               <a:ext uri="{FF2B5EF4-FFF2-40B4-BE49-F238E27FC236}">
-                <a16:creationId xmlns:a16="http://schemas.microsoft.com/office/drawing/2014/main" id="{7A9EE05C-1106-4E3A-B314-A7610038CB0A}"/>
+                <a16:creationId xmlns:a16="http://schemas.microsoft.com/office/drawing/2014/main" id="{5F93106B-04B1-4FB3-8C3D-8FE69E7E28CD}"/>
               </a:ext>
             </a:extLst>
           </p:cNvPr>
@@ -26429,7 +26498,7 @@
     </p:spTree>
     <p:extLst>
       <p:ext uri="{BB962C8B-B14F-4D97-AF65-F5344CB8AC3E}">
-        <p14:creationId xmlns:p14="http://schemas.microsoft.com/office/powerpoint/2010/main" val="582885115"/>
+        <p14:creationId xmlns:p14="http://schemas.microsoft.com/office/powerpoint/2010/main" val="1588217946"/>
       </p:ext>
     </p:extLst>
   </p:cSld>
@@ -26471,7 +26540,7 @@
           <p:cNvPr id="6" name="text">
             <a:extLst xmlns:a="http://schemas.openxmlformats.org/drawingml/2006/main">
               <a:ext uri="{FF2B5EF4-FFF2-40B4-BE49-F238E27FC236}">
-                <a16:creationId xmlns:a16="http://schemas.microsoft.com/office/drawing/2014/main" id="{7D41ACF6-EDAB-4CFE-8DCF-135D45CDA0B4}"/>
+                <a16:creationId xmlns:a16="http://schemas.microsoft.com/office/drawing/2014/main" id="{24067F7B-0236-4D88-B6F5-D4E3E587B3C7}"/>
               </a:ext>
             </a:extLst>
           </p:cNvPr>
@@ -26528,7 +26597,7 @@
           <p:cNvPr id="2" name="text">
             <a:extLst xmlns:a="http://schemas.openxmlformats.org/drawingml/2006/main">
               <a:ext uri="{FF2B5EF4-FFF2-40B4-BE49-F238E27FC236}">
-                <a16:creationId xmlns:a16="http://schemas.microsoft.com/office/drawing/2014/main" id="{FE4DF668-38B9-4B8C-B20E-1EF38FC87D52}"/>
+                <a16:creationId xmlns:a16="http://schemas.microsoft.com/office/drawing/2014/main" id="{3B1D8155-246B-412B-9927-5A9B2F16D6F8}"/>
               </a:ext>
             </a:extLst>
           </p:cNvPr>
@@ -26585,7 +26654,7 @@
           <p:cNvPr id="3" name="text">
             <a:extLst xmlns:a="http://schemas.openxmlformats.org/drawingml/2006/main">
               <a:ext uri="{FF2B5EF4-FFF2-40B4-BE49-F238E27FC236}">
-                <a16:creationId xmlns:a16="http://schemas.microsoft.com/office/drawing/2014/main" id="{79C5F459-FA3B-4918-8BF3-244B695091B9}"/>
+                <a16:creationId xmlns:a16="http://schemas.microsoft.com/office/drawing/2014/main" id="{25E50530-F802-43BB-9377-FE95415165C9}"/>
               </a:ext>
             </a:extLst>
           </p:cNvPr>
@@ -26642,7 +26711,7 @@
           <p:cNvPr id="4" name="text">
             <a:extLst xmlns:a="http://schemas.openxmlformats.org/drawingml/2006/main">
               <a:ext uri="{FF2B5EF4-FFF2-40B4-BE49-F238E27FC236}">
-                <a16:creationId xmlns:a16="http://schemas.microsoft.com/office/drawing/2014/main" id="{3E5E11F9-49AE-47CA-BE46-848E39E73019}"/>
+                <a16:creationId xmlns:a16="http://schemas.microsoft.com/office/drawing/2014/main" id="{A229753D-424C-40FE-8CCA-21279FF13A91}"/>
               </a:ext>
             </a:extLst>
           </p:cNvPr>
@@ -26699,7 +26768,7 @@
           <p:cNvPr id="5" name="text">
             <a:extLst xmlns:a="http://schemas.openxmlformats.org/drawingml/2006/main">
               <a:ext uri="{FF2B5EF4-FFF2-40B4-BE49-F238E27FC236}">
-                <a16:creationId xmlns:a16="http://schemas.microsoft.com/office/drawing/2014/main" id="{54318B8C-E8BF-47F8-967F-23D6FF24E32D}"/>
+                <a16:creationId xmlns:a16="http://schemas.microsoft.com/office/drawing/2014/main" id="{84B5417C-3988-43BE-9994-27E0D8207A92}"/>
               </a:ext>
             </a:extLst>
           </p:cNvPr>
@@ -26754,7 +26823,7 @@
     </p:spTree>
     <p:extLst>
       <p:ext uri="{BB962C8B-B14F-4D97-AF65-F5344CB8AC3E}">
-        <p14:creationId xmlns:p14="http://schemas.microsoft.com/office/powerpoint/2010/main" val="1468804789"/>
+        <p14:creationId xmlns:p14="http://schemas.microsoft.com/office/powerpoint/2010/main" val="257175664"/>
       </p:ext>
     </p:extLst>
   </p:cSld>
@@ -26796,7 +26865,7 @@
           <p:cNvPr id="9" name="text">
             <a:extLst xmlns:a="http://schemas.openxmlformats.org/drawingml/2006/main">
               <a:ext uri="{FF2B5EF4-FFF2-40B4-BE49-F238E27FC236}">
-                <a16:creationId xmlns:a16="http://schemas.microsoft.com/office/drawing/2014/main" id="{6C6F2407-5CFA-4CE1-AFA0-5B439A2645A9}"/>
+                <a16:creationId xmlns:a16="http://schemas.microsoft.com/office/drawing/2014/main" id="{8BC3BDE9-A053-4F3F-BDD4-C3BAD8EC6FB8}"/>
               </a:ext>
             </a:extLst>
           </p:cNvPr>
@@ -26853,7 +26922,7 @@
           <p:cNvPr id="2" name="text">
             <a:extLst xmlns:a="http://schemas.openxmlformats.org/drawingml/2006/main">
               <a:ext uri="{FF2B5EF4-FFF2-40B4-BE49-F238E27FC236}">
-                <a16:creationId xmlns:a16="http://schemas.microsoft.com/office/drawing/2014/main" id="{2F71C165-B261-4B68-A927-37DA530D624A}"/>
+                <a16:creationId xmlns:a16="http://schemas.microsoft.com/office/drawing/2014/main" id="{3873D929-3E70-4188-AA2B-E4E2B9E87FAE}"/>
               </a:ext>
             </a:extLst>
           </p:cNvPr>
@@ -26910,7 +26979,7 @@
           <p:cNvPr id="3" name="text">
             <a:extLst xmlns:a="http://schemas.openxmlformats.org/drawingml/2006/main">
               <a:ext uri="{FF2B5EF4-FFF2-40B4-BE49-F238E27FC236}">
-                <a16:creationId xmlns:a16="http://schemas.microsoft.com/office/drawing/2014/main" id="{0DB8B8B7-F4A2-4FFB-BF6D-28413F0DEAA4}"/>
+                <a16:creationId xmlns:a16="http://schemas.microsoft.com/office/drawing/2014/main" id="{AA03B5E4-C914-4052-86F6-A0D07A4CE6D8}"/>
               </a:ext>
             </a:extLst>
           </p:cNvPr>
@@ -26967,7 +27036,7 @@
           <p:cNvPr id="4" name="text">
             <a:extLst xmlns:a="http://schemas.openxmlformats.org/drawingml/2006/main">
               <a:ext uri="{FF2B5EF4-FFF2-40B4-BE49-F238E27FC236}">
-                <a16:creationId xmlns:a16="http://schemas.microsoft.com/office/drawing/2014/main" id="{8C8C6508-0E42-457F-9F22-416692E0FB4F}"/>
+                <a16:creationId xmlns:a16="http://schemas.microsoft.com/office/drawing/2014/main" id="{595934FE-DF6F-41D9-A8F5-47B62997F442}"/>
               </a:ext>
             </a:extLst>
           </p:cNvPr>
@@ -27024,7 +27093,7 @@
           <p:cNvPr id="5" name="text">
             <a:extLst xmlns:a="http://schemas.openxmlformats.org/drawingml/2006/main">
               <a:ext uri="{FF2B5EF4-FFF2-40B4-BE49-F238E27FC236}">
-                <a16:creationId xmlns:a16="http://schemas.microsoft.com/office/drawing/2014/main" id="{3214D70B-9B3D-4142-AA13-DA2C40FB0C4D}"/>
+                <a16:creationId xmlns:a16="http://schemas.microsoft.com/office/drawing/2014/main" id="{DC863DBE-A8D5-48BE-AE84-5F7D528762E8}"/>
               </a:ext>
             </a:extLst>
           </p:cNvPr>
@@ -27081,7 +27150,7 @@
           <p:cNvPr id="6" name="text">
             <a:extLst xmlns:a="http://schemas.openxmlformats.org/drawingml/2006/main">
               <a:ext uri="{FF2B5EF4-FFF2-40B4-BE49-F238E27FC236}">
-                <a16:creationId xmlns:a16="http://schemas.microsoft.com/office/drawing/2014/main" id="{C76AB122-E67F-40C9-B99E-549BE832DF22}"/>
+                <a16:creationId xmlns:a16="http://schemas.microsoft.com/office/drawing/2014/main" id="{5D6BFB1C-1918-49B4-A60B-40FD91E99C1F}"/>
               </a:ext>
             </a:extLst>
           </p:cNvPr>
@@ -27138,7 +27207,7 @@
           <p:cNvPr id="7" name="text">
             <a:extLst xmlns:a="http://schemas.openxmlformats.org/drawingml/2006/main">
               <a:ext uri="{FF2B5EF4-FFF2-40B4-BE49-F238E27FC236}">
-                <a16:creationId xmlns:a16="http://schemas.microsoft.com/office/drawing/2014/main" id="{AABE7F57-60E8-4E2E-B3C6-40D9135F8974}"/>
+                <a16:creationId xmlns:a16="http://schemas.microsoft.com/office/drawing/2014/main" id="{F1664D3B-1DCB-4ED5-B9FB-38A5029B1A8C}"/>
               </a:ext>
             </a:extLst>
           </p:cNvPr>
@@ -27184,7 +27253,7 @@
                 <a:latin typeface="Heebo"/>
                 <a:ea typeface="Heebo"/>
                 <a:cs typeface="Heebo"/>
-                <a:hlinkClick xmlns:r="http://schemas.openxmlformats.org/officeDocument/2006/relationships" r:id="Rdca69573265444c8"/>
+                <a:hlinkClick xmlns:r="http://schemas.openxmlformats.org/officeDocument/2006/relationships" r:id="R1db6068425214873"/>
               </a:rPr>
               <a:t>תרגול קבוצה 01</a:t>
             </a:r>
@@ -27196,7 +27265,7 @@
           <p:cNvPr id="8" name="text">
             <a:extLst xmlns:a="http://schemas.openxmlformats.org/drawingml/2006/main">
               <a:ext uri="{FF2B5EF4-FFF2-40B4-BE49-F238E27FC236}">
-                <a16:creationId xmlns:a16="http://schemas.microsoft.com/office/drawing/2014/main" id="{582FBC6D-37C3-4194-88C6-8783E4B5AF8E}"/>
+                <a16:creationId xmlns:a16="http://schemas.microsoft.com/office/drawing/2014/main" id="{1D6A32C8-7848-4D3B-80F9-F19D62E417A9}"/>
               </a:ext>
             </a:extLst>
           </p:cNvPr>
@@ -27251,7 +27320,7 @@
     </p:spTree>
     <p:extLst>
       <p:ext uri="{BB962C8B-B14F-4D97-AF65-F5344CB8AC3E}">
-        <p14:creationId xmlns:p14="http://schemas.microsoft.com/office/powerpoint/2010/main" val="1999309827"/>
+        <p14:creationId xmlns:p14="http://schemas.microsoft.com/office/powerpoint/2010/main" val="2084795226"/>
       </p:ext>
     </p:extLst>
   </p:cSld>
@@ -27297,7 +27366,7 @@
           <p:nvPr/>
         </p:nvPicPr>
         <p:blipFill>
-          <a:blip xmlns:r="http://schemas.openxmlformats.org/officeDocument/2006/relationships" xmlns:a="http://schemas.openxmlformats.org/drawingml/2006/main" r:embed="Ra5a58011bdd44828"/>
+          <a:blip xmlns:r="http://schemas.openxmlformats.org/officeDocument/2006/relationships" xmlns:a="http://schemas.openxmlformats.org/drawingml/2006/main" r:embed="R906d9a1dee0f41d5"/>
           <a:stretch xmlns:a="http://schemas.openxmlformats.org/drawingml/2006/main"/>
         </p:blipFill>
         <p:spPr>
@@ -27313,7 +27382,7 @@
     </p:spTree>
     <p:extLst>
       <p:ext uri="{BB962C8B-B14F-4D97-AF65-F5344CB8AC3E}">
-        <p14:creationId xmlns:p14="http://schemas.microsoft.com/office/powerpoint/2010/main" val="1321083947"/>
+        <p14:creationId xmlns:p14="http://schemas.microsoft.com/office/powerpoint/2010/main" val="1057082245"/>
       </p:ext>
     </p:extLst>
   </p:cSld>
@@ -27355,7 +27424,7 @@
           <p:cNvPr id="6" name="text">
             <a:extLst xmlns:a="http://schemas.openxmlformats.org/drawingml/2006/main">
               <a:ext uri="{FF2B5EF4-FFF2-40B4-BE49-F238E27FC236}">
-                <a16:creationId xmlns:a16="http://schemas.microsoft.com/office/drawing/2014/main" id="{C44A2466-4FAA-4806-A914-44ADEFE1A3C9}"/>
+                <a16:creationId xmlns:a16="http://schemas.microsoft.com/office/drawing/2014/main" id="{9D882B17-4A8A-4820-9627-A79A6ADE9982}"/>
               </a:ext>
             </a:extLst>
           </p:cNvPr>
@@ -27412,7 +27481,7 @@
           <p:cNvPr id="2" name="text">
             <a:extLst xmlns:a="http://schemas.openxmlformats.org/drawingml/2006/main">
               <a:ext uri="{FF2B5EF4-FFF2-40B4-BE49-F238E27FC236}">
-                <a16:creationId xmlns:a16="http://schemas.microsoft.com/office/drawing/2014/main" id="{5CECD58B-9700-464D-B0D6-ACB285104603}"/>
+                <a16:creationId xmlns:a16="http://schemas.microsoft.com/office/drawing/2014/main" id="{512B7EE1-0B52-4721-B1C1-0CAE66CC80F6}"/>
               </a:ext>
             </a:extLst>
           </p:cNvPr>
@@ -27469,7 +27538,7 @@
           <p:cNvPr id="3" name="text">
             <a:extLst xmlns:a="http://schemas.openxmlformats.org/drawingml/2006/main">
               <a:ext uri="{FF2B5EF4-FFF2-40B4-BE49-F238E27FC236}">
-                <a16:creationId xmlns:a16="http://schemas.microsoft.com/office/drawing/2014/main" id="{3498012B-D08A-42E1-9E4D-E0016F1D4A39}"/>
+                <a16:creationId xmlns:a16="http://schemas.microsoft.com/office/drawing/2014/main" id="{A89B918D-528C-4740-ADE2-DBCC7D8BE6E3}"/>
               </a:ext>
             </a:extLst>
           </p:cNvPr>
@@ -27526,7 +27595,7 @@
           <p:cNvPr id="4" name="text">
             <a:extLst xmlns:a="http://schemas.openxmlformats.org/drawingml/2006/main">
               <a:ext uri="{FF2B5EF4-FFF2-40B4-BE49-F238E27FC236}">
-                <a16:creationId xmlns:a16="http://schemas.microsoft.com/office/drawing/2014/main" id="{CCF5A81F-DE67-43E1-8C7C-EA4175565400}"/>
+                <a16:creationId xmlns:a16="http://schemas.microsoft.com/office/drawing/2014/main" id="{0BD1730C-2779-43FC-B32F-DD010BB75EE6}"/>
               </a:ext>
             </a:extLst>
           </p:cNvPr>
@@ -27583,7 +27652,7 @@
           <p:cNvPr id="5" name="text">
             <a:extLst xmlns:a="http://schemas.openxmlformats.org/drawingml/2006/main">
               <a:ext uri="{FF2B5EF4-FFF2-40B4-BE49-F238E27FC236}">
-                <a16:creationId xmlns:a16="http://schemas.microsoft.com/office/drawing/2014/main" id="{A0557AB1-8D2A-432A-A18E-56227BCB86E4}"/>
+                <a16:creationId xmlns:a16="http://schemas.microsoft.com/office/drawing/2014/main" id="{3518FF5C-FE9D-4736-8972-1824303BBD08}"/>
               </a:ext>
             </a:extLst>
           </p:cNvPr>
@@ -27638,7 +27707,7 @@
     </p:spTree>
     <p:extLst>
       <p:ext uri="{BB962C8B-B14F-4D97-AF65-F5344CB8AC3E}">
-        <p14:creationId xmlns:p14="http://schemas.microsoft.com/office/powerpoint/2010/main" val="1478764528"/>
+        <p14:creationId xmlns:p14="http://schemas.microsoft.com/office/powerpoint/2010/main" val="432462037"/>
       </p:ext>
     </p:extLst>
   </p:cSld>
@@ -27680,7 +27749,7 @@
           <p:cNvPr id="6" name="text">
             <a:extLst xmlns:a="http://schemas.openxmlformats.org/drawingml/2006/main">
               <a:ext uri="{FF2B5EF4-FFF2-40B4-BE49-F238E27FC236}">
-                <a16:creationId xmlns:a16="http://schemas.microsoft.com/office/drawing/2014/main" id="{71ECAF4B-EC68-45E3-BE36-EC7BA07E93CD}"/>
+                <a16:creationId xmlns:a16="http://schemas.microsoft.com/office/drawing/2014/main" id="{6DBD0932-EC5D-4898-8EBB-A8D0F0888E5E}"/>
               </a:ext>
             </a:extLst>
           </p:cNvPr>
@@ -27737,7 +27806,7 @@
           <p:cNvPr id="2" name="text">
             <a:extLst xmlns:a="http://schemas.openxmlformats.org/drawingml/2006/main">
               <a:ext uri="{FF2B5EF4-FFF2-40B4-BE49-F238E27FC236}">
-                <a16:creationId xmlns:a16="http://schemas.microsoft.com/office/drawing/2014/main" id="{97FDBAA8-A69F-43D6-8679-A3543C88E27B}"/>
+                <a16:creationId xmlns:a16="http://schemas.microsoft.com/office/drawing/2014/main" id="{BA32C489-42D9-4A24-BE8B-4CF35370B6B5}"/>
               </a:ext>
             </a:extLst>
           </p:cNvPr>
@@ -27794,7 +27863,7 @@
           <p:cNvPr id="3" name="text">
             <a:extLst xmlns:a="http://schemas.openxmlformats.org/drawingml/2006/main">
               <a:ext uri="{FF2B5EF4-FFF2-40B4-BE49-F238E27FC236}">
-                <a16:creationId xmlns:a16="http://schemas.microsoft.com/office/drawing/2014/main" id="{265EDC2E-828E-46DA-8465-5DCD721F3AE4}"/>
+                <a16:creationId xmlns:a16="http://schemas.microsoft.com/office/drawing/2014/main" id="{8B70E131-97E1-493D-BD7A-465E9250EA3C}"/>
               </a:ext>
             </a:extLst>
           </p:cNvPr>
@@ -27851,7 +27920,7 @@
           <p:cNvPr id="4" name="text">
             <a:extLst xmlns:a="http://schemas.openxmlformats.org/drawingml/2006/main">
               <a:ext uri="{FF2B5EF4-FFF2-40B4-BE49-F238E27FC236}">
-                <a16:creationId xmlns:a16="http://schemas.microsoft.com/office/drawing/2014/main" id="{F556ED46-1F23-4CE5-8072-C4D3CA73AFD4}"/>
+                <a16:creationId xmlns:a16="http://schemas.microsoft.com/office/drawing/2014/main" id="{7773AB21-41D9-4BFB-BEEC-01ADA4D27DE1}"/>
               </a:ext>
             </a:extLst>
           </p:cNvPr>
@@ -27908,7 +27977,7 @@
           <p:cNvPr id="5" name="text">
             <a:extLst xmlns:a="http://schemas.openxmlformats.org/drawingml/2006/main">
               <a:ext uri="{FF2B5EF4-FFF2-40B4-BE49-F238E27FC236}">
-                <a16:creationId xmlns:a16="http://schemas.microsoft.com/office/drawing/2014/main" id="{1B922374-610A-4644-B1ED-12A0C3E92480}"/>
+                <a16:creationId xmlns:a16="http://schemas.microsoft.com/office/drawing/2014/main" id="{E83DF5A8-DDBB-47AA-9DC2-6E6D86389EAB}"/>
               </a:ext>
             </a:extLst>
           </p:cNvPr>
@@ -27963,7 +28032,7 @@
     </p:spTree>
     <p:extLst>
       <p:ext uri="{BB962C8B-B14F-4D97-AF65-F5344CB8AC3E}">
-        <p14:creationId xmlns:p14="http://schemas.microsoft.com/office/powerpoint/2010/main" val="1062305516"/>
+        <p14:creationId xmlns:p14="http://schemas.microsoft.com/office/powerpoint/2010/main" val="1316160991"/>
       </p:ext>
     </p:extLst>
   </p:cSld>
@@ -28005,7 +28074,7 @@
           <p:cNvPr id="8" name="text">
             <a:extLst xmlns:a="http://schemas.openxmlformats.org/drawingml/2006/main">
               <a:ext uri="{FF2B5EF4-FFF2-40B4-BE49-F238E27FC236}">
-                <a16:creationId xmlns:a16="http://schemas.microsoft.com/office/drawing/2014/main" id="{02013835-C63D-4DB0-82DE-7331A0A459A3}"/>
+                <a16:creationId xmlns:a16="http://schemas.microsoft.com/office/drawing/2014/main" id="{5A54D448-388F-496F-A3F1-CFF823D7A0D0}"/>
               </a:ext>
             </a:extLst>
           </p:cNvPr>
@@ -28062,7 +28131,7 @@
           <p:cNvPr id="2" name="text">
             <a:extLst xmlns:a="http://schemas.openxmlformats.org/drawingml/2006/main">
               <a:ext uri="{FF2B5EF4-FFF2-40B4-BE49-F238E27FC236}">
-                <a16:creationId xmlns:a16="http://schemas.microsoft.com/office/drawing/2014/main" id="{10714453-DF13-4684-A203-B821F408E457}"/>
+                <a16:creationId xmlns:a16="http://schemas.microsoft.com/office/drawing/2014/main" id="{CD1DC8F4-24FB-43B7-B557-CFBE5E8CE6F5}"/>
               </a:ext>
             </a:extLst>
           </p:cNvPr>
@@ -28119,7 +28188,7 @@
           <p:cNvPr id="3" name="text">
             <a:extLst xmlns:a="http://schemas.openxmlformats.org/drawingml/2006/main">
               <a:ext uri="{FF2B5EF4-FFF2-40B4-BE49-F238E27FC236}">
-                <a16:creationId xmlns:a16="http://schemas.microsoft.com/office/drawing/2014/main" id="{4F36CE50-E2C3-43AF-8EB1-F1ECCC3C47B8}"/>
+                <a16:creationId xmlns:a16="http://schemas.microsoft.com/office/drawing/2014/main" id="{FCF0D683-0AEB-4929-A976-5EA52610A2BF}"/>
               </a:ext>
             </a:extLst>
           </p:cNvPr>
@@ -28176,7 +28245,7 @@
           <p:cNvPr id="4" name="text">
             <a:extLst xmlns:a="http://schemas.openxmlformats.org/drawingml/2006/main">
               <a:ext uri="{FF2B5EF4-FFF2-40B4-BE49-F238E27FC236}">
-                <a16:creationId xmlns:a16="http://schemas.microsoft.com/office/drawing/2014/main" id="{BA8F513C-DC64-4FFB-AB79-76E90F90B900}"/>
+                <a16:creationId xmlns:a16="http://schemas.microsoft.com/office/drawing/2014/main" id="{1458E46D-D616-4280-BCCC-B308EF082D86}"/>
               </a:ext>
             </a:extLst>
           </p:cNvPr>
@@ -28233,7 +28302,7 @@
           <p:cNvPr id="5" name="text">
             <a:extLst xmlns:a="http://schemas.openxmlformats.org/drawingml/2006/main">
               <a:ext uri="{FF2B5EF4-FFF2-40B4-BE49-F238E27FC236}">
-                <a16:creationId xmlns:a16="http://schemas.microsoft.com/office/drawing/2014/main" id="{EC6ABDD5-9CC8-44BE-AA69-E5797970B398}"/>
+                <a16:creationId xmlns:a16="http://schemas.microsoft.com/office/drawing/2014/main" id="{A861D195-63F6-4C40-8A65-85291B63B8DC}"/>
               </a:ext>
             </a:extLst>
           </p:cNvPr>
@@ -28290,7 +28359,7 @@
           <p:cNvPr id="6" name="text">
             <a:extLst xmlns:a="http://schemas.openxmlformats.org/drawingml/2006/main">
               <a:ext uri="{FF2B5EF4-FFF2-40B4-BE49-F238E27FC236}">
-                <a16:creationId xmlns:a16="http://schemas.microsoft.com/office/drawing/2014/main" id="{305F8CF2-4355-42CC-9500-21E3406B5D1F}"/>
+                <a16:creationId xmlns:a16="http://schemas.microsoft.com/office/drawing/2014/main" id="{81F8A756-17B2-43EF-817D-8A23632E8248}"/>
               </a:ext>
             </a:extLst>
           </p:cNvPr>
@@ -28347,7 +28416,7 @@
           <p:cNvPr id="7" name="text">
             <a:extLst xmlns:a="http://schemas.openxmlformats.org/drawingml/2006/main">
               <a:ext uri="{FF2B5EF4-FFF2-40B4-BE49-F238E27FC236}">
-                <a16:creationId xmlns:a16="http://schemas.microsoft.com/office/drawing/2014/main" id="{249CBEE5-49F8-45FF-8F05-2957D7CB8EBC}"/>
+                <a16:creationId xmlns:a16="http://schemas.microsoft.com/office/drawing/2014/main" id="{02A6774B-929B-4B23-A66D-2C87D9E17A2B}"/>
               </a:ext>
             </a:extLst>
           </p:cNvPr>
@@ -28402,7 +28471,7 @@
     </p:spTree>
     <p:extLst>
       <p:ext uri="{BB962C8B-B14F-4D97-AF65-F5344CB8AC3E}">
-        <p14:creationId xmlns:p14="http://schemas.microsoft.com/office/powerpoint/2010/main" val="1941026819"/>
+        <p14:creationId xmlns:p14="http://schemas.microsoft.com/office/powerpoint/2010/main" val="360034247"/>
       </p:ext>
     </p:extLst>
   </p:cSld>

</xml_diff>